<commit_message>
Declutter README showcase teaser
</commit_message>
<xml_diff>
--- a/docs/assets/readme-slides/mdpr-showcase-teaser.pptx
+++ b/docs/assets/readme-slides/mdpr-showcase-teaser.pptx
@@ -129,7 +129,7 @@
           <p:cNvPr id="2" name="제목 1">
             <a:extLst>
               <a:ext uri="{FF2B5EF4-FFF2-40B4-BE49-F238E27FC236}">
-                <a16:creationId xmlns:a16="http://schemas.microsoft.com/office/drawing/2014/main" id="{6507773E-F009-ECA8-9C57-EE847D1BCA2D}"/>
+                <a16:creationId xmlns:a16="http://schemas.microsoft.com/office/drawing/2014/main" id="{84854C82-8393-0E74-7995-9C1BBFF4E62F}"/>
               </a:ext>
             </a:extLst>
           </p:cNvPr>
@@ -166,7 +166,7 @@
           <p:cNvPr id="3" name="부제목 2">
             <a:extLst>
               <a:ext uri="{FF2B5EF4-FFF2-40B4-BE49-F238E27FC236}">
-                <a16:creationId xmlns:a16="http://schemas.microsoft.com/office/drawing/2014/main" id="{A2BF1B6D-DEB6-B8D3-7F9C-B20CA58200CF}"/>
+                <a16:creationId xmlns:a16="http://schemas.microsoft.com/office/drawing/2014/main" id="{B330A05B-1042-012E-2682-FA6A4082C61C}"/>
               </a:ext>
             </a:extLst>
           </p:cNvPr>
@@ -236,7 +236,7 @@
           <p:cNvPr id="4" name="날짜 개체 틀 3">
             <a:extLst>
               <a:ext uri="{FF2B5EF4-FFF2-40B4-BE49-F238E27FC236}">
-                <a16:creationId xmlns:a16="http://schemas.microsoft.com/office/drawing/2014/main" id="{24B48EBF-217E-5E72-996D-55D42158BFDD}"/>
+                <a16:creationId xmlns:a16="http://schemas.microsoft.com/office/drawing/2014/main" id="{7CE3585B-5AC8-BA22-E0F8-6287F942AC85}"/>
               </a:ext>
             </a:extLst>
           </p:cNvPr>
@@ -252,7 +252,7 @@
           <a:bodyPr/>
           <a:lstStyle/>
           <a:p>
-            <a:fld id="{BBCE5FCE-C137-4A6E-A349-AF724E9D2612}" type="datetimeFigureOut">
+            <a:fld id="{C56CB09B-924A-4ABE-8F3B-7B27270F5C95}" type="datetimeFigureOut">
               <a:rPr lang="ko-KR" altLang="en-US" smtClean="0"/>
               <a:t>2026-06-21</a:t>
             </a:fld>
@@ -265,7 +265,7 @@
           <p:cNvPr id="5" name="바닥글 개체 틀 4">
             <a:extLst>
               <a:ext uri="{FF2B5EF4-FFF2-40B4-BE49-F238E27FC236}">
-                <a16:creationId xmlns:a16="http://schemas.microsoft.com/office/drawing/2014/main" id="{AC7EB0AF-FC0B-4045-8FBD-D66D980851E2}"/>
+                <a16:creationId xmlns:a16="http://schemas.microsoft.com/office/drawing/2014/main" id="{95C52B05-99A8-F028-66DF-00ACD79D2E09}"/>
               </a:ext>
             </a:extLst>
           </p:cNvPr>
@@ -290,7 +290,7 @@
           <p:cNvPr id="6" name="슬라이드 번호 개체 틀 5">
             <a:extLst>
               <a:ext uri="{FF2B5EF4-FFF2-40B4-BE49-F238E27FC236}">
-                <a16:creationId xmlns:a16="http://schemas.microsoft.com/office/drawing/2014/main" id="{CDDA265C-C451-450F-4CB9-E1236BCDFFF2}"/>
+                <a16:creationId xmlns:a16="http://schemas.microsoft.com/office/drawing/2014/main" id="{51B96468-A817-82C5-D6AB-E8F877FABD6F}"/>
               </a:ext>
             </a:extLst>
           </p:cNvPr>
@@ -306,7 +306,7 @@
           <a:bodyPr/>
           <a:lstStyle/>
           <a:p>
-            <a:fld id="{2B191F36-BDAF-4756-8918-2B97940F915D}" type="slidenum">
+            <a:fld id="{D3A47458-2532-49EB-9E23-A67CFBCC437C}" type="slidenum">
               <a:rPr lang="ko-KR" altLang="en-US" smtClean="0"/>
               <a:t>‹#›</a:t>
             </a:fld>
@@ -317,7 +317,7 @@
     </p:spTree>
     <p:extLst>
       <p:ext uri="{BB962C8B-B14F-4D97-AF65-F5344CB8AC3E}">
-        <p14:creationId xmlns:p14="http://schemas.microsoft.com/office/powerpoint/2010/main" val="3897903959"/>
+        <p14:creationId xmlns:p14="http://schemas.microsoft.com/office/powerpoint/2010/main" val="1367878885"/>
       </p:ext>
     </p:extLst>
   </p:cSld>
@@ -349,7 +349,7 @@
           <p:cNvPr id="2" name="제목 1">
             <a:extLst>
               <a:ext uri="{FF2B5EF4-FFF2-40B4-BE49-F238E27FC236}">
-                <a16:creationId xmlns:a16="http://schemas.microsoft.com/office/drawing/2014/main" id="{1DA9C719-1092-971A-6BFA-328C45853651}"/>
+                <a16:creationId xmlns:a16="http://schemas.microsoft.com/office/drawing/2014/main" id="{EE17FBFA-7DDC-14B6-69BD-A163F0A24D87}"/>
               </a:ext>
             </a:extLst>
           </p:cNvPr>
@@ -377,7 +377,7 @@
           <p:cNvPr id="3" name="세로 텍스트 개체 틀 2">
             <a:extLst>
               <a:ext uri="{FF2B5EF4-FFF2-40B4-BE49-F238E27FC236}">
-                <a16:creationId xmlns:a16="http://schemas.microsoft.com/office/drawing/2014/main" id="{63B38B8D-E973-C06B-8358-569E6E4D6DF8}"/>
+                <a16:creationId xmlns:a16="http://schemas.microsoft.com/office/drawing/2014/main" id="{0F3896BA-5C3B-A715-49C8-203A5E40D43B}"/>
               </a:ext>
             </a:extLst>
           </p:cNvPr>
@@ -434,7 +434,7 @@
           <p:cNvPr id="4" name="날짜 개체 틀 3">
             <a:extLst>
               <a:ext uri="{FF2B5EF4-FFF2-40B4-BE49-F238E27FC236}">
-                <a16:creationId xmlns:a16="http://schemas.microsoft.com/office/drawing/2014/main" id="{F7617414-87AF-0C93-93DB-16FD9E0063E2}"/>
+                <a16:creationId xmlns:a16="http://schemas.microsoft.com/office/drawing/2014/main" id="{CAEDBCC3-1483-B89C-F363-7C2BA98684E3}"/>
               </a:ext>
             </a:extLst>
           </p:cNvPr>
@@ -450,7 +450,7 @@
           <a:bodyPr/>
           <a:lstStyle/>
           <a:p>
-            <a:fld id="{BBCE5FCE-C137-4A6E-A349-AF724E9D2612}" type="datetimeFigureOut">
+            <a:fld id="{C56CB09B-924A-4ABE-8F3B-7B27270F5C95}" type="datetimeFigureOut">
               <a:rPr lang="ko-KR" altLang="en-US" smtClean="0"/>
               <a:t>2026-06-21</a:t>
             </a:fld>
@@ -463,7 +463,7 @@
           <p:cNvPr id="5" name="바닥글 개체 틀 4">
             <a:extLst>
               <a:ext uri="{FF2B5EF4-FFF2-40B4-BE49-F238E27FC236}">
-                <a16:creationId xmlns:a16="http://schemas.microsoft.com/office/drawing/2014/main" id="{2EF3E945-4267-67AD-F97D-28444E4B8EF7}"/>
+                <a16:creationId xmlns:a16="http://schemas.microsoft.com/office/drawing/2014/main" id="{29A34C43-4ADA-6B9A-17DF-79A0A8F7A122}"/>
               </a:ext>
             </a:extLst>
           </p:cNvPr>
@@ -488,7 +488,7 @@
           <p:cNvPr id="6" name="슬라이드 번호 개체 틀 5">
             <a:extLst>
               <a:ext uri="{FF2B5EF4-FFF2-40B4-BE49-F238E27FC236}">
-                <a16:creationId xmlns:a16="http://schemas.microsoft.com/office/drawing/2014/main" id="{52BA803A-02F9-AB1C-FF63-BAA2A8E80256}"/>
+                <a16:creationId xmlns:a16="http://schemas.microsoft.com/office/drawing/2014/main" id="{64F77C36-6F56-30CD-F1A8-21F1243A8A2C}"/>
               </a:ext>
             </a:extLst>
           </p:cNvPr>
@@ -504,7 +504,7 @@
           <a:bodyPr/>
           <a:lstStyle/>
           <a:p>
-            <a:fld id="{2B191F36-BDAF-4756-8918-2B97940F915D}" type="slidenum">
+            <a:fld id="{D3A47458-2532-49EB-9E23-A67CFBCC437C}" type="slidenum">
               <a:rPr lang="ko-KR" altLang="en-US" smtClean="0"/>
               <a:t>‹#›</a:t>
             </a:fld>
@@ -515,7 +515,7 @@
     </p:spTree>
     <p:extLst>
       <p:ext uri="{BB962C8B-B14F-4D97-AF65-F5344CB8AC3E}">
-        <p14:creationId xmlns:p14="http://schemas.microsoft.com/office/powerpoint/2010/main" val="215395083"/>
+        <p14:creationId xmlns:p14="http://schemas.microsoft.com/office/powerpoint/2010/main" val="3357210172"/>
       </p:ext>
     </p:extLst>
   </p:cSld>
@@ -547,7 +547,7 @@
           <p:cNvPr id="2" name="세로 제목 1">
             <a:extLst>
               <a:ext uri="{FF2B5EF4-FFF2-40B4-BE49-F238E27FC236}">
-                <a16:creationId xmlns:a16="http://schemas.microsoft.com/office/drawing/2014/main" id="{653128D3-56E3-6887-E4F6-1FB3C40C455C}"/>
+                <a16:creationId xmlns:a16="http://schemas.microsoft.com/office/drawing/2014/main" id="{C94693B7-97E2-4C0C-F875-981768EFA99F}"/>
               </a:ext>
             </a:extLst>
           </p:cNvPr>
@@ -580,7 +580,7 @@
           <p:cNvPr id="3" name="세로 텍스트 개체 틀 2">
             <a:extLst>
               <a:ext uri="{FF2B5EF4-FFF2-40B4-BE49-F238E27FC236}">
-                <a16:creationId xmlns:a16="http://schemas.microsoft.com/office/drawing/2014/main" id="{923B99CB-43BC-19A0-C3A9-B2097D2E99F7}"/>
+                <a16:creationId xmlns:a16="http://schemas.microsoft.com/office/drawing/2014/main" id="{6E7090BA-AE1C-E3F6-A295-8F1157380B69}"/>
               </a:ext>
             </a:extLst>
           </p:cNvPr>
@@ -642,7 +642,7 @@
           <p:cNvPr id="4" name="날짜 개체 틀 3">
             <a:extLst>
               <a:ext uri="{FF2B5EF4-FFF2-40B4-BE49-F238E27FC236}">
-                <a16:creationId xmlns:a16="http://schemas.microsoft.com/office/drawing/2014/main" id="{04DAD116-6727-00BD-0431-9DB27C65D477}"/>
+                <a16:creationId xmlns:a16="http://schemas.microsoft.com/office/drawing/2014/main" id="{F7B14750-D038-9DCC-B2E9-414017DDB2BF}"/>
               </a:ext>
             </a:extLst>
           </p:cNvPr>
@@ -658,7 +658,7 @@
           <a:bodyPr/>
           <a:lstStyle/>
           <a:p>
-            <a:fld id="{BBCE5FCE-C137-4A6E-A349-AF724E9D2612}" type="datetimeFigureOut">
+            <a:fld id="{C56CB09B-924A-4ABE-8F3B-7B27270F5C95}" type="datetimeFigureOut">
               <a:rPr lang="ko-KR" altLang="en-US" smtClean="0"/>
               <a:t>2026-06-21</a:t>
             </a:fld>
@@ -671,7 +671,7 @@
           <p:cNvPr id="5" name="바닥글 개체 틀 4">
             <a:extLst>
               <a:ext uri="{FF2B5EF4-FFF2-40B4-BE49-F238E27FC236}">
-                <a16:creationId xmlns:a16="http://schemas.microsoft.com/office/drawing/2014/main" id="{5376535F-E4B6-D6F5-2680-ECBCD55FF166}"/>
+                <a16:creationId xmlns:a16="http://schemas.microsoft.com/office/drawing/2014/main" id="{D528EC0A-8275-C9C1-8BEB-E29981E996DA}"/>
               </a:ext>
             </a:extLst>
           </p:cNvPr>
@@ -696,7 +696,7 @@
           <p:cNvPr id="6" name="슬라이드 번호 개체 틀 5">
             <a:extLst>
               <a:ext uri="{FF2B5EF4-FFF2-40B4-BE49-F238E27FC236}">
-                <a16:creationId xmlns:a16="http://schemas.microsoft.com/office/drawing/2014/main" id="{AC1243A6-26FE-D476-5CA2-A46CD16BD712}"/>
+                <a16:creationId xmlns:a16="http://schemas.microsoft.com/office/drawing/2014/main" id="{66051A4E-E11B-0D3E-DFCF-6750628EF074}"/>
               </a:ext>
             </a:extLst>
           </p:cNvPr>
@@ -712,7 +712,7 @@
           <a:bodyPr/>
           <a:lstStyle/>
           <a:p>
-            <a:fld id="{2B191F36-BDAF-4756-8918-2B97940F915D}" type="slidenum">
+            <a:fld id="{D3A47458-2532-49EB-9E23-A67CFBCC437C}" type="slidenum">
               <a:rPr lang="ko-KR" altLang="en-US" smtClean="0"/>
               <a:t>‹#›</a:t>
             </a:fld>
@@ -723,7 +723,7 @@
     </p:spTree>
     <p:extLst>
       <p:ext uri="{BB962C8B-B14F-4D97-AF65-F5344CB8AC3E}">
-        <p14:creationId xmlns:p14="http://schemas.microsoft.com/office/powerpoint/2010/main" val="3467042301"/>
+        <p14:creationId xmlns:p14="http://schemas.microsoft.com/office/powerpoint/2010/main" val="60989146"/>
       </p:ext>
     </p:extLst>
   </p:cSld>
@@ -755,7 +755,7 @@
           <p:cNvPr id="2" name="제목 1">
             <a:extLst>
               <a:ext uri="{FF2B5EF4-FFF2-40B4-BE49-F238E27FC236}">
-                <a16:creationId xmlns:a16="http://schemas.microsoft.com/office/drawing/2014/main" id="{21C7EE12-A725-408C-41E0-B33DC5594DA6}"/>
+                <a16:creationId xmlns:a16="http://schemas.microsoft.com/office/drawing/2014/main" id="{895BB150-8B2E-DEFD-09AA-183D9EC96878}"/>
               </a:ext>
             </a:extLst>
           </p:cNvPr>
@@ -783,7 +783,7 @@
           <p:cNvPr id="3" name="내용 개체 틀 2">
             <a:extLst>
               <a:ext uri="{FF2B5EF4-FFF2-40B4-BE49-F238E27FC236}">
-                <a16:creationId xmlns:a16="http://schemas.microsoft.com/office/drawing/2014/main" id="{3E29E7AC-267C-3FE3-7352-EA3BC3A37955}"/>
+                <a16:creationId xmlns:a16="http://schemas.microsoft.com/office/drawing/2014/main" id="{2233A253-821A-EBF5-9576-4CA6DF4AA8D1}"/>
               </a:ext>
             </a:extLst>
           </p:cNvPr>
@@ -840,7 +840,7 @@
           <p:cNvPr id="4" name="날짜 개체 틀 3">
             <a:extLst>
               <a:ext uri="{FF2B5EF4-FFF2-40B4-BE49-F238E27FC236}">
-                <a16:creationId xmlns:a16="http://schemas.microsoft.com/office/drawing/2014/main" id="{173C9F73-A51E-04E6-836F-A194B0F9F916}"/>
+                <a16:creationId xmlns:a16="http://schemas.microsoft.com/office/drawing/2014/main" id="{7566512C-A86B-C5BC-732C-4573273FBC27}"/>
               </a:ext>
             </a:extLst>
           </p:cNvPr>
@@ -856,7 +856,7 @@
           <a:bodyPr/>
           <a:lstStyle/>
           <a:p>
-            <a:fld id="{BBCE5FCE-C137-4A6E-A349-AF724E9D2612}" type="datetimeFigureOut">
+            <a:fld id="{C56CB09B-924A-4ABE-8F3B-7B27270F5C95}" type="datetimeFigureOut">
               <a:rPr lang="ko-KR" altLang="en-US" smtClean="0"/>
               <a:t>2026-06-21</a:t>
             </a:fld>
@@ -869,7 +869,7 @@
           <p:cNvPr id="5" name="바닥글 개체 틀 4">
             <a:extLst>
               <a:ext uri="{FF2B5EF4-FFF2-40B4-BE49-F238E27FC236}">
-                <a16:creationId xmlns:a16="http://schemas.microsoft.com/office/drawing/2014/main" id="{3B06AFC1-43CA-5AA1-69D8-C041D79A2D89}"/>
+                <a16:creationId xmlns:a16="http://schemas.microsoft.com/office/drawing/2014/main" id="{2A7968DD-F3E1-A637-DAE0-2CAEF782DB50}"/>
               </a:ext>
             </a:extLst>
           </p:cNvPr>
@@ -894,7 +894,7 @@
           <p:cNvPr id="6" name="슬라이드 번호 개체 틀 5">
             <a:extLst>
               <a:ext uri="{FF2B5EF4-FFF2-40B4-BE49-F238E27FC236}">
-                <a16:creationId xmlns:a16="http://schemas.microsoft.com/office/drawing/2014/main" id="{F9965614-CC06-D37F-8818-5EF2086919D0}"/>
+                <a16:creationId xmlns:a16="http://schemas.microsoft.com/office/drawing/2014/main" id="{2CE5E579-8263-B1CA-5841-1D7CCB1B2A75}"/>
               </a:ext>
             </a:extLst>
           </p:cNvPr>
@@ -910,7 +910,7 @@
           <a:bodyPr/>
           <a:lstStyle/>
           <a:p>
-            <a:fld id="{2B191F36-BDAF-4756-8918-2B97940F915D}" type="slidenum">
+            <a:fld id="{D3A47458-2532-49EB-9E23-A67CFBCC437C}" type="slidenum">
               <a:rPr lang="ko-KR" altLang="en-US" smtClean="0"/>
               <a:t>‹#›</a:t>
             </a:fld>
@@ -921,7 +921,7 @@
     </p:spTree>
     <p:extLst>
       <p:ext uri="{BB962C8B-B14F-4D97-AF65-F5344CB8AC3E}">
-        <p14:creationId xmlns:p14="http://schemas.microsoft.com/office/powerpoint/2010/main" val="2816063283"/>
+        <p14:creationId xmlns:p14="http://schemas.microsoft.com/office/powerpoint/2010/main" val="1809395730"/>
       </p:ext>
     </p:extLst>
   </p:cSld>
@@ -953,7 +953,7 @@
           <p:cNvPr id="2" name="제목 1">
             <a:extLst>
               <a:ext uri="{FF2B5EF4-FFF2-40B4-BE49-F238E27FC236}">
-                <a16:creationId xmlns:a16="http://schemas.microsoft.com/office/drawing/2014/main" id="{5A3C91A9-74F9-E478-D789-34ACBEC31126}"/>
+                <a16:creationId xmlns:a16="http://schemas.microsoft.com/office/drawing/2014/main" id="{0F163EE7-8CA4-CD22-2D30-DC2BB65A88C1}"/>
               </a:ext>
             </a:extLst>
           </p:cNvPr>
@@ -990,7 +990,7 @@
           <p:cNvPr id="3" name="텍스트 개체 틀 2">
             <a:extLst>
               <a:ext uri="{FF2B5EF4-FFF2-40B4-BE49-F238E27FC236}">
-                <a16:creationId xmlns:a16="http://schemas.microsoft.com/office/drawing/2014/main" id="{8957B5ED-0DC8-EFBD-D72F-EE32A72E1194}"/>
+                <a16:creationId xmlns:a16="http://schemas.microsoft.com/office/drawing/2014/main" id="{F95FEE7A-53C3-B6D8-78E6-D2AD7628F0CD}"/>
               </a:ext>
             </a:extLst>
           </p:cNvPr>
@@ -1115,7 +1115,7 @@
           <p:cNvPr id="4" name="날짜 개체 틀 3">
             <a:extLst>
               <a:ext uri="{FF2B5EF4-FFF2-40B4-BE49-F238E27FC236}">
-                <a16:creationId xmlns:a16="http://schemas.microsoft.com/office/drawing/2014/main" id="{A44A760D-BC43-0B72-8F05-8506D7418FFB}"/>
+                <a16:creationId xmlns:a16="http://schemas.microsoft.com/office/drawing/2014/main" id="{73D626D6-F55A-5C2F-3B02-74416C6412DD}"/>
               </a:ext>
             </a:extLst>
           </p:cNvPr>
@@ -1131,7 +1131,7 @@
           <a:bodyPr/>
           <a:lstStyle/>
           <a:p>
-            <a:fld id="{BBCE5FCE-C137-4A6E-A349-AF724E9D2612}" type="datetimeFigureOut">
+            <a:fld id="{C56CB09B-924A-4ABE-8F3B-7B27270F5C95}" type="datetimeFigureOut">
               <a:rPr lang="ko-KR" altLang="en-US" smtClean="0"/>
               <a:t>2026-06-21</a:t>
             </a:fld>
@@ -1144,7 +1144,7 @@
           <p:cNvPr id="5" name="바닥글 개체 틀 4">
             <a:extLst>
               <a:ext uri="{FF2B5EF4-FFF2-40B4-BE49-F238E27FC236}">
-                <a16:creationId xmlns:a16="http://schemas.microsoft.com/office/drawing/2014/main" id="{CCC30712-760A-EBAF-1E7A-E618EB9C5DE0}"/>
+                <a16:creationId xmlns:a16="http://schemas.microsoft.com/office/drawing/2014/main" id="{7D3ED58A-558A-1807-EC3D-9C6BAB24781B}"/>
               </a:ext>
             </a:extLst>
           </p:cNvPr>
@@ -1169,7 +1169,7 @@
           <p:cNvPr id="6" name="슬라이드 번호 개체 틀 5">
             <a:extLst>
               <a:ext uri="{FF2B5EF4-FFF2-40B4-BE49-F238E27FC236}">
-                <a16:creationId xmlns:a16="http://schemas.microsoft.com/office/drawing/2014/main" id="{013DA966-A2FB-41DF-6D14-459BD2A97604}"/>
+                <a16:creationId xmlns:a16="http://schemas.microsoft.com/office/drawing/2014/main" id="{575B7F6F-3A5B-1054-B245-C47895F53599}"/>
               </a:ext>
             </a:extLst>
           </p:cNvPr>
@@ -1185,7 +1185,7 @@
           <a:bodyPr/>
           <a:lstStyle/>
           <a:p>
-            <a:fld id="{2B191F36-BDAF-4756-8918-2B97940F915D}" type="slidenum">
+            <a:fld id="{D3A47458-2532-49EB-9E23-A67CFBCC437C}" type="slidenum">
               <a:rPr lang="ko-KR" altLang="en-US" smtClean="0"/>
               <a:t>‹#›</a:t>
             </a:fld>
@@ -1196,7 +1196,7 @@
     </p:spTree>
     <p:extLst>
       <p:ext uri="{BB962C8B-B14F-4D97-AF65-F5344CB8AC3E}">
-        <p14:creationId xmlns:p14="http://schemas.microsoft.com/office/powerpoint/2010/main" val="1230502311"/>
+        <p14:creationId xmlns:p14="http://schemas.microsoft.com/office/powerpoint/2010/main" val="4011219354"/>
       </p:ext>
     </p:extLst>
   </p:cSld>
@@ -1228,7 +1228,7 @@
           <p:cNvPr id="2" name="제목 1">
             <a:extLst>
               <a:ext uri="{FF2B5EF4-FFF2-40B4-BE49-F238E27FC236}">
-                <a16:creationId xmlns:a16="http://schemas.microsoft.com/office/drawing/2014/main" id="{48B97ABD-1F87-6827-9505-7AA39288D92D}"/>
+                <a16:creationId xmlns:a16="http://schemas.microsoft.com/office/drawing/2014/main" id="{E4C8BBCB-9CE4-EE85-3543-E01083EE532D}"/>
               </a:ext>
             </a:extLst>
           </p:cNvPr>
@@ -1256,7 +1256,7 @@
           <p:cNvPr id="3" name="내용 개체 틀 2">
             <a:extLst>
               <a:ext uri="{FF2B5EF4-FFF2-40B4-BE49-F238E27FC236}">
-                <a16:creationId xmlns:a16="http://schemas.microsoft.com/office/drawing/2014/main" id="{15E8A035-91BD-816B-F48A-A1960C61447E}"/>
+                <a16:creationId xmlns:a16="http://schemas.microsoft.com/office/drawing/2014/main" id="{32417E4A-3E1B-1DA7-0C07-3FB07568A416}"/>
               </a:ext>
             </a:extLst>
           </p:cNvPr>
@@ -1318,7 +1318,7 @@
           <p:cNvPr id="4" name="내용 개체 틀 3">
             <a:extLst>
               <a:ext uri="{FF2B5EF4-FFF2-40B4-BE49-F238E27FC236}">
-                <a16:creationId xmlns:a16="http://schemas.microsoft.com/office/drawing/2014/main" id="{CBEA2845-8A94-7E34-1719-5BCFB17D3CAC}"/>
+                <a16:creationId xmlns:a16="http://schemas.microsoft.com/office/drawing/2014/main" id="{00996385-E499-2D6D-88F1-671273748172}"/>
               </a:ext>
             </a:extLst>
           </p:cNvPr>
@@ -1380,7 +1380,7 @@
           <p:cNvPr id="5" name="날짜 개체 틀 4">
             <a:extLst>
               <a:ext uri="{FF2B5EF4-FFF2-40B4-BE49-F238E27FC236}">
-                <a16:creationId xmlns:a16="http://schemas.microsoft.com/office/drawing/2014/main" id="{F5B16447-BCCB-D993-45BD-B4E69A7D8EDB}"/>
+                <a16:creationId xmlns:a16="http://schemas.microsoft.com/office/drawing/2014/main" id="{EF903F8E-333F-5A25-7BF2-6896612BD12C}"/>
               </a:ext>
             </a:extLst>
           </p:cNvPr>
@@ -1396,7 +1396,7 @@
           <a:bodyPr/>
           <a:lstStyle/>
           <a:p>
-            <a:fld id="{BBCE5FCE-C137-4A6E-A349-AF724E9D2612}" type="datetimeFigureOut">
+            <a:fld id="{C56CB09B-924A-4ABE-8F3B-7B27270F5C95}" type="datetimeFigureOut">
               <a:rPr lang="ko-KR" altLang="en-US" smtClean="0"/>
               <a:t>2026-06-21</a:t>
             </a:fld>
@@ -1409,7 +1409,7 @@
           <p:cNvPr id="6" name="바닥글 개체 틀 5">
             <a:extLst>
               <a:ext uri="{FF2B5EF4-FFF2-40B4-BE49-F238E27FC236}">
-                <a16:creationId xmlns:a16="http://schemas.microsoft.com/office/drawing/2014/main" id="{EA0C13BB-B47A-BCF7-3C64-C2BCB53C15FD}"/>
+                <a16:creationId xmlns:a16="http://schemas.microsoft.com/office/drawing/2014/main" id="{9F222359-D8F8-54C3-31A7-861784BFBCE0}"/>
               </a:ext>
             </a:extLst>
           </p:cNvPr>
@@ -1434,7 +1434,7 @@
           <p:cNvPr id="7" name="슬라이드 번호 개체 틀 6">
             <a:extLst>
               <a:ext uri="{FF2B5EF4-FFF2-40B4-BE49-F238E27FC236}">
-                <a16:creationId xmlns:a16="http://schemas.microsoft.com/office/drawing/2014/main" id="{01AC7681-8473-5F93-D134-0EA3F4E77B47}"/>
+                <a16:creationId xmlns:a16="http://schemas.microsoft.com/office/drawing/2014/main" id="{285C5A6F-06A0-2A7D-1B7E-321E8FDA80E6}"/>
               </a:ext>
             </a:extLst>
           </p:cNvPr>
@@ -1450,7 +1450,7 @@
           <a:bodyPr/>
           <a:lstStyle/>
           <a:p>
-            <a:fld id="{2B191F36-BDAF-4756-8918-2B97940F915D}" type="slidenum">
+            <a:fld id="{D3A47458-2532-49EB-9E23-A67CFBCC437C}" type="slidenum">
               <a:rPr lang="ko-KR" altLang="en-US" smtClean="0"/>
               <a:t>‹#›</a:t>
             </a:fld>
@@ -1461,7 +1461,7 @@
     </p:spTree>
     <p:extLst>
       <p:ext uri="{BB962C8B-B14F-4D97-AF65-F5344CB8AC3E}">
-        <p14:creationId xmlns:p14="http://schemas.microsoft.com/office/powerpoint/2010/main" val="1471737091"/>
+        <p14:creationId xmlns:p14="http://schemas.microsoft.com/office/powerpoint/2010/main" val="57420849"/>
       </p:ext>
     </p:extLst>
   </p:cSld>
@@ -1493,7 +1493,7 @@
           <p:cNvPr id="2" name="제목 1">
             <a:extLst>
               <a:ext uri="{FF2B5EF4-FFF2-40B4-BE49-F238E27FC236}">
-                <a16:creationId xmlns:a16="http://schemas.microsoft.com/office/drawing/2014/main" id="{6A06550D-4349-E6E9-F814-A051E5B1B8F9}"/>
+                <a16:creationId xmlns:a16="http://schemas.microsoft.com/office/drawing/2014/main" id="{938E7163-64FE-63B8-FF64-138E075670B5}"/>
               </a:ext>
             </a:extLst>
           </p:cNvPr>
@@ -1526,7 +1526,7 @@
           <p:cNvPr id="3" name="텍스트 개체 틀 2">
             <a:extLst>
               <a:ext uri="{FF2B5EF4-FFF2-40B4-BE49-F238E27FC236}">
-                <a16:creationId xmlns:a16="http://schemas.microsoft.com/office/drawing/2014/main" id="{AABDA8E7-3A25-40C6-DC81-A0483B8E6D0B}"/>
+                <a16:creationId xmlns:a16="http://schemas.microsoft.com/office/drawing/2014/main" id="{10EA0985-195F-94D6-D07A-80877B29D911}"/>
               </a:ext>
             </a:extLst>
           </p:cNvPr>
@@ -1597,7 +1597,7 @@
           <p:cNvPr id="4" name="내용 개체 틀 3">
             <a:extLst>
               <a:ext uri="{FF2B5EF4-FFF2-40B4-BE49-F238E27FC236}">
-                <a16:creationId xmlns:a16="http://schemas.microsoft.com/office/drawing/2014/main" id="{FD9366D2-E491-C439-8064-047147B5F73A}"/>
+                <a16:creationId xmlns:a16="http://schemas.microsoft.com/office/drawing/2014/main" id="{5D2AAF64-0B28-8163-312B-2FE7B601DF3B}"/>
               </a:ext>
             </a:extLst>
           </p:cNvPr>
@@ -1659,7 +1659,7 @@
           <p:cNvPr id="5" name="텍스트 개체 틀 4">
             <a:extLst>
               <a:ext uri="{FF2B5EF4-FFF2-40B4-BE49-F238E27FC236}">
-                <a16:creationId xmlns:a16="http://schemas.microsoft.com/office/drawing/2014/main" id="{DEE14B0E-86E2-9E80-3024-6DFA9538C8F8}"/>
+                <a16:creationId xmlns:a16="http://schemas.microsoft.com/office/drawing/2014/main" id="{FE72E930-BE51-98B4-F3D2-F106BE4D9B2E}"/>
               </a:ext>
             </a:extLst>
           </p:cNvPr>
@@ -1730,7 +1730,7 @@
           <p:cNvPr id="6" name="내용 개체 틀 5">
             <a:extLst>
               <a:ext uri="{FF2B5EF4-FFF2-40B4-BE49-F238E27FC236}">
-                <a16:creationId xmlns:a16="http://schemas.microsoft.com/office/drawing/2014/main" id="{C25DE6AE-B269-B3E6-2B47-E10F6F86F989}"/>
+                <a16:creationId xmlns:a16="http://schemas.microsoft.com/office/drawing/2014/main" id="{9BA3674E-FFA2-1EE3-D5B2-F963E1F48FCC}"/>
               </a:ext>
             </a:extLst>
           </p:cNvPr>
@@ -1792,7 +1792,7 @@
           <p:cNvPr id="7" name="날짜 개체 틀 6">
             <a:extLst>
               <a:ext uri="{FF2B5EF4-FFF2-40B4-BE49-F238E27FC236}">
-                <a16:creationId xmlns:a16="http://schemas.microsoft.com/office/drawing/2014/main" id="{EEB6B6E0-E19D-067E-7FD4-6C6D1F5FB482}"/>
+                <a16:creationId xmlns:a16="http://schemas.microsoft.com/office/drawing/2014/main" id="{6F0ABAF1-304E-3F48-7237-531A6D0AC128}"/>
               </a:ext>
             </a:extLst>
           </p:cNvPr>
@@ -1808,7 +1808,7 @@
           <a:bodyPr/>
           <a:lstStyle/>
           <a:p>
-            <a:fld id="{BBCE5FCE-C137-4A6E-A349-AF724E9D2612}" type="datetimeFigureOut">
+            <a:fld id="{C56CB09B-924A-4ABE-8F3B-7B27270F5C95}" type="datetimeFigureOut">
               <a:rPr lang="ko-KR" altLang="en-US" smtClean="0"/>
               <a:t>2026-06-21</a:t>
             </a:fld>
@@ -1821,7 +1821,7 @@
           <p:cNvPr id="8" name="바닥글 개체 틀 7">
             <a:extLst>
               <a:ext uri="{FF2B5EF4-FFF2-40B4-BE49-F238E27FC236}">
-                <a16:creationId xmlns:a16="http://schemas.microsoft.com/office/drawing/2014/main" id="{B56698E3-DFB3-87CB-01AF-38A4D562A8AB}"/>
+                <a16:creationId xmlns:a16="http://schemas.microsoft.com/office/drawing/2014/main" id="{350404E6-91BB-C965-6BEA-116B339DF680}"/>
               </a:ext>
             </a:extLst>
           </p:cNvPr>
@@ -1846,7 +1846,7 @@
           <p:cNvPr id="9" name="슬라이드 번호 개체 틀 8">
             <a:extLst>
               <a:ext uri="{FF2B5EF4-FFF2-40B4-BE49-F238E27FC236}">
-                <a16:creationId xmlns:a16="http://schemas.microsoft.com/office/drawing/2014/main" id="{E6688BC9-0B8F-6B46-2302-AA63CD1AB1D2}"/>
+                <a16:creationId xmlns:a16="http://schemas.microsoft.com/office/drawing/2014/main" id="{3DD2FA6D-6822-9A89-D42D-2B205DC4F3BB}"/>
               </a:ext>
             </a:extLst>
           </p:cNvPr>
@@ -1862,7 +1862,7 @@
           <a:bodyPr/>
           <a:lstStyle/>
           <a:p>
-            <a:fld id="{2B191F36-BDAF-4756-8918-2B97940F915D}" type="slidenum">
+            <a:fld id="{D3A47458-2532-49EB-9E23-A67CFBCC437C}" type="slidenum">
               <a:rPr lang="ko-KR" altLang="en-US" smtClean="0"/>
               <a:t>‹#›</a:t>
             </a:fld>
@@ -1873,7 +1873,7 @@
     </p:spTree>
     <p:extLst>
       <p:ext uri="{BB962C8B-B14F-4D97-AF65-F5344CB8AC3E}">
-        <p14:creationId xmlns:p14="http://schemas.microsoft.com/office/powerpoint/2010/main" val="2920768522"/>
+        <p14:creationId xmlns:p14="http://schemas.microsoft.com/office/powerpoint/2010/main" val="1107329252"/>
       </p:ext>
     </p:extLst>
   </p:cSld>
@@ -1905,7 +1905,7 @@
           <p:cNvPr id="2" name="제목 1">
             <a:extLst>
               <a:ext uri="{FF2B5EF4-FFF2-40B4-BE49-F238E27FC236}">
-                <a16:creationId xmlns:a16="http://schemas.microsoft.com/office/drawing/2014/main" id="{2CAEA5C4-8309-E77E-5BF8-AC01F7475728}"/>
+                <a16:creationId xmlns:a16="http://schemas.microsoft.com/office/drawing/2014/main" id="{10FC0AA2-F65E-6585-6ABD-E36C1C5F799E}"/>
               </a:ext>
             </a:extLst>
           </p:cNvPr>
@@ -1933,7 +1933,7 @@
           <p:cNvPr id="3" name="날짜 개체 틀 2">
             <a:extLst>
               <a:ext uri="{FF2B5EF4-FFF2-40B4-BE49-F238E27FC236}">
-                <a16:creationId xmlns:a16="http://schemas.microsoft.com/office/drawing/2014/main" id="{9F34B0B0-AD47-C707-2220-1DF3C4A01920}"/>
+                <a16:creationId xmlns:a16="http://schemas.microsoft.com/office/drawing/2014/main" id="{B078A1C2-0E55-4157-DA35-2B0646E894EE}"/>
               </a:ext>
             </a:extLst>
           </p:cNvPr>
@@ -1949,7 +1949,7 @@
           <a:bodyPr/>
           <a:lstStyle/>
           <a:p>
-            <a:fld id="{BBCE5FCE-C137-4A6E-A349-AF724E9D2612}" type="datetimeFigureOut">
+            <a:fld id="{C56CB09B-924A-4ABE-8F3B-7B27270F5C95}" type="datetimeFigureOut">
               <a:rPr lang="ko-KR" altLang="en-US" smtClean="0"/>
               <a:t>2026-06-21</a:t>
             </a:fld>
@@ -1962,7 +1962,7 @@
           <p:cNvPr id="4" name="바닥글 개체 틀 3">
             <a:extLst>
               <a:ext uri="{FF2B5EF4-FFF2-40B4-BE49-F238E27FC236}">
-                <a16:creationId xmlns:a16="http://schemas.microsoft.com/office/drawing/2014/main" id="{AC1471AB-80A1-39BF-A042-A08842F22B14}"/>
+                <a16:creationId xmlns:a16="http://schemas.microsoft.com/office/drawing/2014/main" id="{C7DC72F7-AC98-CB9F-FC4F-4EDCDC98C152}"/>
               </a:ext>
             </a:extLst>
           </p:cNvPr>
@@ -1987,7 +1987,7 @@
           <p:cNvPr id="5" name="슬라이드 번호 개체 틀 4">
             <a:extLst>
               <a:ext uri="{FF2B5EF4-FFF2-40B4-BE49-F238E27FC236}">
-                <a16:creationId xmlns:a16="http://schemas.microsoft.com/office/drawing/2014/main" id="{FC0B026A-B9FD-87EC-E686-FC2CCDB2FB31}"/>
+                <a16:creationId xmlns:a16="http://schemas.microsoft.com/office/drawing/2014/main" id="{CF79D011-9720-E761-52E1-3A1A6ECD7370}"/>
               </a:ext>
             </a:extLst>
           </p:cNvPr>
@@ -2003,7 +2003,7 @@
           <a:bodyPr/>
           <a:lstStyle/>
           <a:p>
-            <a:fld id="{2B191F36-BDAF-4756-8918-2B97940F915D}" type="slidenum">
+            <a:fld id="{D3A47458-2532-49EB-9E23-A67CFBCC437C}" type="slidenum">
               <a:rPr lang="ko-KR" altLang="en-US" smtClean="0"/>
               <a:t>‹#›</a:t>
             </a:fld>
@@ -2014,7 +2014,7 @@
     </p:spTree>
     <p:extLst>
       <p:ext uri="{BB962C8B-B14F-4D97-AF65-F5344CB8AC3E}">
-        <p14:creationId xmlns:p14="http://schemas.microsoft.com/office/powerpoint/2010/main" val="2811457797"/>
+        <p14:creationId xmlns:p14="http://schemas.microsoft.com/office/powerpoint/2010/main" val="151527459"/>
       </p:ext>
     </p:extLst>
   </p:cSld>
@@ -2046,7 +2046,7 @@
           <p:cNvPr id="2" name="날짜 개체 틀 1">
             <a:extLst>
               <a:ext uri="{FF2B5EF4-FFF2-40B4-BE49-F238E27FC236}">
-                <a16:creationId xmlns:a16="http://schemas.microsoft.com/office/drawing/2014/main" id="{447B39C3-3CF2-B89F-9125-C8E9DDC967B6}"/>
+                <a16:creationId xmlns:a16="http://schemas.microsoft.com/office/drawing/2014/main" id="{4AFA276D-2649-F5E7-63F9-510CC2236B63}"/>
               </a:ext>
             </a:extLst>
           </p:cNvPr>
@@ -2062,7 +2062,7 @@
           <a:bodyPr/>
           <a:lstStyle/>
           <a:p>
-            <a:fld id="{BBCE5FCE-C137-4A6E-A349-AF724E9D2612}" type="datetimeFigureOut">
+            <a:fld id="{C56CB09B-924A-4ABE-8F3B-7B27270F5C95}" type="datetimeFigureOut">
               <a:rPr lang="ko-KR" altLang="en-US" smtClean="0"/>
               <a:t>2026-06-21</a:t>
             </a:fld>
@@ -2075,7 +2075,7 @@
           <p:cNvPr id="3" name="바닥글 개체 틀 2">
             <a:extLst>
               <a:ext uri="{FF2B5EF4-FFF2-40B4-BE49-F238E27FC236}">
-                <a16:creationId xmlns:a16="http://schemas.microsoft.com/office/drawing/2014/main" id="{72871281-100F-16BC-C88E-DA1FFABCB72A}"/>
+                <a16:creationId xmlns:a16="http://schemas.microsoft.com/office/drawing/2014/main" id="{EF2812A9-B5BC-2E83-5E50-A393CE6E2AA1}"/>
               </a:ext>
             </a:extLst>
           </p:cNvPr>
@@ -2100,7 +2100,7 @@
           <p:cNvPr id="4" name="슬라이드 번호 개체 틀 3">
             <a:extLst>
               <a:ext uri="{FF2B5EF4-FFF2-40B4-BE49-F238E27FC236}">
-                <a16:creationId xmlns:a16="http://schemas.microsoft.com/office/drawing/2014/main" id="{DD085CE4-B905-2561-63CD-B0BD0E5D6F0F}"/>
+                <a16:creationId xmlns:a16="http://schemas.microsoft.com/office/drawing/2014/main" id="{D2234DC8-43F9-9B58-C7F4-0D5DBE325ECA}"/>
               </a:ext>
             </a:extLst>
           </p:cNvPr>
@@ -2116,7 +2116,7 @@
           <a:bodyPr/>
           <a:lstStyle/>
           <a:p>
-            <a:fld id="{2B191F36-BDAF-4756-8918-2B97940F915D}" type="slidenum">
+            <a:fld id="{D3A47458-2532-49EB-9E23-A67CFBCC437C}" type="slidenum">
               <a:rPr lang="ko-KR" altLang="en-US" smtClean="0"/>
               <a:t>‹#›</a:t>
             </a:fld>
@@ -2127,7 +2127,7 @@
     </p:spTree>
     <p:extLst>
       <p:ext uri="{BB962C8B-B14F-4D97-AF65-F5344CB8AC3E}">
-        <p14:creationId xmlns:p14="http://schemas.microsoft.com/office/powerpoint/2010/main" val="2171788464"/>
+        <p14:creationId xmlns:p14="http://schemas.microsoft.com/office/powerpoint/2010/main" val="3841180524"/>
       </p:ext>
     </p:extLst>
   </p:cSld>
@@ -2159,7 +2159,7 @@
           <p:cNvPr id="2" name="제목 1">
             <a:extLst>
               <a:ext uri="{FF2B5EF4-FFF2-40B4-BE49-F238E27FC236}">
-                <a16:creationId xmlns:a16="http://schemas.microsoft.com/office/drawing/2014/main" id="{7C555960-0B51-4892-A540-33CCBB072DC0}"/>
+                <a16:creationId xmlns:a16="http://schemas.microsoft.com/office/drawing/2014/main" id="{A289B40F-A228-3AB9-9F87-FE09E534FB8A}"/>
               </a:ext>
             </a:extLst>
           </p:cNvPr>
@@ -2196,7 +2196,7 @@
           <p:cNvPr id="3" name="내용 개체 틀 2">
             <a:extLst>
               <a:ext uri="{FF2B5EF4-FFF2-40B4-BE49-F238E27FC236}">
-                <a16:creationId xmlns:a16="http://schemas.microsoft.com/office/drawing/2014/main" id="{E7C34F78-C893-A1AA-859E-769EE84F42F2}"/>
+                <a16:creationId xmlns:a16="http://schemas.microsoft.com/office/drawing/2014/main" id="{6B335BBC-2515-B9A4-4E8C-99F41D57C810}"/>
               </a:ext>
             </a:extLst>
           </p:cNvPr>
@@ -2286,7 +2286,7 @@
           <p:cNvPr id="4" name="텍스트 개체 틀 3">
             <a:extLst>
               <a:ext uri="{FF2B5EF4-FFF2-40B4-BE49-F238E27FC236}">
-                <a16:creationId xmlns:a16="http://schemas.microsoft.com/office/drawing/2014/main" id="{39AE5F33-CEA6-CFD3-1BE2-444C50FB6035}"/>
+                <a16:creationId xmlns:a16="http://schemas.microsoft.com/office/drawing/2014/main" id="{F675ACFE-0F2B-0464-1C6C-3E5134BF97EF}"/>
               </a:ext>
             </a:extLst>
           </p:cNvPr>
@@ -2357,7 +2357,7 @@
           <p:cNvPr id="5" name="날짜 개체 틀 4">
             <a:extLst>
               <a:ext uri="{FF2B5EF4-FFF2-40B4-BE49-F238E27FC236}">
-                <a16:creationId xmlns:a16="http://schemas.microsoft.com/office/drawing/2014/main" id="{D84155CA-3860-604E-7D10-4AF29473BA62}"/>
+                <a16:creationId xmlns:a16="http://schemas.microsoft.com/office/drawing/2014/main" id="{BE4BFBC0-5B98-800E-7F35-74402BA94C57}"/>
               </a:ext>
             </a:extLst>
           </p:cNvPr>
@@ -2373,7 +2373,7 @@
           <a:bodyPr/>
           <a:lstStyle/>
           <a:p>
-            <a:fld id="{BBCE5FCE-C137-4A6E-A349-AF724E9D2612}" type="datetimeFigureOut">
+            <a:fld id="{C56CB09B-924A-4ABE-8F3B-7B27270F5C95}" type="datetimeFigureOut">
               <a:rPr lang="ko-KR" altLang="en-US" smtClean="0"/>
               <a:t>2026-06-21</a:t>
             </a:fld>
@@ -2386,7 +2386,7 @@
           <p:cNvPr id="6" name="바닥글 개체 틀 5">
             <a:extLst>
               <a:ext uri="{FF2B5EF4-FFF2-40B4-BE49-F238E27FC236}">
-                <a16:creationId xmlns:a16="http://schemas.microsoft.com/office/drawing/2014/main" id="{96D804D8-B565-48D2-65B6-CA04FE115D11}"/>
+                <a16:creationId xmlns:a16="http://schemas.microsoft.com/office/drawing/2014/main" id="{D913A8D1-0170-21B7-4F2E-8693B79713BA}"/>
               </a:ext>
             </a:extLst>
           </p:cNvPr>
@@ -2411,7 +2411,7 @@
           <p:cNvPr id="7" name="슬라이드 번호 개체 틀 6">
             <a:extLst>
               <a:ext uri="{FF2B5EF4-FFF2-40B4-BE49-F238E27FC236}">
-                <a16:creationId xmlns:a16="http://schemas.microsoft.com/office/drawing/2014/main" id="{DC5B6CA1-A7CC-C37E-AEF6-100385B0D981}"/>
+                <a16:creationId xmlns:a16="http://schemas.microsoft.com/office/drawing/2014/main" id="{45391D3D-ED1D-6298-6801-01547B041C94}"/>
               </a:ext>
             </a:extLst>
           </p:cNvPr>
@@ -2427,7 +2427,7 @@
           <a:bodyPr/>
           <a:lstStyle/>
           <a:p>
-            <a:fld id="{2B191F36-BDAF-4756-8918-2B97940F915D}" type="slidenum">
+            <a:fld id="{D3A47458-2532-49EB-9E23-A67CFBCC437C}" type="slidenum">
               <a:rPr lang="ko-KR" altLang="en-US" smtClean="0"/>
               <a:t>‹#›</a:t>
             </a:fld>
@@ -2438,7 +2438,7 @@
     </p:spTree>
     <p:extLst>
       <p:ext uri="{BB962C8B-B14F-4D97-AF65-F5344CB8AC3E}">
-        <p14:creationId xmlns:p14="http://schemas.microsoft.com/office/powerpoint/2010/main" val="3268423433"/>
+        <p14:creationId xmlns:p14="http://schemas.microsoft.com/office/powerpoint/2010/main" val="4076835907"/>
       </p:ext>
     </p:extLst>
   </p:cSld>
@@ -2470,7 +2470,7 @@
           <p:cNvPr id="2" name="제목 1">
             <a:extLst>
               <a:ext uri="{FF2B5EF4-FFF2-40B4-BE49-F238E27FC236}">
-                <a16:creationId xmlns:a16="http://schemas.microsoft.com/office/drawing/2014/main" id="{AAC6DD83-145B-0BB7-76A8-92E42A2F21A5}"/>
+                <a16:creationId xmlns:a16="http://schemas.microsoft.com/office/drawing/2014/main" id="{B1813A8F-08EB-2386-E1C6-347244F70D4E}"/>
               </a:ext>
             </a:extLst>
           </p:cNvPr>
@@ -2507,7 +2507,7 @@
           <p:cNvPr id="3" name="그림 개체 틀 2">
             <a:extLst>
               <a:ext uri="{FF2B5EF4-FFF2-40B4-BE49-F238E27FC236}">
-                <a16:creationId xmlns:a16="http://schemas.microsoft.com/office/drawing/2014/main" id="{7C55993B-D31F-1F68-8C8D-DE85F9689EA6}"/>
+                <a16:creationId xmlns:a16="http://schemas.microsoft.com/office/drawing/2014/main" id="{7D86926F-C4F5-11F5-EA25-876B69877963}"/>
               </a:ext>
             </a:extLst>
           </p:cNvPr>
@@ -2574,7 +2574,7 @@
           <p:cNvPr id="4" name="텍스트 개체 틀 3">
             <a:extLst>
               <a:ext uri="{FF2B5EF4-FFF2-40B4-BE49-F238E27FC236}">
-                <a16:creationId xmlns:a16="http://schemas.microsoft.com/office/drawing/2014/main" id="{86955DEC-13B9-E690-C9CF-7373CD2AFF4E}"/>
+                <a16:creationId xmlns:a16="http://schemas.microsoft.com/office/drawing/2014/main" id="{2D043360-26C2-97F8-B173-61D571C5E7BC}"/>
               </a:ext>
             </a:extLst>
           </p:cNvPr>
@@ -2645,7 +2645,7 @@
           <p:cNvPr id="5" name="날짜 개체 틀 4">
             <a:extLst>
               <a:ext uri="{FF2B5EF4-FFF2-40B4-BE49-F238E27FC236}">
-                <a16:creationId xmlns:a16="http://schemas.microsoft.com/office/drawing/2014/main" id="{64F39131-6A0B-BA5B-2F3F-1F4F9B7A7EBF}"/>
+                <a16:creationId xmlns:a16="http://schemas.microsoft.com/office/drawing/2014/main" id="{3E8C2396-1149-37EC-A45A-AE0013792B98}"/>
               </a:ext>
             </a:extLst>
           </p:cNvPr>
@@ -2661,7 +2661,7 @@
           <a:bodyPr/>
           <a:lstStyle/>
           <a:p>
-            <a:fld id="{BBCE5FCE-C137-4A6E-A349-AF724E9D2612}" type="datetimeFigureOut">
+            <a:fld id="{C56CB09B-924A-4ABE-8F3B-7B27270F5C95}" type="datetimeFigureOut">
               <a:rPr lang="ko-KR" altLang="en-US" smtClean="0"/>
               <a:t>2026-06-21</a:t>
             </a:fld>
@@ -2674,7 +2674,7 @@
           <p:cNvPr id="6" name="바닥글 개체 틀 5">
             <a:extLst>
               <a:ext uri="{FF2B5EF4-FFF2-40B4-BE49-F238E27FC236}">
-                <a16:creationId xmlns:a16="http://schemas.microsoft.com/office/drawing/2014/main" id="{ED132DB5-0517-73A8-3AC7-75D6BF106CC9}"/>
+                <a16:creationId xmlns:a16="http://schemas.microsoft.com/office/drawing/2014/main" id="{31DC5376-4E8D-B97D-ED5D-001C90BCAE2E}"/>
               </a:ext>
             </a:extLst>
           </p:cNvPr>
@@ -2699,7 +2699,7 @@
           <p:cNvPr id="7" name="슬라이드 번호 개체 틀 6">
             <a:extLst>
               <a:ext uri="{FF2B5EF4-FFF2-40B4-BE49-F238E27FC236}">
-                <a16:creationId xmlns:a16="http://schemas.microsoft.com/office/drawing/2014/main" id="{92B3A1F8-EC32-C2DC-4D8A-A8FDE6F8035B}"/>
+                <a16:creationId xmlns:a16="http://schemas.microsoft.com/office/drawing/2014/main" id="{94621A28-32A8-69DB-7161-27757E2D7206}"/>
               </a:ext>
             </a:extLst>
           </p:cNvPr>
@@ -2715,7 +2715,7 @@
           <a:bodyPr/>
           <a:lstStyle/>
           <a:p>
-            <a:fld id="{2B191F36-BDAF-4756-8918-2B97940F915D}" type="slidenum">
+            <a:fld id="{D3A47458-2532-49EB-9E23-A67CFBCC437C}" type="slidenum">
               <a:rPr lang="ko-KR" altLang="en-US" smtClean="0"/>
               <a:t>‹#›</a:t>
             </a:fld>
@@ -2726,7 +2726,7 @@
     </p:spTree>
     <p:extLst>
       <p:ext uri="{BB962C8B-B14F-4D97-AF65-F5344CB8AC3E}">
-        <p14:creationId xmlns:p14="http://schemas.microsoft.com/office/powerpoint/2010/main" val="3181649641"/>
+        <p14:creationId xmlns:p14="http://schemas.microsoft.com/office/powerpoint/2010/main" val="4062780644"/>
       </p:ext>
     </p:extLst>
   </p:cSld>
@@ -2763,7 +2763,7 @@
           <p:cNvPr id="2" name="제목 개체 틀 1">
             <a:extLst>
               <a:ext uri="{FF2B5EF4-FFF2-40B4-BE49-F238E27FC236}">
-                <a16:creationId xmlns:a16="http://schemas.microsoft.com/office/drawing/2014/main" id="{56CCB758-897F-A264-75EF-CF69B399080A}"/>
+                <a16:creationId xmlns:a16="http://schemas.microsoft.com/office/drawing/2014/main" id="{BFEAE158-F3F8-86B0-E098-3B7E8BD9C767}"/>
               </a:ext>
             </a:extLst>
           </p:cNvPr>
@@ -2801,7 +2801,7 @@
           <p:cNvPr id="3" name="텍스트 개체 틀 2">
             <a:extLst>
               <a:ext uri="{FF2B5EF4-FFF2-40B4-BE49-F238E27FC236}">
-                <a16:creationId xmlns:a16="http://schemas.microsoft.com/office/drawing/2014/main" id="{1D4EFF31-B807-0DDB-2C1C-CCC88E60C232}"/>
+                <a16:creationId xmlns:a16="http://schemas.microsoft.com/office/drawing/2014/main" id="{C3D68E68-9F11-D70D-9617-9179435B251C}"/>
               </a:ext>
             </a:extLst>
           </p:cNvPr>
@@ -2868,7 +2868,7 @@
           <p:cNvPr id="4" name="날짜 개체 틀 3">
             <a:extLst>
               <a:ext uri="{FF2B5EF4-FFF2-40B4-BE49-F238E27FC236}">
-                <a16:creationId xmlns:a16="http://schemas.microsoft.com/office/drawing/2014/main" id="{AB6A01BC-7F43-2AAC-03DD-BAECA73DD2D6}"/>
+                <a16:creationId xmlns:a16="http://schemas.microsoft.com/office/drawing/2014/main" id="{E1424892-038A-5D2C-C0C3-40E62DDB4880}"/>
               </a:ext>
             </a:extLst>
           </p:cNvPr>
@@ -2902,7 +2902,7 @@
             </a:lvl1pPr>
           </a:lstStyle>
           <a:p>
-            <a:fld id="{BBCE5FCE-C137-4A6E-A349-AF724E9D2612}" type="datetimeFigureOut">
+            <a:fld id="{C56CB09B-924A-4ABE-8F3B-7B27270F5C95}" type="datetimeFigureOut">
               <a:rPr lang="ko-KR" altLang="en-US" smtClean="0"/>
               <a:t>2026-06-21</a:t>
             </a:fld>
@@ -2915,7 +2915,7 @@
           <p:cNvPr id="5" name="바닥글 개체 틀 4">
             <a:extLst>
               <a:ext uri="{FF2B5EF4-FFF2-40B4-BE49-F238E27FC236}">
-                <a16:creationId xmlns:a16="http://schemas.microsoft.com/office/drawing/2014/main" id="{321EB699-0318-4EE1-20C2-4492E05AC3D9}"/>
+                <a16:creationId xmlns:a16="http://schemas.microsoft.com/office/drawing/2014/main" id="{BC2AE701-D41D-BB62-8863-7199856AD450}"/>
               </a:ext>
             </a:extLst>
           </p:cNvPr>
@@ -2958,7 +2958,7 @@
           <p:cNvPr id="6" name="슬라이드 번호 개체 틀 5">
             <a:extLst>
               <a:ext uri="{FF2B5EF4-FFF2-40B4-BE49-F238E27FC236}">
-                <a16:creationId xmlns:a16="http://schemas.microsoft.com/office/drawing/2014/main" id="{BD7F7ADC-5841-7A65-AA44-6E7B99BA58AE}"/>
+                <a16:creationId xmlns:a16="http://schemas.microsoft.com/office/drawing/2014/main" id="{D1A5F3ED-4830-AC1F-7B45-F38B8AE728A2}"/>
               </a:ext>
             </a:extLst>
           </p:cNvPr>
@@ -2992,7 +2992,7 @@
             </a:lvl1pPr>
           </a:lstStyle>
           <a:p>
-            <a:fld id="{2B191F36-BDAF-4756-8918-2B97940F915D}" type="slidenum">
+            <a:fld id="{D3A47458-2532-49EB-9E23-A67CFBCC437C}" type="slidenum">
               <a:rPr lang="ko-KR" altLang="en-US" smtClean="0"/>
               <a:t>‹#›</a:t>
             </a:fld>
@@ -3003,7 +3003,7 @@
     </p:spTree>
     <p:extLst>
       <p:ext uri="{BB962C8B-B14F-4D97-AF65-F5344CB8AC3E}">
-        <p14:creationId xmlns:p14="http://schemas.microsoft.com/office/powerpoint/2010/main" val="3672853671"/>
+        <p14:creationId xmlns:p14="http://schemas.microsoft.com/office/powerpoint/2010/main" val="1491562661"/>
       </p:ext>
     </p:extLst>
   </p:cSld>
@@ -3334,7 +3334,7 @@
           <p:cNvPr id="2" name="직사각형 1">
             <a:extLst>
               <a:ext uri="{FF2B5EF4-FFF2-40B4-BE49-F238E27FC236}">
-                <a16:creationId xmlns:a16="http://schemas.microsoft.com/office/drawing/2014/main" id="{53443336-3667-F881-17F3-FADC968447CB}"/>
+                <a16:creationId xmlns:a16="http://schemas.microsoft.com/office/drawing/2014/main" id="{711B3C41-A907-F256-62D2-F6D76E8D4726}"/>
               </a:ext>
             </a:extLst>
           </p:cNvPr>
@@ -3388,7 +3388,7 @@
           <p:cNvPr id="3" name="직사각형 2">
             <a:extLst>
               <a:ext uri="{FF2B5EF4-FFF2-40B4-BE49-F238E27FC236}">
-                <a16:creationId xmlns:a16="http://schemas.microsoft.com/office/drawing/2014/main" id="{E7103E04-AD48-95EA-0812-4E1670307BEE}"/>
+                <a16:creationId xmlns:a16="http://schemas.microsoft.com/office/drawing/2014/main" id="{7B381BEC-0CE6-8762-D34D-CB1DEBB4A69E}"/>
               </a:ext>
             </a:extLst>
           </p:cNvPr>
@@ -3398,7 +3398,7 @@
         <p:spPr>
           <a:xfrm>
             <a:off x="0" y="0"/>
-            <a:ext cx="670543" cy="6858000"/>
+            <a:ext cx="563866" cy="6858000"/>
           </a:xfrm>
           <a:prstGeom prst="rect">
             <a:avLst/>
@@ -3442,7 +3442,7 @@
           <p:cNvPr id="4" name="직사각형 3">
             <a:extLst>
               <a:ext uri="{FF2B5EF4-FFF2-40B4-BE49-F238E27FC236}">
-                <a16:creationId xmlns:a16="http://schemas.microsoft.com/office/drawing/2014/main" id="{7542932D-5571-F5E2-1546-1A12764B4507}"/>
+                <a16:creationId xmlns:a16="http://schemas.microsoft.com/office/drawing/2014/main" id="{5969F5E2-9E71-D218-ED2F-29461D84770F}"/>
               </a:ext>
             </a:extLst>
           </p:cNvPr>
@@ -3451,8 +3451,8 @@
         </p:nvSpPr>
         <p:spPr>
           <a:xfrm>
-            <a:off x="670543" y="0"/>
-            <a:ext cx="11521152" cy="91440"/>
+            <a:off x="563866" y="0"/>
+            <a:ext cx="11627829" cy="76200"/>
           </a:xfrm>
           <a:prstGeom prst="rect">
             <a:avLst/>
@@ -3493,131 +3493,32 @@
       </p:sp>
       <p:sp>
         <p:nvSpPr>
-          <p:cNvPr id="5" name="TextBox 4">
-            <a:extLst>
-              <a:ext uri="{FF2B5EF4-FFF2-40B4-BE49-F238E27FC236}">
-                <a16:creationId xmlns:a16="http://schemas.microsoft.com/office/drawing/2014/main" id="{9C3E9150-4176-9578-32E6-7E69930B176A}"/>
-              </a:ext>
-            </a:extLst>
-          </p:cNvPr>
-          <p:cNvSpPr txBox="1"/>
+          <p:cNvPr id="5" name="직사각형 4">
+            <a:extLst>
+              <a:ext uri="{FF2B5EF4-FFF2-40B4-BE49-F238E27FC236}">
+                <a16:creationId xmlns:a16="http://schemas.microsoft.com/office/drawing/2014/main" id="{6B8C73BC-0CE2-5FC1-C0E3-A891D424464F}"/>
+              </a:ext>
+            </a:extLst>
+          </p:cNvPr>
+          <p:cNvSpPr/>
           <p:nvPr/>
         </p:nvSpPr>
         <p:spPr>
           <a:xfrm>
-            <a:off x="990575" y="411480"/>
-            <a:ext cx="6248244" cy="369332"/>
+            <a:off x="563866" y="6248400"/>
+            <a:ext cx="11627829" cy="609600"/>
           </a:xfrm>
           <a:prstGeom prst="rect">
             <a:avLst/>
           </a:prstGeom>
-          <a:noFill/>
-        </p:spPr>
-        <p:txBody>
-          <a:bodyPr vert="horz" wrap="square" lIns="0" tIns="0" rIns="0" bIns="0" rtlCol="0" anchor="ctr">
-            <a:noAutofit/>
-          </a:bodyPr>
-          <a:lstStyle/>
-          <a:p>
-            <a:r>
-              <a:rPr lang="en-US" altLang="ko-KR" sz="3600" b="1">
-                <a:solidFill>
-                  <a:srgbClr val="FFFFFF"/>
-                </a:solidFill>
-                <a:latin typeface="Aptos" panose="020B0004020202020204" pitchFamily="34" charset="0"/>
-              </a:rPr>
-              <a:t>MDPR Visual Grammar</a:t>
-            </a:r>
-            <a:endParaRPr lang="ko-KR" altLang="en-US" sz="3600" b="1">
-              <a:solidFill>
-                <a:srgbClr val="FFFFFF"/>
-              </a:solidFill>
-              <a:latin typeface="Aptos" panose="020B0004020202020204" pitchFamily="34" charset="0"/>
-            </a:endParaRPr>
-          </a:p>
-        </p:txBody>
-      </p:sp>
-      <p:sp>
-        <p:nvSpPr>
-          <p:cNvPr id="6" name="TextBox 5">
-            <a:extLst>
-              <a:ext uri="{FF2B5EF4-FFF2-40B4-BE49-F238E27FC236}">
-                <a16:creationId xmlns:a16="http://schemas.microsoft.com/office/drawing/2014/main" id="{9426C290-D3ED-2DFB-A45D-9BB5518292E5}"/>
-              </a:ext>
-            </a:extLst>
-          </p:cNvPr>
-          <p:cNvSpPr txBox="1"/>
-          <p:nvPr/>
-        </p:nvSpPr>
-        <p:spPr>
-          <a:xfrm>
-            <a:off x="1021054" y="944880"/>
-            <a:ext cx="7467413" cy="369332"/>
-          </a:xfrm>
-          <a:prstGeom prst="rect">
-            <a:avLst/>
-          </a:prstGeom>
-          <a:noFill/>
-        </p:spPr>
-        <p:txBody>
-          <a:bodyPr vert="horz" wrap="square" lIns="0" tIns="0" rIns="0" bIns="0" rtlCol="0" anchor="ctr">
-            <a:noAutofit/>
-          </a:bodyPr>
-          <a:lstStyle/>
-          <a:p>
-            <a:r>
-              <a:rPr lang="en-US" altLang="ko-KR" sz="1512">
-                <a:solidFill>
-                  <a:srgbClr val="CBD5E1"/>
-                </a:solidFill>
-                <a:latin typeface="Aptos" panose="020B0004020202020204" pitchFamily="34" charset="0"/>
-              </a:rPr>
-              <a:t>PPTX-first themes, layout compositions, proof objects, and visual QA generated from actual MDPR outputs.</a:t>
-            </a:r>
-            <a:endParaRPr lang="ko-KR" altLang="en-US" sz="1512">
-              <a:solidFill>
-                <a:srgbClr val="CBD5E1"/>
-              </a:solidFill>
-              <a:latin typeface="Aptos" panose="020B0004020202020204" pitchFamily="34" charset="0"/>
-            </a:endParaRPr>
-          </a:p>
-        </p:txBody>
-      </p:sp>
-      <p:sp>
-        <p:nvSpPr>
-          <p:cNvPr id="7" name="사각형: 둥근 모서리 6">
-            <a:extLst>
-              <a:ext uri="{FF2B5EF4-FFF2-40B4-BE49-F238E27FC236}">
-                <a16:creationId xmlns:a16="http://schemas.microsoft.com/office/drawing/2014/main" id="{39684400-8551-854E-208C-8F3E9778E1F8}"/>
-              </a:ext>
-            </a:extLst>
-          </p:cNvPr>
-          <p:cNvSpPr/>
-          <p:nvPr/>
-        </p:nvSpPr>
-        <p:spPr>
-          <a:xfrm>
-            <a:off x="8610385" y="365760"/>
-            <a:ext cx="1203929" cy="792480"/>
-          </a:xfrm>
-          <a:prstGeom prst="roundRect">
-            <a:avLst/>
-          </a:prstGeom>
           <a:solidFill>
-            <a:srgbClr val="FFFFFF"/>
+            <a:srgbClr val="0C1320"/>
           </a:solidFill>
-          <a:ln w="15240">
+          <a:ln w="10668">
             <a:solidFill>
-              <a:srgbClr val="14B8A6"/>
+              <a:srgbClr val="0C1320"/>
             </a:solidFill>
           </a:ln>
-          <a:effectLst>
-            <a:outerShdw blurRad="38100" dist="28988" dir="3671352" rotWithShape="0">
-              <a:scrgbClr r="0" g="0" b="0">
-                <a:alpha val="14000"/>
-              </a:scrgbClr>
-            </a:outerShdw>
-          </a:effectLst>
         </p:spPr>
         <p:style>
           <a:lnRef idx="2">
@@ -3646,10 +3547,10 @@
       </p:sp>
       <p:sp>
         <p:nvSpPr>
-          <p:cNvPr id="8" name="TextBox 7">
-            <a:extLst>
-              <a:ext uri="{FF2B5EF4-FFF2-40B4-BE49-F238E27FC236}">
-                <a16:creationId xmlns:a16="http://schemas.microsoft.com/office/drawing/2014/main" id="{D173B438-671B-BA84-F5B8-5577FA11BCB7}"/>
+          <p:cNvPr id="6" name="TextBox 5">
+            <a:extLst>
+              <a:ext uri="{FF2B5EF4-FFF2-40B4-BE49-F238E27FC236}">
+                <a16:creationId xmlns:a16="http://schemas.microsoft.com/office/drawing/2014/main" id="{AC182E3A-6B7C-911F-A2DD-385EB9D4561A}"/>
               </a:ext>
             </a:extLst>
           </p:cNvPr>
@@ -3658,8 +3559,8 @@
         </p:nvSpPr>
         <p:spPr>
           <a:xfrm>
-            <a:off x="8747541" y="487680"/>
-            <a:ext cx="929617" cy="369332"/>
+            <a:off x="944856" y="441960"/>
+            <a:ext cx="6400640" cy="369332"/>
           </a:xfrm>
           <a:prstGeom prst="rect">
             <a:avLst/>
@@ -3672,19 +3573,18 @@
           </a:bodyPr>
           <a:lstStyle/>
           <a:p>
-            <a:pPr algn="ctr"/>
-            <a:r>
-              <a:rPr lang="en-US" altLang="ko-KR" sz="2448" b="1">
+            <a:r>
+              <a:rPr lang="en-US" altLang="ko-KR" sz="3312" b="1">
                 <a:solidFill>
-                  <a:srgbClr val="14B8A6"/>
+                  <a:srgbClr val="FFFFFF"/>
                 </a:solidFill>
                 <a:latin typeface="Aptos" panose="020B0004020202020204" pitchFamily="34" charset="0"/>
               </a:rPr>
-              <a:t>10</a:t>
-            </a:r>
-            <a:endParaRPr lang="ko-KR" altLang="en-US" sz="2448" b="1">
+              <a:t>Markdown to editable PowerPoint</a:t>
+            </a:r>
+            <a:endParaRPr lang="ko-KR" altLang="en-US" sz="3312" b="1">
               <a:solidFill>
-                <a:srgbClr val="14B8A6"/>
+                <a:srgbClr val="FFFFFF"/>
               </a:solidFill>
               <a:latin typeface="Aptos" panose="020B0004020202020204" pitchFamily="34" charset="0"/>
             </a:endParaRPr>
@@ -3693,10 +3593,10 @@
       </p:sp>
       <p:sp>
         <p:nvSpPr>
-          <p:cNvPr id="9" name="TextBox 8">
-            <a:extLst>
-              <a:ext uri="{FF2B5EF4-FFF2-40B4-BE49-F238E27FC236}">
-                <a16:creationId xmlns:a16="http://schemas.microsoft.com/office/drawing/2014/main" id="{DBC71E5F-FAB2-9C37-722C-CCCBD9D35CC7}"/>
+          <p:cNvPr id="7" name="TextBox 6">
+            <a:extLst>
+              <a:ext uri="{FF2B5EF4-FFF2-40B4-BE49-F238E27FC236}">
+                <a16:creationId xmlns:a16="http://schemas.microsoft.com/office/drawing/2014/main" id="{62AD3262-E8DD-89AA-4673-DD915614FEDB}"/>
               </a:ext>
             </a:extLst>
           </p:cNvPr>
@@ -3705,8 +3605,8 @@
         </p:nvSpPr>
         <p:spPr>
           <a:xfrm>
-            <a:off x="8747541" y="830580"/>
-            <a:ext cx="929617" cy="369332"/>
+            <a:off x="960096" y="944880"/>
+            <a:ext cx="6019650" cy="369332"/>
           </a:xfrm>
           <a:prstGeom prst="rect">
             <a:avLst/>
@@ -3714,24 +3614,23 @@
           <a:noFill/>
         </p:spPr>
         <p:txBody>
-          <a:bodyPr vert="horz" wrap="square" lIns="0" tIns="0" rIns="0" bIns="0" rtlCol="0" anchor="ctr">
+          <a:bodyPr vert="horz" wrap="square" lIns="0" tIns="0" rIns="0" bIns="0" rtlCol="0" anchor="t">
             <a:noAutofit/>
           </a:bodyPr>
           <a:lstStyle/>
           <a:p>
-            <a:pPr algn="ctr"/>
-            <a:r>
-              <a:rPr lang="en-US" altLang="ko-KR" sz="1080" b="1">
+            <a:r>
+              <a:rPr lang="en-US" altLang="ko-KR" sz="1440">
                 <a:solidFill>
-                  <a:srgbClr val="64748B"/>
+                  <a:srgbClr val="CBD5E1"/>
                 </a:solidFill>
                 <a:latin typeface="Aptos" panose="020B0004020202020204" pitchFamily="34" charset="0"/>
               </a:rPr>
-              <a:t>theme styles</a:t>
-            </a:r>
-            <a:endParaRPr lang="ko-KR" altLang="en-US" sz="1080" b="1">
+              <a:t>MDPR uses rule-based layouts, theme colors, proof objects, tables, charts, and visual QA generated from actual PPTX outputs.</a:t>
+            </a:r>
+            <a:endParaRPr lang="ko-KR" altLang="en-US" sz="1440">
               <a:solidFill>
-                <a:srgbClr val="64748B"/>
+                <a:srgbClr val="CBD5E1"/>
               </a:solidFill>
               <a:latin typeface="Aptos" panose="020B0004020202020204" pitchFamily="34" charset="0"/>
             </a:endParaRPr>
@@ -3740,10 +3639,10 @@
       </p:sp>
       <p:sp>
         <p:nvSpPr>
-          <p:cNvPr id="10" name="사각형: 둥근 모서리 9">
-            <a:extLst>
-              <a:ext uri="{FF2B5EF4-FFF2-40B4-BE49-F238E27FC236}">
-                <a16:creationId xmlns:a16="http://schemas.microsoft.com/office/drawing/2014/main" id="{010DBF04-CB6E-C8DF-2C6E-2A2661B09CE1}"/>
+          <p:cNvPr id="8" name="직사각형 7">
+            <a:extLst>
+              <a:ext uri="{FF2B5EF4-FFF2-40B4-BE49-F238E27FC236}">
+                <a16:creationId xmlns:a16="http://schemas.microsoft.com/office/drawing/2014/main" id="{31729B58-F11C-4B97-00DF-53F97B642C36}"/>
               </a:ext>
             </a:extLst>
           </p:cNvPr>
@@ -3752,27 +3651,20 @@
         </p:nvSpPr>
         <p:spPr>
           <a:xfrm>
-            <a:off x="9951471" y="365760"/>
-            <a:ext cx="1203929" cy="792480"/>
-          </a:xfrm>
-          <a:prstGeom prst="roundRect">
+            <a:off x="960096" y="1493520"/>
+            <a:ext cx="1371566" cy="45720"/>
+          </a:xfrm>
+          <a:prstGeom prst="rect">
             <a:avLst/>
           </a:prstGeom>
           <a:solidFill>
-            <a:srgbClr val="FFFFFF"/>
+            <a:srgbClr val="14B8A6"/>
           </a:solidFill>
-          <a:ln w="15240">
+          <a:ln w="10668">
             <a:solidFill>
-              <a:srgbClr val="E9B44C"/>
+              <a:srgbClr val="14B8A6"/>
             </a:solidFill>
           </a:ln>
-          <a:effectLst>
-            <a:outerShdw blurRad="38100" dist="28988" dir="3671352" rotWithShape="0">
-              <a:scrgbClr r="0" g="0" b="0">
-                <a:alpha val="14000"/>
-              </a:scrgbClr>
-            </a:outerShdw>
-          </a:effectLst>
         </p:spPr>
         <p:style>
           <a:lnRef idx="2">
@@ -3801,104 +3693,10 @@
       </p:sp>
       <p:sp>
         <p:nvSpPr>
-          <p:cNvPr id="11" name="TextBox 10">
-            <a:extLst>
-              <a:ext uri="{FF2B5EF4-FFF2-40B4-BE49-F238E27FC236}">
-                <a16:creationId xmlns:a16="http://schemas.microsoft.com/office/drawing/2014/main" id="{3D56783E-BD12-C650-B0C2-C50A9A7D6FDF}"/>
-              </a:ext>
-            </a:extLst>
-          </p:cNvPr>
-          <p:cNvSpPr txBox="1"/>
-          <p:nvPr/>
-        </p:nvSpPr>
-        <p:spPr>
-          <a:xfrm>
-            <a:off x="10088628" y="487680"/>
-            <a:ext cx="929617" cy="369332"/>
-          </a:xfrm>
-          <a:prstGeom prst="rect">
-            <a:avLst/>
-          </a:prstGeom>
-          <a:noFill/>
-        </p:spPr>
-        <p:txBody>
-          <a:bodyPr vert="horz" wrap="square" lIns="0" tIns="0" rIns="0" bIns="0" rtlCol="0" anchor="ctr">
-            <a:noAutofit/>
-          </a:bodyPr>
-          <a:lstStyle/>
-          <a:p>
-            <a:pPr algn="ctr"/>
-            <a:r>
-              <a:rPr lang="en-US" altLang="ko-KR" sz="2448" b="1">
-                <a:solidFill>
-                  <a:srgbClr val="E9B44C"/>
-                </a:solidFill>
-                <a:latin typeface="Aptos" panose="020B0004020202020204" pitchFamily="34" charset="0"/>
-              </a:rPr>
-              <a:t>10</a:t>
-            </a:r>
-            <a:endParaRPr lang="ko-KR" altLang="en-US" sz="2448" b="1">
-              <a:solidFill>
-                <a:srgbClr val="E9B44C"/>
-              </a:solidFill>
-              <a:latin typeface="Aptos" panose="020B0004020202020204" pitchFamily="34" charset="0"/>
-            </a:endParaRPr>
-          </a:p>
-        </p:txBody>
-      </p:sp>
-      <p:sp>
-        <p:nvSpPr>
-          <p:cNvPr id="12" name="TextBox 11">
-            <a:extLst>
-              <a:ext uri="{FF2B5EF4-FFF2-40B4-BE49-F238E27FC236}">
-                <a16:creationId xmlns:a16="http://schemas.microsoft.com/office/drawing/2014/main" id="{D6C7ED44-4095-8622-84A0-E67E796AB535}"/>
-              </a:ext>
-            </a:extLst>
-          </p:cNvPr>
-          <p:cNvSpPr txBox="1"/>
-          <p:nvPr/>
-        </p:nvSpPr>
-        <p:spPr>
-          <a:xfrm>
-            <a:off x="10088628" y="830580"/>
-            <a:ext cx="929617" cy="369332"/>
-          </a:xfrm>
-          <a:prstGeom prst="rect">
-            <a:avLst/>
-          </a:prstGeom>
-          <a:noFill/>
-        </p:spPr>
-        <p:txBody>
-          <a:bodyPr vert="horz" wrap="square" lIns="0" tIns="0" rIns="0" bIns="0" rtlCol="0" anchor="ctr">
-            <a:noAutofit/>
-          </a:bodyPr>
-          <a:lstStyle/>
-          <a:p>
-            <a:pPr algn="ctr"/>
-            <a:r>
-              <a:rPr lang="en-US" altLang="ko-KR" sz="1080" b="1">
-                <a:solidFill>
-                  <a:srgbClr val="64748B"/>
-                </a:solidFill>
-                <a:latin typeface="Aptos" panose="020B0004020202020204" pitchFamily="34" charset="0"/>
-              </a:rPr>
-              <a:t>layouts</a:t>
-            </a:r>
-            <a:endParaRPr lang="ko-KR" altLang="en-US" sz="1080" b="1">
-              <a:solidFill>
-                <a:srgbClr val="64748B"/>
-              </a:solidFill>
-              <a:latin typeface="Aptos" panose="020B0004020202020204" pitchFamily="34" charset="0"/>
-            </a:endParaRPr>
-          </a:p>
-        </p:txBody>
-      </p:sp>
-      <p:sp>
-        <p:nvSpPr>
-          <p:cNvPr id="13" name="사각형: 둥근 모서리 12">
-            <a:extLst>
-              <a:ext uri="{FF2B5EF4-FFF2-40B4-BE49-F238E27FC236}">
-                <a16:creationId xmlns:a16="http://schemas.microsoft.com/office/drawing/2014/main" id="{4093D14F-7DCC-A35B-BC6D-2C74AA2AC467}"/>
+          <p:cNvPr id="9" name="사각형: 둥근 모서리 8">
+            <a:extLst>
+              <a:ext uri="{FF2B5EF4-FFF2-40B4-BE49-F238E27FC236}">
+                <a16:creationId xmlns:a16="http://schemas.microsoft.com/office/drawing/2014/main" id="{41534417-D4A2-6BB9-1177-D17235B1F4FA}"/>
               </a:ext>
             </a:extLst>
           </p:cNvPr>
@@ -3907,8 +3705,8 @@
         </p:nvSpPr>
         <p:spPr>
           <a:xfrm>
-            <a:off x="8610385" y="1295400"/>
-            <a:ext cx="1203929" cy="792480"/>
+            <a:off x="960096" y="1844040"/>
+            <a:ext cx="6034889" cy="3398520"/>
           </a:xfrm>
           <a:prstGeom prst="roundRect">
             <a:avLst/>
@@ -3916,9 +3714,9 @@
           <a:solidFill>
             <a:srgbClr val="FFFFFF"/>
           </a:solidFill>
-          <a:ln w="15240">
+          <a:ln w="9906">
             <a:solidFill>
-              <a:srgbClr val="8B7CF6"/>
+              <a:srgbClr val="334155"/>
             </a:solidFill>
           </a:ln>
           <a:effectLst>
@@ -3954,106 +3752,48 @@
           </a:p>
         </p:txBody>
       </p:sp>
-      <p:sp>
-        <p:nvSpPr>
-          <p:cNvPr id="14" name="TextBox 13">
-            <a:extLst>
-              <a:ext uri="{FF2B5EF4-FFF2-40B4-BE49-F238E27FC236}">
-                <a16:creationId xmlns:a16="http://schemas.microsoft.com/office/drawing/2014/main" id="{6B599E94-D59E-A1FC-57CD-6E464E72EBDB}"/>
-              </a:ext>
-            </a:extLst>
-          </p:cNvPr>
-          <p:cNvSpPr txBox="1"/>
+      <p:pic>
+        <p:nvPicPr>
+          <p:cNvPr id="11" name="그림 10">
+            <a:extLst>
+              <a:ext uri="{FF2B5EF4-FFF2-40B4-BE49-F238E27FC236}">
+                <a16:creationId xmlns:a16="http://schemas.microsoft.com/office/drawing/2014/main" id="{258ECB5F-3520-318D-5B98-37C1C195520C}"/>
+              </a:ext>
+            </a:extLst>
+          </p:cNvPr>
+          <p:cNvPicPr>
+            <a:picLocks/>
+          </p:cNvPicPr>
           <p:nvPr/>
-        </p:nvSpPr>
-        <p:spPr>
-          <a:xfrm>
-            <a:off x="8747541" y="1417320"/>
-            <a:ext cx="929617" cy="369332"/>
+        </p:nvPicPr>
+        <p:blipFill>
+          <a:blip r:embed="rId2">
+            <a:extLst>
+              <a:ext uri="{28A0092B-C50C-407E-A947-70E740481C1C}">
+                <a14:useLocalDpi xmlns:a14="http://schemas.microsoft.com/office/drawing/2010/main" val="0"/>
+              </a:ext>
+            </a:extLst>
+          </a:blip>
+          <a:stretch>
+            <a:fillRect/>
+          </a:stretch>
+        </p:blipFill>
+        <p:spPr>
+          <a:xfrm>
+            <a:off x="1097253" y="1996440"/>
+            <a:ext cx="5760576" cy="2941320"/>
           </a:xfrm>
           <a:prstGeom prst="rect">
             <a:avLst/>
           </a:prstGeom>
-          <a:noFill/>
-        </p:spPr>
-        <p:txBody>
-          <a:bodyPr vert="horz" wrap="square" lIns="0" tIns="0" rIns="0" bIns="0" rtlCol="0" anchor="ctr">
-            <a:noAutofit/>
-          </a:bodyPr>
-          <a:lstStyle/>
-          <a:p>
-            <a:pPr algn="ctr"/>
-            <a:r>
-              <a:rPr lang="en-US" altLang="ko-KR" sz="2448" b="1">
-                <a:solidFill>
-                  <a:srgbClr val="8B7CF6"/>
-                </a:solidFill>
-                <a:latin typeface="Aptos" panose="020B0004020202020204" pitchFamily="34" charset="0"/>
-              </a:rPr>
-              <a:t>10</a:t>
-            </a:r>
-            <a:endParaRPr lang="ko-KR" altLang="en-US" sz="2448" b="1">
-              <a:solidFill>
-                <a:srgbClr val="8B7CF6"/>
-              </a:solidFill>
-              <a:latin typeface="Aptos" panose="020B0004020202020204" pitchFamily="34" charset="0"/>
-            </a:endParaRPr>
-          </a:p>
-        </p:txBody>
-      </p:sp>
-      <p:sp>
-        <p:nvSpPr>
-          <p:cNvPr id="15" name="TextBox 14">
-            <a:extLst>
-              <a:ext uri="{FF2B5EF4-FFF2-40B4-BE49-F238E27FC236}">
-                <a16:creationId xmlns:a16="http://schemas.microsoft.com/office/drawing/2014/main" id="{69DD650B-452F-A8EF-A76E-10A64DEE0A6D}"/>
-              </a:ext>
-            </a:extLst>
-          </p:cNvPr>
-          <p:cNvSpPr txBox="1"/>
-          <p:nvPr/>
-        </p:nvSpPr>
-        <p:spPr>
-          <a:xfrm>
-            <a:off x="8747541" y="1760220"/>
-            <a:ext cx="929617" cy="369332"/>
-          </a:xfrm>
-          <a:prstGeom prst="rect">
-            <a:avLst/>
-          </a:prstGeom>
-          <a:noFill/>
-        </p:spPr>
-        <p:txBody>
-          <a:bodyPr vert="horz" wrap="square" lIns="0" tIns="0" rIns="0" bIns="0" rtlCol="0" anchor="ctr">
-            <a:noAutofit/>
-          </a:bodyPr>
-          <a:lstStyle/>
-          <a:p>
-            <a:pPr algn="ctr"/>
-            <a:r>
-              <a:rPr lang="en-US" altLang="ko-KR" sz="1080" b="1">
-                <a:solidFill>
-                  <a:srgbClr val="64748B"/>
-                </a:solidFill>
-                <a:latin typeface="Aptos" panose="020B0004020202020204" pitchFamily="34" charset="0"/>
-              </a:rPr>
-              <a:t>object forms</a:t>
-            </a:r>
-            <a:endParaRPr lang="ko-KR" altLang="en-US" sz="1080" b="1">
-              <a:solidFill>
-                <a:srgbClr val="64748B"/>
-              </a:solidFill>
-              <a:latin typeface="Aptos" panose="020B0004020202020204" pitchFamily="34" charset="0"/>
-            </a:endParaRPr>
-          </a:p>
-        </p:txBody>
-      </p:sp>
-      <p:sp>
-        <p:nvSpPr>
-          <p:cNvPr id="16" name="사각형: 둥근 모서리 15">
-            <a:extLst>
-              <a:ext uri="{FF2B5EF4-FFF2-40B4-BE49-F238E27FC236}">
-                <a16:creationId xmlns:a16="http://schemas.microsoft.com/office/drawing/2014/main" id="{30DE012C-A0F9-BC56-B128-A32D707BF060}"/>
+        </p:spPr>
+      </p:pic>
+      <p:sp>
+        <p:nvSpPr>
+          <p:cNvPr id="12" name="직사각형 11">
+            <a:extLst>
+              <a:ext uri="{FF2B5EF4-FFF2-40B4-BE49-F238E27FC236}">
+                <a16:creationId xmlns:a16="http://schemas.microsoft.com/office/drawing/2014/main" id="{B838E032-9FE9-F68B-36AB-6102B120A035}"/>
               </a:ext>
             </a:extLst>
           </p:cNvPr>
@@ -4062,27 +3802,20 @@
         </p:nvSpPr>
         <p:spPr>
           <a:xfrm>
-            <a:off x="9951471" y="1295400"/>
-            <a:ext cx="1203929" cy="792480"/>
-          </a:xfrm>
-          <a:prstGeom prst="roundRect">
+            <a:off x="1097253" y="4937760"/>
+            <a:ext cx="5760576" cy="304800"/>
+          </a:xfrm>
+          <a:prstGeom prst="rect">
             <a:avLst/>
           </a:prstGeom>
           <a:solidFill>
             <a:srgbClr val="FFFFFF"/>
           </a:solidFill>
-          <a:ln w="15240">
+          <a:ln w="6350">
             <a:solidFill>
-              <a:srgbClr val="BE123C"/>
+              <a:srgbClr val="FFFFFF"/>
             </a:solidFill>
           </a:ln>
-          <a:effectLst>
-            <a:outerShdw blurRad="38100" dist="28988" dir="3671352" rotWithShape="0">
-              <a:scrgbClr r="0" g="0" b="0">
-                <a:alpha val="14000"/>
-              </a:scrgbClr>
-            </a:outerShdw>
-          </a:effectLst>
         </p:spPr>
         <p:style>
           <a:lnRef idx="2">
@@ -4111,10 +3844,10 @@
       </p:sp>
       <p:sp>
         <p:nvSpPr>
-          <p:cNvPr id="17" name="TextBox 16">
-            <a:extLst>
-              <a:ext uri="{FF2B5EF4-FFF2-40B4-BE49-F238E27FC236}">
-                <a16:creationId xmlns:a16="http://schemas.microsoft.com/office/drawing/2014/main" id="{BF3F91C0-07FC-9101-C94C-F3B76CF7932D}"/>
+          <p:cNvPr id="13" name="TextBox 12">
+            <a:extLst>
+              <a:ext uri="{FF2B5EF4-FFF2-40B4-BE49-F238E27FC236}">
+                <a16:creationId xmlns:a16="http://schemas.microsoft.com/office/drawing/2014/main" id="{E8C0221C-9710-4321-4B1F-2C9DFAAB9BC0}"/>
               </a:ext>
             </a:extLst>
           </p:cNvPr>
@@ -4123,8 +3856,8 @@
         </p:nvSpPr>
         <p:spPr>
           <a:xfrm>
-            <a:off x="10088628" y="1417320"/>
-            <a:ext cx="929617" cy="369332"/>
+            <a:off x="1249649" y="5006340"/>
+            <a:ext cx="1371566" cy="369332"/>
           </a:xfrm>
           <a:prstGeom prst="rect">
             <a:avLst/>
@@ -4137,19 +3870,18 @@
           </a:bodyPr>
           <a:lstStyle/>
           <a:p>
-            <a:pPr algn="ctr"/>
-            <a:r>
-              <a:rPr lang="en-US" altLang="ko-KR" sz="2448" b="1">
+            <a:r>
+              <a:rPr lang="en-US" altLang="ko-KR" sz="1008" b="1">
                 <a:solidFill>
-                  <a:srgbClr val="BE123C"/>
+                  <a:srgbClr val="111827"/>
                 </a:solidFill>
                 <a:latin typeface="Aptos" panose="020B0004020202020204" pitchFamily="34" charset="0"/>
               </a:rPr>
-              <a:t>190</a:t>
-            </a:r>
-            <a:endParaRPr lang="ko-KR" altLang="en-US" sz="2448" b="1">
+              <a:t>data</a:t>
+            </a:r>
+            <a:endParaRPr lang="ko-KR" altLang="en-US" sz="1008" b="1">
               <a:solidFill>
-                <a:srgbClr val="BE123C"/>
+                <a:srgbClr val="111827"/>
               </a:solidFill>
               <a:latin typeface="Aptos" panose="020B0004020202020204" pitchFamily="34" charset="0"/>
             </a:endParaRPr>
@@ -4158,10 +3890,10 @@
       </p:sp>
       <p:sp>
         <p:nvSpPr>
-          <p:cNvPr id="18" name="TextBox 17">
-            <a:extLst>
-              <a:ext uri="{FF2B5EF4-FFF2-40B4-BE49-F238E27FC236}">
-                <a16:creationId xmlns:a16="http://schemas.microsoft.com/office/drawing/2014/main" id="{7221744E-67BA-6889-840E-A6E1D8B2D6F6}"/>
+          <p:cNvPr id="14" name="TextBox 13">
+            <a:extLst>
+              <a:ext uri="{FF2B5EF4-FFF2-40B4-BE49-F238E27FC236}">
+                <a16:creationId xmlns:a16="http://schemas.microsoft.com/office/drawing/2014/main" id="{29B5FF15-CE4C-C5C2-4D5B-564A1DD238F4}"/>
               </a:ext>
             </a:extLst>
           </p:cNvPr>
@@ -4170,8 +3902,8 @@
         </p:nvSpPr>
         <p:spPr>
           <a:xfrm>
-            <a:off x="10088628" y="1760220"/>
-            <a:ext cx="929617" cy="369332"/>
+            <a:off x="2666933" y="5006340"/>
+            <a:ext cx="3962301" cy="369332"/>
           </a:xfrm>
           <a:prstGeom prst="rect">
             <a:avLst/>
@@ -4184,17 +3916,16 @@
           </a:bodyPr>
           <a:lstStyle/>
           <a:p>
-            <a:pPr algn="ctr"/>
-            <a:r>
-              <a:rPr lang="en-US" altLang="ko-KR" sz="1080" b="1">
+            <a:r>
+              <a:rPr lang="en-US" altLang="ko-KR" sz="936">
                 <a:solidFill>
                   <a:srgbClr val="64748B"/>
                 </a:solidFill>
                 <a:latin typeface="Aptos" panose="020B0004020202020204" pitchFamily="34" charset="0"/>
               </a:rPr>
-              <a:t>PPT PNGs</a:t>
-            </a:r>
-            <a:endParaRPr lang="ko-KR" altLang="en-US" sz="1080" b="1">
+              <a:t>Chart + table: chart and table stay editable, aligned, and theme-bound</a:t>
+            </a:r>
+            <a:endParaRPr lang="ko-KR" altLang="en-US" sz="936">
               <a:solidFill>
                 <a:srgbClr val="64748B"/>
               </a:solidFill>
@@ -4205,10 +3936,10 @@
       </p:sp>
       <p:sp>
         <p:nvSpPr>
-          <p:cNvPr id="19" name="사각형: 둥근 모서리 18">
-            <a:extLst>
-              <a:ext uri="{FF2B5EF4-FFF2-40B4-BE49-F238E27FC236}">
-                <a16:creationId xmlns:a16="http://schemas.microsoft.com/office/drawing/2014/main" id="{BAF260C7-7490-4266-3ED3-FDA6EF5D6035}"/>
+          <p:cNvPr id="15" name="사각형: 둥근 모서리 14">
+            <a:extLst>
+              <a:ext uri="{FF2B5EF4-FFF2-40B4-BE49-F238E27FC236}">
+                <a16:creationId xmlns:a16="http://schemas.microsoft.com/office/drawing/2014/main" id="{208DE5C4-675D-0F49-6715-855A2D4DC246}"/>
               </a:ext>
             </a:extLst>
           </p:cNvPr>
@@ -4217,14 +3948,14 @@
         </p:nvSpPr>
         <p:spPr>
           <a:xfrm>
-            <a:off x="914377" y="1600200"/>
-            <a:ext cx="3886103" cy="2377440"/>
+            <a:off x="7452174" y="441960"/>
+            <a:ext cx="3703227" cy="1844040"/>
           </a:xfrm>
           <a:prstGeom prst="roundRect">
             <a:avLst/>
           </a:prstGeom>
           <a:solidFill>
-            <a:srgbClr val="FFFFFF"/>
+            <a:srgbClr val="17213A"/>
           </a:solidFill>
           <a:ln w="9144">
             <a:solidFill>
@@ -4264,48 +3995,58 @@
           </a:p>
         </p:txBody>
       </p:sp>
-      <p:pic>
-        <p:nvPicPr>
-          <p:cNvPr id="21" name="그림 20">
-            <a:extLst>
-              <a:ext uri="{FF2B5EF4-FFF2-40B4-BE49-F238E27FC236}">
-                <a16:creationId xmlns:a16="http://schemas.microsoft.com/office/drawing/2014/main" id="{0CFCE513-8753-828B-CD32-18E0CBE70464}"/>
-              </a:ext>
-            </a:extLst>
-          </p:cNvPr>
-          <p:cNvPicPr>
-            <a:picLocks/>
-          </p:cNvPicPr>
+      <p:sp>
+        <p:nvSpPr>
+          <p:cNvPr id="16" name="TextBox 15">
+            <a:extLst>
+              <a:ext uri="{FF2B5EF4-FFF2-40B4-BE49-F238E27FC236}">
+                <a16:creationId xmlns:a16="http://schemas.microsoft.com/office/drawing/2014/main" id="{031634A5-97EB-F071-C9F2-E7984FBD8A87}"/>
+              </a:ext>
+            </a:extLst>
+          </p:cNvPr>
+          <p:cNvSpPr txBox="1"/>
           <p:nvPr/>
-        </p:nvPicPr>
-        <p:blipFill>
-          <a:blip r:embed="rId2">
-            <a:extLst>
-              <a:ext uri="{28A0092B-C50C-407E-A947-70E740481C1C}">
-                <a14:useLocalDpi xmlns:a14="http://schemas.microsoft.com/office/drawing/2010/main" val="0"/>
-              </a:ext>
-            </a:extLst>
-          </a:blip>
-          <a:stretch>
-            <a:fillRect/>
-          </a:stretch>
-        </p:blipFill>
-        <p:spPr>
-          <a:xfrm>
-            <a:off x="990575" y="1676400"/>
-            <a:ext cx="3733707" cy="1981200"/>
+        </p:nvSpPr>
+        <p:spPr>
+          <a:xfrm>
+            <a:off x="7726487" y="670560"/>
+            <a:ext cx="3017445" cy="369332"/>
           </a:xfrm>
           <a:prstGeom prst="rect">
             <a:avLst/>
           </a:prstGeom>
-        </p:spPr>
-      </p:pic>
-      <p:sp>
-        <p:nvSpPr>
-          <p:cNvPr id="22" name="직사각형 21">
-            <a:extLst>
-              <a:ext uri="{FF2B5EF4-FFF2-40B4-BE49-F238E27FC236}">
-                <a16:creationId xmlns:a16="http://schemas.microsoft.com/office/drawing/2014/main" id="{A0504BC4-893B-A117-3E56-496C557CAB47}"/>
+          <a:noFill/>
+        </p:spPr>
+        <p:txBody>
+          <a:bodyPr vert="horz" wrap="square" lIns="0" tIns="0" rIns="0" bIns="0" rtlCol="0" anchor="ctr">
+            <a:noAutofit/>
+          </a:bodyPr>
+          <a:lstStyle/>
+          <a:p>
+            <a:r>
+              <a:rPr lang="en-US" altLang="ko-KR" b="1">
+                <a:solidFill>
+                  <a:srgbClr val="FFFFFF"/>
+                </a:solidFill>
+                <a:latin typeface="Aptos" panose="020B0004020202020204" pitchFamily="34" charset="0"/>
+              </a:rPr>
+              <a:t>What is covered</a:t>
+            </a:r>
+            <a:endParaRPr lang="ko-KR" altLang="en-US" b="1">
+              <a:solidFill>
+                <a:srgbClr val="FFFFFF"/>
+              </a:solidFill>
+              <a:latin typeface="Aptos" panose="020B0004020202020204" pitchFamily="34" charset="0"/>
+            </a:endParaRPr>
+          </a:p>
+        </p:txBody>
+      </p:sp>
+      <p:sp>
+        <p:nvSpPr>
+          <p:cNvPr id="17" name="타원 16">
+            <a:extLst>
+              <a:ext uri="{FF2B5EF4-FFF2-40B4-BE49-F238E27FC236}">
+                <a16:creationId xmlns:a16="http://schemas.microsoft.com/office/drawing/2014/main" id="{72E05CD1-B59D-66BC-EC10-7393D88A8D3D}"/>
               </a:ext>
             </a:extLst>
           </p:cNvPr>
@@ -4314,16 +4055,16 @@
         </p:nvSpPr>
         <p:spPr>
           <a:xfrm>
-            <a:off x="990575" y="3657600"/>
-            <a:ext cx="3733707" cy="289560"/>
-          </a:xfrm>
-          <a:prstGeom prst="rect">
+            <a:off x="7680768" y="1097280"/>
+            <a:ext cx="152396" cy="152400"/>
+          </a:xfrm>
+          <a:prstGeom prst="ellipse">
             <a:avLst/>
           </a:prstGeom>
           <a:solidFill>
-            <a:srgbClr val="FFFFFF"/>
+            <a:srgbClr val="14B8A6"/>
           </a:solidFill>
-          <a:ln w="6350">
+          <a:ln w="7620">
             <a:solidFill>
               <a:srgbClr val="FFFFFF"/>
             </a:solidFill>
@@ -4356,10 +4097,10 @@
       </p:sp>
       <p:sp>
         <p:nvSpPr>
-          <p:cNvPr id="23" name="TextBox 22">
-            <a:extLst>
-              <a:ext uri="{FF2B5EF4-FFF2-40B4-BE49-F238E27FC236}">
-                <a16:creationId xmlns:a16="http://schemas.microsoft.com/office/drawing/2014/main" id="{C4E141D6-7D1E-F1F8-BB1D-1DEA19FD4AFD}"/>
+          <p:cNvPr id="18" name="TextBox 17">
+            <a:extLst>
+              <a:ext uri="{FF2B5EF4-FFF2-40B4-BE49-F238E27FC236}">
+                <a16:creationId xmlns:a16="http://schemas.microsoft.com/office/drawing/2014/main" id="{1FDD2A65-A9C1-DB60-631A-6BE6261651D2}"/>
               </a:ext>
             </a:extLst>
           </p:cNvPr>
@@ -4368,8 +4109,8 @@
         </p:nvSpPr>
         <p:spPr>
           <a:xfrm>
-            <a:off x="1127732" y="3718560"/>
-            <a:ext cx="1219169" cy="369332"/>
+            <a:off x="7924602" y="1082040"/>
+            <a:ext cx="990575" cy="369332"/>
           </a:xfrm>
           <a:prstGeom prst="rect">
             <a:avLst/>
@@ -4383,17 +4124,17 @@
           <a:lstStyle/>
           <a:p>
             <a:r>
-              <a:rPr lang="en-US" altLang="ko-KR" sz="1080" b="1">
+              <a:rPr lang="en-US" altLang="ko-KR" sz="936" b="1">
                 <a:solidFill>
-                  <a:srgbClr val="111827"/>
+                  <a:srgbClr val="E2E8F0"/>
                 </a:solidFill>
                 <a:latin typeface="Aptos" panose="020B0004020202020204" pitchFamily="34" charset="0"/>
               </a:rPr>
-              <a:t>technical</a:t>
-            </a:r>
-            <a:endParaRPr lang="ko-KR" altLang="en-US" sz="1080" b="1">
+              <a:t>Themes</a:t>
+            </a:r>
+            <a:endParaRPr lang="ko-KR" altLang="en-US" sz="936" b="1">
               <a:solidFill>
-                <a:srgbClr val="111827"/>
+                <a:srgbClr val="E2E8F0"/>
               </a:solidFill>
               <a:latin typeface="Aptos" panose="020B0004020202020204" pitchFamily="34" charset="0"/>
             </a:endParaRPr>
@@ -4402,10 +4143,10 @@
       </p:sp>
       <p:sp>
         <p:nvSpPr>
-          <p:cNvPr id="24" name="TextBox 23">
-            <a:extLst>
-              <a:ext uri="{FF2B5EF4-FFF2-40B4-BE49-F238E27FC236}">
-                <a16:creationId xmlns:a16="http://schemas.microsoft.com/office/drawing/2014/main" id="{AEE805FA-D676-5617-66A3-5753E6AD2507}"/>
+          <p:cNvPr id="19" name="TextBox 18">
+            <a:extLst>
+              <a:ext uri="{FF2B5EF4-FFF2-40B4-BE49-F238E27FC236}">
+                <a16:creationId xmlns:a16="http://schemas.microsoft.com/office/drawing/2014/main" id="{4DE8C881-1803-0996-24C0-E0499A547E34}"/>
               </a:ext>
             </a:extLst>
           </p:cNvPr>
@@ -4414,8 +4155,8 @@
         </p:nvSpPr>
         <p:spPr>
           <a:xfrm>
-            <a:off x="2331662" y="3718560"/>
-            <a:ext cx="2255464" cy="369332"/>
+            <a:off x="9082813" y="1082040"/>
+            <a:ext cx="1706837" cy="369332"/>
           </a:xfrm>
           <a:prstGeom prst="rect">
             <a:avLst/>
@@ -4429,17 +4170,17 @@
           <a:lstStyle/>
           <a:p>
             <a:r>
-              <a:rPr lang="en-US" altLang="ko-KR" sz="1008">
+              <a:rPr lang="en-US" altLang="ko-KR" sz="936">
                 <a:solidFill>
-                  <a:srgbClr val="64748B"/>
+                  <a:srgbClr val="CBD5E1"/>
                 </a:solidFill>
                 <a:latin typeface="Aptos" panose="020B0004020202020204" pitchFamily="34" charset="0"/>
               </a:rPr>
-              <a:t>Cover / title</a:t>
-            </a:r>
-            <a:endParaRPr lang="ko-KR" altLang="en-US" sz="1008">
+              <a:t>10 styles</a:t>
+            </a:r>
+            <a:endParaRPr lang="ko-KR" altLang="en-US" sz="936">
               <a:solidFill>
-                <a:srgbClr val="64748B"/>
+                <a:srgbClr val="CBD5E1"/>
               </a:solidFill>
               <a:latin typeface="Aptos" panose="020B0004020202020204" pitchFamily="34" charset="0"/>
             </a:endParaRPr>
@@ -4448,10 +4189,10 @@
       </p:sp>
       <p:sp>
         <p:nvSpPr>
-          <p:cNvPr id="25" name="사각형: 둥근 모서리 24">
-            <a:extLst>
-              <a:ext uri="{FF2B5EF4-FFF2-40B4-BE49-F238E27FC236}">
-                <a16:creationId xmlns:a16="http://schemas.microsoft.com/office/drawing/2014/main" id="{25317516-ED83-1C9E-A63E-E0DDE000D9A1}"/>
+          <p:cNvPr id="20" name="타원 19">
+            <a:extLst>
+              <a:ext uri="{FF2B5EF4-FFF2-40B4-BE49-F238E27FC236}">
+                <a16:creationId xmlns:a16="http://schemas.microsoft.com/office/drawing/2014/main" id="{D08F6711-C20D-6696-A98B-2935806FC746}"/>
               </a:ext>
             </a:extLst>
           </p:cNvPr>
@@ -4460,27 +4201,20 @@
         </p:nvSpPr>
         <p:spPr>
           <a:xfrm>
-            <a:off x="4876678" y="1600200"/>
-            <a:ext cx="3886103" cy="2377440"/>
-          </a:xfrm>
-          <a:prstGeom prst="roundRect">
+            <a:off x="7680768" y="1371600"/>
+            <a:ext cx="152396" cy="152400"/>
+          </a:xfrm>
+          <a:prstGeom prst="ellipse">
             <a:avLst/>
           </a:prstGeom>
           <a:solidFill>
-            <a:srgbClr val="FFFFFF"/>
+            <a:srgbClr val="E9B44C"/>
           </a:solidFill>
-          <a:ln w="9144">
+          <a:ln w="7620">
             <a:solidFill>
-              <a:srgbClr val="334155"/>
+              <a:srgbClr val="FFFFFF"/>
             </a:solidFill>
           </a:ln>
-          <a:effectLst>
-            <a:outerShdw blurRad="38100" dist="28988" dir="3671352" rotWithShape="0">
-              <a:scrgbClr r="0" g="0" b="0">
-                <a:alpha val="14000"/>
-              </a:scrgbClr>
-            </a:outerShdw>
-          </a:effectLst>
         </p:spPr>
         <p:style>
           <a:lnRef idx="2">
@@ -4507,66 +4241,122 @@
           </a:p>
         </p:txBody>
       </p:sp>
-      <p:pic>
-        <p:nvPicPr>
-          <p:cNvPr id="27" name="그림 26">
-            <a:extLst>
-              <a:ext uri="{FF2B5EF4-FFF2-40B4-BE49-F238E27FC236}">
-                <a16:creationId xmlns:a16="http://schemas.microsoft.com/office/drawing/2014/main" id="{72156CED-7A3D-9B65-6EB3-CB48FB7239B4}"/>
-              </a:ext>
-            </a:extLst>
-          </p:cNvPr>
-          <p:cNvPicPr>
-            <a:picLocks/>
-          </p:cNvPicPr>
+      <p:sp>
+        <p:nvSpPr>
+          <p:cNvPr id="21" name="TextBox 20">
+            <a:extLst>
+              <a:ext uri="{FF2B5EF4-FFF2-40B4-BE49-F238E27FC236}">
+                <a16:creationId xmlns:a16="http://schemas.microsoft.com/office/drawing/2014/main" id="{EA8E47F4-1FA0-42FE-38B1-FB2991E8D55B}"/>
+              </a:ext>
+            </a:extLst>
+          </p:cNvPr>
+          <p:cNvSpPr txBox="1"/>
           <p:nvPr/>
-        </p:nvPicPr>
-        <p:blipFill>
-          <a:blip r:embed="rId3">
-            <a:extLst>
-              <a:ext uri="{28A0092B-C50C-407E-A947-70E740481C1C}">
-                <a14:useLocalDpi xmlns:a14="http://schemas.microsoft.com/office/drawing/2010/main" val="0"/>
-              </a:ext>
-            </a:extLst>
-          </a:blip>
-          <a:stretch>
-            <a:fillRect/>
-          </a:stretch>
-        </p:blipFill>
-        <p:spPr>
-          <a:xfrm>
-            <a:off x="4952876" y="1676400"/>
-            <a:ext cx="3733707" cy="1981200"/>
+        </p:nvSpPr>
+        <p:spPr>
+          <a:xfrm>
+            <a:off x="7924602" y="1356360"/>
+            <a:ext cx="990575" cy="369332"/>
           </a:xfrm>
           <a:prstGeom prst="rect">
             <a:avLst/>
           </a:prstGeom>
-        </p:spPr>
-      </p:pic>
-      <p:sp>
-        <p:nvSpPr>
-          <p:cNvPr id="28" name="직사각형 27">
-            <a:extLst>
-              <a:ext uri="{FF2B5EF4-FFF2-40B4-BE49-F238E27FC236}">
-                <a16:creationId xmlns:a16="http://schemas.microsoft.com/office/drawing/2014/main" id="{1AAF4F35-A055-9117-A3FD-B2AC0D00479C}"/>
-              </a:ext>
-            </a:extLst>
-          </p:cNvPr>
-          <p:cNvSpPr/>
+          <a:noFill/>
+        </p:spPr>
+        <p:txBody>
+          <a:bodyPr vert="horz" wrap="square" lIns="0" tIns="0" rIns="0" bIns="0" rtlCol="0" anchor="ctr">
+            <a:noAutofit/>
+          </a:bodyPr>
+          <a:lstStyle/>
+          <a:p>
+            <a:r>
+              <a:rPr lang="en-US" altLang="ko-KR" sz="936" b="1">
+                <a:solidFill>
+                  <a:srgbClr val="E2E8F0"/>
+                </a:solidFill>
+                <a:latin typeface="Aptos" panose="020B0004020202020204" pitchFamily="34" charset="0"/>
+              </a:rPr>
+              <a:t>Layouts</a:t>
+            </a:r>
+            <a:endParaRPr lang="ko-KR" altLang="en-US" sz="936" b="1">
+              <a:solidFill>
+                <a:srgbClr val="E2E8F0"/>
+              </a:solidFill>
+              <a:latin typeface="Aptos" panose="020B0004020202020204" pitchFamily="34" charset="0"/>
+            </a:endParaRPr>
+          </a:p>
+        </p:txBody>
+      </p:sp>
+      <p:sp>
+        <p:nvSpPr>
+          <p:cNvPr id="22" name="TextBox 21">
+            <a:extLst>
+              <a:ext uri="{FF2B5EF4-FFF2-40B4-BE49-F238E27FC236}">
+                <a16:creationId xmlns:a16="http://schemas.microsoft.com/office/drawing/2014/main" id="{16F0666F-07B3-1EEE-9E4A-0A3CB9C78C86}"/>
+              </a:ext>
+            </a:extLst>
+          </p:cNvPr>
+          <p:cNvSpPr txBox="1"/>
           <p:nvPr/>
         </p:nvSpPr>
         <p:spPr>
           <a:xfrm>
-            <a:off x="4952876" y="3657600"/>
-            <a:ext cx="3733707" cy="289560"/>
+            <a:off x="9082813" y="1356360"/>
+            <a:ext cx="1706837" cy="369332"/>
           </a:xfrm>
           <a:prstGeom prst="rect">
             <a:avLst/>
           </a:prstGeom>
+          <a:noFill/>
+        </p:spPr>
+        <p:txBody>
+          <a:bodyPr vert="horz" wrap="square" lIns="0" tIns="0" rIns="0" bIns="0" rtlCol="0" anchor="ctr">
+            <a:noAutofit/>
+          </a:bodyPr>
+          <a:lstStyle/>
+          <a:p>
+            <a:r>
+              <a:rPr lang="en-US" altLang="ko-KR" sz="936">
+                <a:solidFill>
+                  <a:srgbClr val="CBD5E1"/>
+                </a:solidFill>
+                <a:latin typeface="Aptos" panose="020B0004020202020204" pitchFamily="34" charset="0"/>
+              </a:rPr>
+              <a:t>10 compositions</a:t>
+            </a:r>
+            <a:endParaRPr lang="ko-KR" altLang="en-US" sz="936">
+              <a:solidFill>
+                <a:srgbClr val="CBD5E1"/>
+              </a:solidFill>
+              <a:latin typeface="Aptos" panose="020B0004020202020204" pitchFamily="34" charset="0"/>
+            </a:endParaRPr>
+          </a:p>
+        </p:txBody>
+      </p:sp>
+      <p:sp>
+        <p:nvSpPr>
+          <p:cNvPr id="23" name="타원 22">
+            <a:extLst>
+              <a:ext uri="{FF2B5EF4-FFF2-40B4-BE49-F238E27FC236}">
+                <a16:creationId xmlns:a16="http://schemas.microsoft.com/office/drawing/2014/main" id="{9C7C34CC-46B4-76DC-985B-8828B9E27048}"/>
+              </a:ext>
+            </a:extLst>
+          </p:cNvPr>
+          <p:cNvSpPr/>
+          <p:nvPr/>
+        </p:nvSpPr>
+        <p:spPr>
+          <a:xfrm>
+            <a:off x="7680768" y="1645920"/>
+            <a:ext cx="152396" cy="152400"/>
+          </a:xfrm>
+          <a:prstGeom prst="ellipse">
+            <a:avLst/>
+          </a:prstGeom>
           <a:solidFill>
-            <a:srgbClr val="FFFFFF"/>
+            <a:srgbClr val="8B7CF6"/>
           </a:solidFill>
-          <a:ln w="6350">
+          <a:ln w="7620">
             <a:solidFill>
               <a:srgbClr val="FFFFFF"/>
             </a:solidFill>
@@ -4599,10 +4389,10 @@
       </p:sp>
       <p:sp>
         <p:nvSpPr>
-          <p:cNvPr id="29" name="TextBox 28">
-            <a:extLst>
-              <a:ext uri="{FF2B5EF4-FFF2-40B4-BE49-F238E27FC236}">
-                <a16:creationId xmlns:a16="http://schemas.microsoft.com/office/drawing/2014/main" id="{5753D23C-A9DA-902B-7B18-52277B0EF3CB}"/>
+          <p:cNvPr id="24" name="TextBox 23">
+            <a:extLst>
+              <a:ext uri="{FF2B5EF4-FFF2-40B4-BE49-F238E27FC236}">
+                <a16:creationId xmlns:a16="http://schemas.microsoft.com/office/drawing/2014/main" id="{37DA95D5-F7A7-C25F-4BD6-9CD0A9525AD6}"/>
               </a:ext>
             </a:extLst>
           </p:cNvPr>
@@ -4611,8 +4401,8 @@
         </p:nvSpPr>
         <p:spPr>
           <a:xfrm>
-            <a:off x="5090033" y="3718560"/>
-            <a:ext cx="1219169" cy="369332"/>
+            <a:off x="7924602" y="1630680"/>
+            <a:ext cx="990575" cy="369332"/>
           </a:xfrm>
           <a:prstGeom prst="rect">
             <a:avLst/>
@@ -4626,17 +4416,17 @@
           <a:lstStyle/>
           <a:p>
             <a:r>
-              <a:rPr lang="en-US" altLang="ko-KR" sz="1080" b="1">
+              <a:rPr lang="en-US" altLang="ko-KR" sz="936" b="1">
                 <a:solidFill>
-                  <a:srgbClr val="111827"/>
+                  <a:srgbClr val="E2E8F0"/>
                 </a:solidFill>
                 <a:latin typeface="Aptos" panose="020B0004020202020204" pitchFamily="34" charset="0"/>
               </a:rPr>
-              <a:t>glass</a:t>
-            </a:r>
-            <a:endParaRPr lang="ko-KR" altLang="en-US" sz="1080" b="1">
+              <a:t>Objects</a:t>
+            </a:r>
+            <a:endParaRPr lang="ko-KR" altLang="en-US" sz="936" b="1">
               <a:solidFill>
-                <a:srgbClr val="111827"/>
+                <a:srgbClr val="E2E8F0"/>
               </a:solidFill>
               <a:latin typeface="Aptos" panose="020B0004020202020204" pitchFamily="34" charset="0"/>
             </a:endParaRPr>
@@ -4645,10 +4435,10 @@
       </p:sp>
       <p:sp>
         <p:nvSpPr>
-          <p:cNvPr id="30" name="TextBox 29">
-            <a:extLst>
-              <a:ext uri="{FF2B5EF4-FFF2-40B4-BE49-F238E27FC236}">
-                <a16:creationId xmlns:a16="http://schemas.microsoft.com/office/drawing/2014/main" id="{EC1D4622-8382-5523-315E-639968C9355E}"/>
+          <p:cNvPr id="25" name="TextBox 24">
+            <a:extLst>
+              <a:ext uri="{FF2B5EF4-FFF2-40B4-BE49-F238E27FC236}">
+                <a16:creationId xmlns:a16="http://schemas.microsoft.com/office/drawing/2014/main" id="{DC5FEBC2-290E-9B6F-0F23-BF32D69199FC}"/>
               </a:ext>
             </a:extLst>
           </p:cNvPr>
@@ -4657,8 +4447,8 @@
         </p:nvSpPr>
         <p:spPr>
           <a:xfrm>
-            <a:off x="6293963" y="3718560"/>
-            <a:ext cx="2255464" cy="369332"/>
+            <a:off x="9082813" y="1630680"/>
+            <a:ext cx="1706837" cy="369332"/>
           </a:xfrm>
           <a:prstGeom prst="rect">
             <a:avLst/>
@@ -4672,17 +4462,17 @@
           <a:lstStyle/>
           <a:p>
             <a:r>
-              <a:rPr lang="en-US" altLang="ko-KR" sz="1008">
+              <a:rPr lang="en-US" altLang="ko-KR" sz="936">
                 <a:solidFill>
-                  <a:srgbClr val="64748B"/>
+                  <a:srgbClr val="CBD5E1"/>
                 </a:solidFill>
                 <a:latin typeface="Aptos" panose="020B0004020202020204" pitchFamily="34" charset="0"/>
               </a:rPr>
-              <a:t>Semantic grid</a:t>
-            </a:r>
-            <a:endParaRPr lang="ko-KR" altLang="en-US" sz="1008">
+              <a:t>10 forms</a:t>
+            </a:r>
+            <a:endParaRPr lang="ko-KR" altLang="en-US" sz="936">
               <a:solidFill>
-                <a:srgbClr val="64748B"/>
+                <a:srgbClr val="CBD5E1"/>
               </a:solidFill>
               <a:latin typeface="Aptos" panose="020B0004020202020204" pitchFamily="34" charset="0"/>
             </a:endParaRPr>
@@ -4691,10 +4481,10 @@
       </p:sp>
       <p:sp>
         <p:nvSpPr>
-          <p:cNvPr id="31" name="사각형: 둥근 모서리 30">
-            <a:extLst>
-              <a:ext uri="{FF2B5EF4-FFF2-40B4-BE49-F238E27FC236}">
-                <a16:creationId xmlns:a16="http://schemas.microsoft.com/office/drawing/2014/main" id="{969B176F-0886-33D7-D76C-21A2A55EE94A}"/>
+          <p:cNvPr id="26" name="타원 25">
+            <a:extLst>
+              <a:ext uri="{FF2B5EF4-FFF2-40B4-BE49-F238E27FC236}">
+                <a16:creationId xmlns:a16="http://schemas.microsoft.com/office/drawing/2014/main" id="{21ED70FD-B25C-C4CE-033A-89784AB3B18E}"/>
               </a:ext>
             </a:extLst>
           </p:cNvPr>
@@ -4703,27 +4493,20 @@
         </p:nvSpPr>
         <p:spPr>
           <a:xfrm>
-            <a:off x="914377" y="4130040"/>
-            <a:ext cx="3886103" cy="2377440"/>
-          </a:xfrm>
-          <a:prstGeom prst="roundRect">
+            <a:off x="7680768" y="1920240"/>
+            <a:ext cx="152396" cy="152400"/>
+          </a:xfrm>
+          <a:prstGeom prst="ellipse">
             <a:avLst/>
           </a:prstGeom>
           <a:solidFill>
-            <a:srgbClr val="FFFFFF"/>
+            <a:srgbClr val="BE123C"/>
           </a:solidFill>
-          <a:ln w="9144">
+          <a:ln w="7620">
             <a:solidFill>
-              <a:srgbClr val="334155"/>
+              <a:srgbClr val="FFFFFF"/>
             </a:solidFill>
           </a:ln>
-          <a:effectLst>
-            <a:outerShdw blurRad="38100" dist="28988" dir="3671352" rotWithShape="0">
-              <a:scrgbClr r="0" g="0" b="0">
-                <a:alpha val="14000"/>
-              </a:scrgbClr>
-            </a:outerShdw>
-          </a:effectLst>
         </p:spPr>
         <p:style>
           <a:lnRef idx="2">
@@ -4750,70 +4533,133 @@
           </a:p>
         </p:txBody>
       </p:sp>
-      <p:pic>
-        <p:nvPicPr>
-          <p:cNvPr id="33" name="그림 32">
-            <a:extLst>
-              <a:ext uri="{FF2B5EF4-FFF2-40B4-BE49-F238E27FC236}">
-                <a16:creationId xmlns:a16="http://schemas.microsoft.com/office/drawing/2014/main" id="{5D050ADF-0573-BEE9-74C5-6B3C147BF0DE}"/>
-              </a:ext>
-            </a:extLst>
-          </p:cNvPr>
-          <p:cNvPicPr>
-            <a:picLocks/>
-          </p:cNvPicPr>
+      <p:sp>
+        <p:nvSpPr>
+          <p:cNvPr id="27" name="TextBox 26">
+            <a:extLst>
+              <a:ext uri="{FF2B5EF4-FFF2-40B4-BE49-F238E27FC236}">
+                <a16:creationId xmlns:a16="http://schemas.microsoft.com/office/drawing/2014/main" id="{8693AC0D-9970-7E90-3D0D-248E93A7D3A4}"/>
+              </a:ext>
+            </a:extLst>
+          </p:cNvPr>
+          <p:cNvSpPr txBox="1"/>
           <p:nvPr/>
-        </p:nvPicPr>
-        <p:blipFill>
-          <a:blip r:embed="rId4">
-            <a:extLst>
-              <a:ext uri="{28A0092B-C50C-407E-A947-70E740481C1C}">
-                <a14:useLocalDpi xmlns:a14="http://schemas.microsoft.com/office/drawing/2010/main" val="0"/>
-              </a:ext>
-            </a:extLst>
-          </a:blip>
-          <a:stretch>
-            <a:fillRect/>
-          </a:stretch>
-        </p:blipFill>
-        <p:spPr>
-          <a:xfrm>
-            <a:off x="990575" y="4206240"/>
-            <a:ext cx="3733707" cy="1981200"/>
+        </p:nvSpPr>
+        <p:spPr>
+          <a:xfrm>
+            <a:off x="7924602" y="1905000"/>
+            <a:ext cx="990575" cy="369332"/>
           </a:xfrm>
           <a:prstGeom prst="rect">
             <a:avLst/>
           </a:prstGeom>
-        </p:spPr>
-      </p:pic>
-      <p:sp>
-        <p:nvSpPr>
-          <p:cNvPr id="34" name="직사각형 33">
-            <a:extLst>
-              <a:ext uri="{FF2B5EF4-FFF2-40B4-BE49-F238E27FC236}">
-                <a16:creationId xmlns:a16="http://schemas.microsoft.com/office/drawing/2014/main" id="{571087E5-A80C-C6E5-26B8-B9C0569D5F3D}"/>
-              </a:ext>
-            </a:extLst>
-          </p:cNvPr>
-          <p:cNvSpPr/>
+          <a:noFill/>
+        </p:spPr>
+        <p:txBody>
+          <a:bodyPr vert="horz" wrap="square" lIns="0" tIns="0" rIns="0" bIns="0" rtlCol="0" anchor="ctr">
+            <a:noAutofit/>
+          </a:bodyPr>
+          <a:lstStyle/>
+          <a:p>
+            <a:r>
+              <a:rPr lang="en-US" altLang="ko-KR" sz="936" b="1">
+                <a:solidFill>
+                  <a:srgbClr val="E2E8F0"/>
+                </a:solidFill>
+                <a:latin typeface="Aptos" panose="020B0004020202020204" pitchFamily="34" charset="0"/>
+              </a:rPr>
+              <a:t>Exports</a:t>
+            </a:r>
+            <a:endParaRPr lang="ko-KR" altLang="en-US" sz="936" b="1">
+              <a:solidFill>
+                <a:srgbClr val="E2E8F0"/>
+              </a:solidFill>
+              <a:latin typeface="Aptos" panose="020B0004020202020204" pitchFamily="34" charset="0"/>
+            </a:endParaRPr>
+          </a:p>
+        </p:txBody>
+      </p:sp>
+      <p:sp>
+        <p:nvSpPr>
+          <p:cNvPr id="28" name="TextBox 27">
+            <a:extLst>
+              <a:ext uri="{FF2B5EF4-FFF2-40B4-BE49-F238E27FC236}">
+                <a16:creationId xmlns:a16="http://schemas.microsoft.com/office/drawing/2014/main" id="{81F32292-05CD-82BD-F959-518BE4436567}"/>
+              </a:ext>
+            </a:extLst>
+          </p:cNvPr>
+          <p:cNvSpPr txBox="1"/>
           <p:nvPr/>
         </p:nvSpPr>
         <p:spPr>
           <a:xfrm>
-            <a:off x="990575" y="6187440"/>
-            <a:ext cx="3733707" cy="289560"/>
+            <a:off x="9082813" y="1905000"/>
+            <a:ext cx="1706837" cy="369332"/>
           </a:xfrm>
           <a:prstGeom prst="rect">
             <a:avLst/>
           </a:prstGeom>
+          <a:noFill/>
+        </p:spPr>
+        <p:txBody>
+          <a:bodyPr vert="horz" wrap="square" lIns="0" tIns="0" rIns="0" bIns="0" rtlCol="0" anchor="ctr">
+            <a:noAutofit/>
+          </a:bodyPr>
+          <a:lstStyle/>
+          <a:p>
+            <a:r>
+              <a:rPr lang="en-US" altLang="ko-KR" sz="936">
+                <a:solidFill>
+                  <a:srgbClr val="CBD5E1"/>
+                </a:solidFill>
+                <a:latin typeface="Aptos" panose="020B0004020202020204" pitchFamily="34" charset="0"/>
+              </a:rPr>
+              <a:t>190 PPTX PNGs</a:t>
+            </a:r>
+            <a:endParaRPr lang="ko-KR" altLang="en-US" sz="936">
+              <a:solidFill>
+                <a:srgbClr val="CBD5E1"/>
+              </a:solidFill>
+              <a:latin typeface="Aptos" panose="020B0004020202020204" pitchFamily="34" charset="0"/>
+            </a:endParaRPr>
+          </a:p>
+        </p:txBody>
+      </p:sp>
+      <p:sp>
+        <p:nvSpPr>
+          <p:cNvPr id="29" name="사각형: 둥근 모서리 28">
+            <a:extLst>
+              <a:ext uri="{FF2B5EF4-FFF2-40B4-BE49-F238E27FC236}">
+                <a16:creationId xmlns:a16="http://schemas.microsoft.com/office/drawing/2014/main" id="{504BEF15-8182-459E-2049-C64C92FA4CC7}"/>
+              </a:ext>
+            </a:extLst>
+          </p:cNvPr>
+          <p:cNvSpPr/>
+          <p:nvPr/>
+        </p:nvSpPr>
+        <p:spPr>
+          <a:xfrm>
+            <a:off x="7452174" y="2575560"/>
+            <a:ext cx="3703227" cy="1722120"/>
+          </a:xfrm>
+          <a:prstGeom prst="roundRect">
+            <a:avLst/>
+          </a:prstGeom>
           <a:solidFill>
-            <a:srgbClr val="FFFFFF"/>
+            <a:srgbClr val="FFFDF8"/>
           </a:solidFill>
-          <a:ln w="6350">
+          <a:ln w="9144">
             <a:solidFill>
-              <a:srgbClr val="FFFFFF"/>
+              <a:srgbClr val="334155"/>
             </a:solidFill>
           </a:ln>
+          <a:effectLst>
+            <a:outerShdw blurRad="38100" dist="28988" dir="3671352" rotWithShape="0">
+              <a:scrgbClr r="0" g="0" b="0">
+                <a:alpha val="14000"/>
+              </a:scrgbClr>
+            </a:outerShdw>
+          </a:effectLst>
         </p:spPr>
         <p:style>
           <a:lnRef idx="2">
@@ -4842,10 +4688,10 @@
       </p:sp>
       <p:sp>
         <p:nvSpPr>
-          <p:cNvPr id="35" name="TextBox 34">
-            <a:extLst>
-              <a:ext uri="{FF2B5EF4-FFF2-40B4-BE49-F238E27FC236}">
-                <a16:creationId xmlns:a16="http://schemas.microsoft.com/office/drawing/2014/main" id="{AB45DBB2-BB4D-093A-7749-A9E4FED7DEF4}"/>
+          <p:cNvPr id="30" name="TextBox 29">
+            <a:extLst>
+              <a:ext uri="{FF2B5EF4-FFF2-40B4-BE49-F238E27FC236}">
+                <a16:creationId xmlns:a16="http://schemas.microsoft.com/office/drawing/2014/main" id="{DE681FA1-8B35-1AD4-DFE0-7CF6F537F9AF}"/>
               </a:ext>
             </a:extLst>
           </p:cNvPr>
@@ -4854,8 +4700,8 @@
         </p:nvSpPr>
         <p:spPr>
           <a:xfrm>
-            <a:off x="1127732" y="6248400"/>
-            <a:ext cx="1219169" cy="369332"/>
+            <a:off x="7726487" y="2819400"/>
+            <a:ext cx="2971726" cy="369332"/>
           </a:xfrm>
           <a:prstGeom prst="rect">
             <a:avLst/>
@@ -4869,15 +4715,15 @@
           <a:lstStyle/>
           <a:p>
             <a:r>
-              <a:rPr lang="en-US" altLang="ko-KR" sz="1080" b="1">
+              <a:rPr lang="en-US" altLang="ko-KR" sz="1728" b="1">
                 <a:solidFill>
                   <a:srgbClr val="111827"/>
                 </a:solidFill>
                 <a:latin typeface="Aptos" panose="020B0004020202020204" pitchFamily="34" charset="0"/>
               </a:rPr>
-              <a:t>data</a:t>
-            </a:r>
-            <a:endParaRPr lang="ko-KR" altLang="en-US" sz="1080" b="1">
+              <a:t>Deterministic visual rules</a:t>
+            </a:r>
+            <a:endParaRPr lang="ko-KR" altLang="en-US" sz="1728" b="1">
               <a:solidFill>
                 <a:srgbClr val="111827"/>
               </a:solidFill>
@@ -4888,56 +4734,10 @@
       </p:sp>
       <p:sp>
         <p:nvSpPr>
-          <p:cNvPr id="36" name="TextBox 35">
-            <a:extLst>
-              <a:ext uri="{FF2B5EF4-FFF2-40B4-BE49-F238E27FC236}">
-                <a16:creationId xmlns:a16="http://schemas.microsoft.com/office/drawing/2014/main" id="{6A9F6AF4-F6B3-7AD5-8C6D-0AF718F75FB2}"/>
-              </a:ext>
-            </a:extLst>
-          </p:cNvPr>
-          <p:cNvSpPr txBox="1"/>
-          <p:nvPr/>
-        </p:nvSpPr>
-        <p:spPr>
-          <a:xfrm>
-            <a:off x="2331662" y="6248400"/>
-            <a:ext cx="2255464" cy="369332"/>
-          </a:xfrm>
-          <a:prstGeom prst="rect">
-            <a:avLst/>
-          </a:prstGeom>
-          <a:noFill/>
-        </p:spPr>
-        <p:txBody>
-          <a:bodyPr vert="horz" wrap="square" lIns="0" tIns="0" rIns="0" bIns="0" rtlCol="0" anchor="ctr">
-            <a:noAutofit/>
-          </a:bodyPr>
-          <a:lstStyle/>
-          <a:p>
-            <a:r>
-              <a:rPr lang="en-US" altLang="ko-KR" sz="1008">
-                <a:solidFill>
-                  <a:srgbClr val="64748B"/>
-                </a:solidFill>
-                <a:latin typeface="Aptos" panose="020B0004020202020204" pitchFamily="34" charset="0"/>
-              </a:rPr>
-              <a:t>Chart + table</a:t>
-            </a:r>
-            <a:endParaRPr lang="ko-KR" altLang="en-US" sz="1008">
-              <a:solidFill>
-                <a:srgbClr val="64748B"/>
-              </a:solidFill>
-              <a:latin typeface="Aptos" panose="020B0004020202020204" pitchFamily="34" charset="0"/>
-            </a:endParaRPr>
-          </a:p>
-        </p:txBody>
-      </p:sp>
-      <p:sp>
-        <p:nvSpPr>
-          <p:cNvPr id="37" name="사각형: 둥근 모서리 36">
-            <a:extLst>
-              <a:ext uri="{FF2B5EF4-FFF2-40B4-BE49-F238E27FC236}">
-                <a16:creationId xmlns:a16="http://schemas.microsoft.com/office/drawing/2014/main" id="{FC58F2D7-57DD-6622-3832-8911ED623706}"/>
+          <p:cNvPr id="31" name="타원 30">
+            <a:extLst>
+              <a:ext uri="{FF2B5EF4-FFF2-40B4-BE49-F238E27FC236}">
+                <a16:creationId xmlns:a16="http://schemas.microsoft.com/office/drawing/2014/main" id="{A1947E5C-3C0E-5D93-D5E4-A10869CDF08F}"/>
               </a:ext>
             </a:extLst>
           </p:cNvPr>
@@ -4946,27 +4746,20 @@
         </p:nvSpPr>
         <p:spPr>
           <a:xfrm>
-            <a:off x="4876678" y="4130040"/>
-            <a:ext cx="3886103" cy="2377440"/>
-          </a:xfrm>
-          <a:prstGeom prst="roundRect">
+            <a:off x="7741727" y="3246120"/>
+            <a:ext cx="121916" cy="121920"/>
+          </a:xfrm>
+          <a:prstGeom prst="ellipse">
             <a:avLst/>
           </a:prstGeom>
           <a:solidFill>
-            <a:srgbClr val="FFFFFF"/>
+            <a:srgbClr val="14B8A6"/>
           </a:solidFill>
-          <a:ln w="9144">
+          <a:ln w="6350">
             <a:solidFill>
-              <a:srgbClr val="334155"/>
+              <a:srgbClr val="14B8A6"/>
             </a:solidFill>
           </a:ln>
-          <a:effectLst>
-            <a:outerShdw blurRad="38100" dist="28988" dir="3671352" rotWithShape="0">
-              <a:scrgbClr r="0" g="0" b="0">
-                <a:alpha val="14000"/>
-              </a:scrgbClr>
-            </a:outerShdw>
-          </a:effectLst>
         </p:spPr>
         <p:style>
           <a:lnRef idx="2">
@@ -4993,48 +4786,58 @@
           </a:p>
         </p:txBody>
       </p:sp>
-      <p:pic>
-        <p:nvPicPr>
-          <p:cNvPr id="39" name="그림 38">
-            <a:extLst>
-              <a:ext uri="{FF2B5EF4-FFF2-40B4-BE49-F238E27FC236}">
-                <a16:creationId xmlns:a16="http://schemas.microsoft.com/office/drawing/2014/main" id="{C03DA2D9-2013-0218-8D0A-6967AECA0E82}"/>
-              </a:ext>
-            </a:extLst>
-          </p:cNvPr>
-          <p:cNvPicPr>
-            <a:picLocks/>
-          </p:cNvPicPr>
+      <p:sp>
+        <p:nvSpPr>
+          <p:cNvPr id="32" name="TextBox 31">
+            <a:extLst>
+              <a:ext uri="{FF2B5EF4-FFF2-40B4-BE49-F238E27FC236}">
+                <a16:creationId xmlns:a16="http://schemas.microsoft.com/office/drawing/2014/main" id="{96D43969-1134-73E7-E5A0-2D3F54C3A8CC}"/>
+              </a:ext>
+            </a:extLst>
+          </p:cNvPr>
+          <p:cNvSpPr txBox="1"/>
           <p:nvPr/>
-        </p:nvPicPr>
-        <p:blipFill>
-          <a:blip r:embed="rId5">
-            <a:extLst>
-              <a:ext uri="{28A0092B-C50C-407E-A947-70E740481C1C}">
-                <a14:useLocalDpi xmlns:a14="http://schemas.microsoft.com/office/drawing/2010/main" val="0"/>
-              </a:ext>
-            </a:extLst>
-          </a:blip>
-          <a:stretch>
-            <a:fillRect/>
-          </a:stretch>
-        </p:blipFill>
-        <p:spPr>
-          <a:xfrm>
-            <a:off x="4952876" y="4206240"/>
-            <a:ext cx="3733707" cy="1981200"/>
+        </p:nvSpPr>
+        <p:spPr>
+          <a:xfrm>
+            <a:off x="7955081" y="3200400"/>
+            <a:ext cx="2514537" cy="369332"/>
           </a:xfrm>
           <a:prstGeom prst="rect">
             <a:avLst/>
           </a:prstGeom>
-        </p:spPr>
-      </p:pic>
-      <p:sp>
-        <p:nvSpPr>
-          <p:cNvPr id="40" name="직사각형 39">
-            <a:extLst>
-              <a:ext uri="{FF2B5EF4-FFF2-40B4-BE49-F238E27FC236}">
-                <a16:creationId xmlns:a16="http://schemas.microsoft.com/office/drawing/2014/main" id="{220C4F08-7207-D5C4-6258-8F42706BB26E}"/>
+          <a:noFill/>
+        </p:spPr>
+        <p:txBody>
+          <a:bodyPr vert="horz" wrap="square" lIns="0" tIns="0" rIns="0" bIns="0" rtlCol="0" anchor="ctr">
+            <a:noAutofit/>
+          </a:bodyPr>
+          <a:lstStyle/>
+          <a:p>
+            <a:r>
+              <a:rPr lang="en-US" altLang="ko-KR" sz="1008" b="1">
+                <a:solidFill>
+                  <a:srgbClr val="111827"/>
+                </a:solidFill>
+                <a:latin typeface="Aptos" panose="020B0004020202020204" pitchFamily="34" charset="0"/>
+              </a:rPr>
+              <a:t>Theme colors</a:t>
+            </a:r>
+            <a:endParaRPr lang="ko-KR" altLang="en-US" sz="1008" b="1">
+              <a:solidFill>
+                <a:srgbClr val="111827"/>
+              </a:solidFill>
+              <a:latin typeface="Aptos" panose="020B0004020202020204" pitchFamily="34" charset="0"/>
+            </a:endParaRPr>
+          </a:p>
+        </p:txBody>
+      </p:sp>
+      <p:sp>
+        <p:nvSpPr>
+          <p:cNvPr id="33" name="타원 32">
+            <a:extLst>
+              <a:ext uri="{FF2B5EF4-FFF2-40B4-BE49-F238E27FC236}">
+                <a16:creationId xmlns:a16="http://schemas.microsoft.com/office/drawing/2014/main" id="{5E5260F0-55EE-E3CE-95AC-1C224F163167}"/>
               </a:ext>
             </a:extLst>
           </p:cNvPr>
@@ -5043,18 +4846,18 @@
         </p:nvSpPr>
         <p:spPr>
           <a:xfrm>
-            <a:off x="4952876" y="6187440"/>
-            <a:ext cx="3733707" cy="289560"/>
-          </a:xfrm>
-          <a:prstGeom prst="rect">
+            <a:off x="7741727" y="3505200"/>
+            <a:ext cx="121916" cy="121920"/>
+          </a:xfrm>
+          <a:prstGeom prst="ellipse">
             <a:avLst/>
           </a:prstGeom>
           <a:solidFill>
-            <a:srgbClr val="FFFFFF"/>
+            <a:srgbClr val="E9B44C"/>
           </a:solidFill>
           <a:ln w="6350">
             <a:solidFill>
-              <a:srgbClr val="FFFFFF"/>
+              <a:srgbClr val="E9B44C"/>
             </a:solidFill>
           </a:ln>
         </p:spPr>
@@ -5085,10 +4888,10 @@
       </p:sp>
       <p:sp>
         <p:nvSpPr>
-          <p:cNvPr id="41" name="TextBox 40">
-            <a:extLst>
-              <a:ext uri="{FF2B5EF4-FFF2-40B4-BE49-F238E27FC236}">
-                <a16:creationId xmlns:a16="http://schemas.microsoft.com/office/drawing/2014/main" id="{1B96E459-4F8C-36A4-6E5D-22A5BDB78A8F}"/>
+          <p:cNvPr id="34" name="TextBox 33">
+            <a:extLst>
+              <a:ext uri="{FF2B5EF4-FFF2-40B4-BE49-F238E27FC236}">
+                <a16:creationId xmlns:a16="http://schemas.microsoft.com/office/drawing/2014/main" id="{D7527378-2E37-9F88-EFC6-3E04643FE0B2}"/>
               </a:ext>
             </a:extLst>
           </p:cNvPr>
@@ -5097,8 +4900,8 @@
         </p:nvSpPr>
         <p:spPr>
           <a:xfrm>
-            <a:off x="5090033" y="6248400"/>
-            <a:ext cx="1219169" cy="369332"/>
+            <a:off x="7955081" y="3459480"/>
+            <a:ext cx="2514537" cy="369332"/>
           </a:xfrm>
           <a:prstGeom prst="rect">
             <a:avLst/>
@@ -5112,15 +4915,15 @@
           <a:lstStyle/>
           <a:p>
             <a:r>
-              <a:rPr lang="en-US" altLang="ko-KR" sz="1080" b="1">
+              <a:rPr lang="en-US" altLang="ko-KR" sz="1008" b="1">
                 <a:solidFill>
                   <a:srgbClr val="111827"/>
                 </a:solidFill>
                 <a:latin typeface="Aptos" panose="020B0004020202020204" pitchFamily="34" charset="0"/>
               </a:rPr>
-              <a:t>magazine</a:t>
-            </a:r>
-            <a:endParaRPr lang="ko-KR" altLang="en-US" sz="1080" b="1">
+              <a:t>SVG-backed surfaces</a:t>
+            </a:r>
+            <a:endParaRPr lang="ko-KR" altLang="en-US" sz="1008" b="1">
               <a:solidFill>
                 <a:srgbClr val="111827"/>
               </a:solidFill>
@@ -5131,56 +4934,10 @@
       </p:sp>
       <p:sp>
         <p:nvSpPr>
-          <p:cNvPr id="42" name="TextBox 41">
-            <a:extLst>
-              <a:ext uri="{FF2B5EF4-FFF2-40B4-BE49-F238E27FC236}">
-                <a16:creationId xmlns:a16="http://schemas.microsoft.com/office/drawing/2014/main" id="{D9B9544F-1355-4DB6-6143-341EA957FC4B}"/>
-              </a:ext>
-            </a:extLst>
-          </p:cNvPr>
-          <p:cNvSpPr txBox="1"/>
-          <p:nvPr/>
-        </p:nvSpPr>
-        <p:spPr>
-          <a:xfrm>
-            <a:off x="6293963" y="6248400"/>
-            <a:ext cx="2255464" cy="369332"/>
-          </a:xfrm>
-          <a:prstGeom prst="rect">
-            <a:avLst/>
-          </a:prstGeom>
-          <a:noFill/>
-        </p:spPr>
-        <p:txBody>
-          <a:bodyPr vert="horz" wrap="square" lIns="0" tIns="0" rIns="0" bIns="0" rtlCol="0" anchor="ctr">
-            <a:noAutofit/>
-          </a:bodyPr>
-          <a:lstStyle/>
-          <a:p>
-            <a:r>
-              <a:rPr lang="en-US" altLang="ko-KR" sz="1008">
-                <a:solidFill>
-                  <a:srgbClr val="64748B"/>
-                </a:solidFill>
-                <a:latin typeface="Aptos" panose="020B0004020202020204" pitchFamily="34" charset="0"/>
-              </a:rPr>
-              <a:t>Object grammar</a:t>
-            </a:r>
-            <a:endParaRPr lang="ko-KR" altLang="en-US" sz="1008">
-              <a:solidFill>
-                <a:srgbClr val="64748B"/>
-              </a:solidFill>
-              <a:latin typeface="Aptos" panose="020B0004020202020204" pitchFamily="34" charset="0"/>
-            </a:endParaRPr>
-          </a:p>
-        </p:txBody>
-      </p:sp>
-      <p:sp>
-        <p:nvSpPr>
-          <p:cNvPr id="43" name="사각형: 둥근 모서리 42">
-            <a:extLst>
-              <a:ext uri="{FF2B5EF4-FFF2-40B4-BE49-F238E27FC236}">
-                <a16:creationId xmlns:a16="http://schemas.microsoft.com/office/drawing/2014/main" id="{2E958CD4-93C6-37E2-5EA1-54413433C0A6}"/>
+          <p:cNvPr id="35" name="타원 34">
+            <a:extLst>
+              <a:ext uri="{FF2B5EF4-FFF2-40B4-BE49-F238E27FC236}">
+                <a16:creationId xmlns:a16="http://schemas.microsoft.com/office/drawing/2014/main" id="{BA642F4D-FB04-D464-6C01-5E571715B268}"/>
               </a:ext>
             </a:extLst>
           </p:cNvPr>
@@ -5189,27 +4946,20 @@
         </p:nvSpPr>
         <p:spPr>
           <a:xfrm>
-            <a:off x="8991375" y="2484120"/>
-            <a:ext cx="2316422" cy="2712720"/>
-          </a:xfrm>
-          <a:prstGeom prst="roundRect">
+            <a:off x="7741727" y="3764280"/>
+            <a:ext cx="121916" cy="121920"/>
+          </a:xfrm>
+          <a:prstGeom prst="ellipse">
             <a:avLst/>
           </a:prstGeom>
           <a:solidFill>
-            <a:srgbClr val="FFFFFF"/>
+            <a:srgbClr val="BE123C"/>
           </a:solidFill>
-          <a:ln w="9144">
+          <a:ln w="6350">
             <a:solidFill>
-              <a:srgbClr val="334155"/>
+              <a:srgbClr val="BE123C"/>
             </a:solidFill>
           </a:ln>
-          <a:effectLst>
-            <a:outerShdw blurRad="38100" dist="28988" dir="3671352" rotWithShape="0">
-              <a:scrgbClr r="0" g="0" b="0">
-                <a:alpha val="14000"/>
-              </a:scrgbClr>
-            </a:outerShdw>
-          </a:effectLst>
         </p:spPr>
         <p:style>
           <a:lnRef idx="2">
@@ -5238,10 +4988,10 @@
       </p:sp>
       <p:sp>
         <p:nvSpPr>
-          <p:cNvPr id="44" name="TextBox 43">
-            <a:extLst>
-              <a:ext uri="{FF2B5EF4-FFF2-40B4-BE49-F238E27FC236}">
-                <a16:creationId xmlns:a16="http://schemas.microsoft.com/office/drawing/2014/main" id="{F6665C0F-7D06-00AB-85BD-3A549C8AA257}"/>
+          <p:cNvPr id="36" name="TextBox 35">
+            <a:extLst>
+              <a:ext uri="{FF2B5EF4-FFF2-40B4-BE49-F238E27FC236}">
+                <a16:creationId xmlns:a16="http://schemas.microsoft.com/office/drawing/2014/main" id="{335C0F66-73E2-9D9D-E256-9D56BFFDB68E}"/>
               </a:ext>
             </a:extLst>
           </p:cNvPr>
@@ -5250,8 +5000,8 @@
         </p:nvSpPr>
         <p:spPr>
           <a:xfrm>
-            <a:off x="9219970" y="2697480"/>
-            <a:ext cx="1752556" cy="369332"/>
+            <a:off x="7955081" y="3718560"/>
+            <a:ext cx="2514537" cy="369332"/>
           </a:xfrm>
           <a:prstGeom prst="rect">
             <a:avLst/>
@@ -5265,15 +5015,15 @@
           <a:lstStyle/>
           <a:p>
             <a:r>
-              <a:rPr lang="en-US" altLang="ko-KR" sz="1728" b="1">
+              <a:rPr lang="en-US" altLang="ko-KR" sz="1008" b="1">
                 <a:solidFill>
                   <a:srgbClr val="111827"/>
                 </a:solidFill>
                 <a:latin typeface="Aptos" panose="020B0004020202020204" pitchFamily="34" charset="0"/>
               </a:rPr>
-              <a:t>Feature Coverage</a:t>
-            </a:r>
-            <a:endParaRPr lang="ko-KR" altLang="en-US" sz="1728" b="1">
+              <a:t>Native tables + charts</a:t>
+            </a:r>
+            <a:endParaRPr lang="ko-KR" altLang="en-US" sz="1008" b="1">
               <a:solidFill>
                 <a:srgbClr val="111827"/>
               </a:solidFill>
@@ -5284,10 +5034,10 @@
       </p:sp>
       <p:sp>
         <p:nvSpPr>
-          <p:cNvPr id="45" name="사각형: 둥근 모서리 44">
-            <a:extLst>
-              <a:ext uri="{FF2B5EF4-FFF2-40B4-BE49-F238E27FC236}">
-                <a16:creationId xmlns:a16="http://schemas.microsoft.com/office/drawing/2014/main" id="{130AA0EC-F13B-9BA9-E5EF-5E892E4A9760}"/>
+          <p:cNvPr id="37" name="타원 36">
+            <a:extLst>
+              <a:ext uri="{FF2B5EF4-FFF2-40B4-BE49-F238E27FC236}">
+                <a16:creationId xmlns:a16="http://schemas.microsoft.com/office/drawing/2014/main" id="{DD9FB404-0E80-973B-85B0-E8210381609F}"/>
               </a:ext>
             </a:extLst>
           </p:cNvPr>
@@ -5296,18 +5046,18 @@
         </p:nvSpPr>
         <p:spPr>
           <a:xfrm>
-            <a:off x="9219970" y="3032760"/>
-            <a:ext cx="1859234" cy="320040"/>
-          </a:xfrm>
-          <a:prstGeom prst="roundRect">
+            <a:off x="7741727" y="4023360"/>
+            <a:ext cx="121916" cy="121920"/>
+          </a:xfrm>
+          <a:prstGeom prst="ellipse">
             <a:avLst/>
           </a:prstGeom>
           <a:solidFill>
-            <a:srgbClr val="FFFFFF"/>
+            <a:srgbClr val="6366F1"/>
           </a:solidFill>
-          <a:ln w="10668">
+          <a:ln w="6350">
             <a:solidFill>
-              <a:srgbClr val="14B8A6"/>
+              <a:srgbClr val="6366F1"/>
             </a:solidFill>
           </a:ln>
         </p:spPr>
@@ -5338,10 +5088,56 @@
       </p:sp>
       <p:sp>
         <p:nvSpPr>
-          <p:cNvPr id="46" name="타원 45">
-            <a:extLst>
-              <a:ext uri="{FF2B5EF4-FFF2-40B4-BE49-F238E27FC236}">
-                <a16:creationId xmlns:a16="http://schemas.microsoft.com/office/drawing/2014/main" id="{62CEC64E-A837-6214-8DE5-1067BCBA5A6D}"/>
+          <p:cNvPr id="38" name="TextBox 37">
+            <a:extLst>
+              <a:ext uri="{FF2B5EF4-FFF2-40B4-BE49-F238E27FC236}">
+                <a16:creationId xmlns:a16="http://schemas.microsoft.com/office/drawing/2014/main" id="{235CDED1-334A-B1B9-59A2-8450081B2179}"/>
+              </a:ext>
+            </a:extLst>
+          </p:cNvPr>
+          <p:cNvSpPr txBox="1"/>
+          <p:nvPr/>
+        </p:nvSpPr>
+        <p:spPr>
+          <a:xfrm>
+            <a:off x="7955081" y="3977640"/>
+            <a:ext cx="2514537" cy="369332"/>
+          </a:xfrm>
+          <a:prstGeom prst="rect">
+            <a:avLst/>
+          </a:prstGeom>
+          <a:noFill/>
+        </p:spPr>
+        <p:txBody>
+          <a:bodyPr vert="horz" wrap="square" lIns="0" tIns="0" rIns="0" bIns="0" rtlCol="0" anchor="ctr">
+            <a:noAutofit/>
+          </a:bodyPr>
+          <a:lstStyle/>
+          <a:p>
+            <a:r>
+              <a:rPr lang="en-US" altLang="ko-KR" sz="1008" b="1">
+                <a:solidFill>
+                  <a:srgbClr val="111827"/>
+                </a:solidFill>
+                <a:latin typeface="Aptos" panose="020B0004020202020204" pitchFamily="34" charset="0"/>
+              </a:rPr>
+              <a:t>Overflow and scale checks</a:t>
+            </a:r>
+            <a:endParaRPr lang="ko-KR" altLang="en-US" sz="1008" b="1">
+              <a:solidFill>
+                <a:srgbClr val="111827"/>
+              </a:solidFill>
+              <a:latin typeface="Aptos" panose="020B0004020202020204" pitchFamily="34" charset="0"/>
+            </a:endParaRPr>
+          </a:p>
+        </p:txBody>
+      </p:sp>
+      <p:sp>
+        <p:nvSpPr>
+          <p:cNvPr id="39" name="사각형: 둥근 모서리 38">
+            <a:extLst>
+              <a:ext uri="{FF2B5EF4-FFF2-40B4-BE49-F238E27FC236}">
+                <a16:creationId xmlns:a16="http://schemas.microsoft.com/office/drawing/2014/main" id="{E065C7E7-29F4-4C7A-2EEC-8FFF3538E8E2}"/>
               </a:ext>
             </a:extLst>
           </p:cNvPr>
@@ -5350,20 +5146,27 @@
         </p:nvSpPr>
         <p:spPr>
           <a:xfrm>
-            <a:off x="9326647" y="3124200"/>
-            <a:ext cx="137157" cy="137160"/>
-          </a:xfrm>
-          <a:prstGeom prst="ellipse">
+            <a:off x="7452174" y="4663440"/>
+            <a:ext cx="1082013" cy="853440"/>
+          </a:xfrm>
+          <a:prstGeom prst="roundRect">
             <a:avLst/>
           </a:prstGeom>
           <a:solidFill>
-            <a:srgbClr val="14B8A6"/>
+            <a:srgbClr val="FFFFFF"/>
           </a:solidFill>
-          <a:ln w="9144">
+          <a:ln w="7620">
             <a:solidFill>
-              <a:srgbClr val="FFFFFF"/>
+              <a:srgbClr val="334155"/>
             </a:solidFill>
           </a:ln>
+          <a:effectLst>
+            <a:outerShdw blurRad="38100" dist="28988" dir="3671352" rotWithShape="0">
+              <a:scrgbClr r="0" g="0" b="0">
+                <a:alpha val="14000"/>
+              </a:scrgbClr>
+            </a:outerShdw>
+          </a:effectLst>
         </p:spPr>
         <p:style>
           <a:lnRef idx="2">
@@ -5390,12 +5193,48 @@
           </a:p>
         </p:txBody>
       </p:sp>
-      <p:sp>
-        <p:nvSpPr>
-          <p:cNvPr id="47" name="TextBox 46">
-            <a:extLst>
-              <a:ext uri="{FF2B5EF4-FFF2-40B4-BE49-F238E27FC236}">
-                <a16:creationId xmlns:a16="http://schemas.microsoft.com/office/drawing/2014/main" id="{930F7D37-E785-ED77-606B-87C42B414DEB}"/>
+      <p:pic>
+        <p:nvPicPr>
+          <p:cNvPr id="41" name="그림 40">
+            <a:extLst>
+              <a:ext uri="{FF2B5EF4-FFF2-40B4-BE49-F238E27FC236}">
+                <a16:creationId xmlns:a16="http://schemas.microsoft.com/office/drawing/2014/main" id="{CE38B550-672D-F0EC-ED31-E04F0605A9CF}"/>
+              </a:ext>
+            </a:extLst>
+          </p:cNvPr>
+          <p:cNvPicPr>
+            <a:picLocks/>
+          </p:cNvPicPr>
+          <p:nvPr/>
+        </p:nvPicPr>
+        <p:blipFill>
+          <a:blip r:embed="rId3">
+            <a:extLst>
+              <a:ext uri="{28A0092B-C50C-407E-A947-70E740481C1C}">
+                <a14:useLocalDpi xmlns:a14="http://schemas.microsoft.com/office/drawing/2010/main" val="0"/>
+              </a:ext>
+            </a:extLst>
+          </a:blip>
+          <a:stretch>
+            <a:fillRect/>
+          </a:stretch>
+        </p:blipFill>
+        <p:spPr>
+          <a:xfrm>
+            <a:off x="7497893" y="4709160"/>
+            <a:ext cx="990575" cy="563880"/>
+          </a:xfrm>
+          <a:prstGeom prst="rect">
+            <a:avLst/>
+          </a:prstGeom>
+        </p:spPr>
+      </p:pic>
+      <p:sp>
+        <p:nvSpPr>
+          <p:cNvPr id="42" name="TextBox 41">
+            <a:extLst>
+              <a:ext uri="{FF2B5EF4-FFF2-40B4-BE49-F238E27FC236}">
+                <a16:creationId xmlns:a16="http://schemas.microsoft.com/office/drawing/2014/main" id="{9E7FCD7E-0E54-7887-8A7E-CB9FEF35EAAF}"/>
               </a:ext>
             </a:extLst>
           </p:cNvPr>
@@ -5404,8 +5243,8 @@
         </p:nvSpPr>
         <p:spPr>
           <a:xfrm>
-            <a:off x="9326647" y="3124200"/>
-            <a:ext cx="137157" cy="369332"/>
+            <a:off x="7513132" y="5318760"/>
+            <a:ext cx="960096" cy="369332"/>
           </a:xfrm>
           <a:prstGeom prst="rect">
             <a:avLst/>
@@ -5421,60 +5260,14 @@
             <a:pPr algn="ctr"/>
             <a:r>
               <a:rPr lang="en-US" altLang="ko-KR" sz="920" b="1">
-                <a:solidFill>
-                  <a:srgbClr val="FFFFFF"/>
-                </a:solidFill>
-                <a:latin typeface="Aptos" panose="020B0004020202020204" pitchFamily="34" charset="0"/>
-              </a:rPr>
-              <a:t>T</a:t>
-            </a:r>
-            <a:endParaRPr lang="ko-KR" altLang="en-US" sz="920" b="1">
-              <a:solidFill>
-                <a:srgbClr val="FFFFFF"/>
-              </a:solidFill>
-              <a:latin typeface="Aptos" panose="020B0004020202020204" pitchFamily="34" charset="0"/>
-            </a:endParaRPr>
-          </a:p>
-        </p:txBody>
-      </p:sp>
-      <p:sp>
-        <p:nvSpPr>
-          <p:cNvPr id="48" name="TextBox 47">
-            <a:extLst>
-              <a:ext uri="{FF2B5EF4-FFF2-40B4-BE49-F238E27FC236}">
-                <a16:creationId xmlns:a16="http://schemas.microsoft.com/office/drawing/2014/main" id="{A256A55A-F54B-6842-C32B-23A127CA3C93}"/>
-              </a:ext>
-            </a:extLst>
-          </p:cNvPr>
-          <p:cNvSpPr txBox="1"/>
-          <p:nvPr/>
-        </p:nvSpPr>
-        <p:spPr>
-          <a:xfrm>
-            <a:off x="9540001" y="3093720"/>
-            <a:ext cx="1432524" cy="369332"/>
-          </a:xfrm>
-          <a:prstGeom prst="rect">
-            <a:avLst/>
-          </a:prstGeom>
-          <a:noFill/>
-        </p:spPr>
-        <p:txBody>
-          <a:bodyPr vert="horz" wrap="square" lIns="0" tIns="0" rIns="0" bIns="0" rtlCol="0" anchor="ctr">
-            <a:noAutofit/>
-          </a:bodyPr>
-          <a:lstStyle/>
-          <a:p>
-            <a:r>
-              <a:rPr lang="en-US" altLang="ko-KR" sz="936" b="1">
                 <a:solidFill>
                   <a:srgbClr val="111827"/>
                 </a:solidFill>
                 <a:latin typeface="Aptos" panose="020B0004020202020204" pitchFamily="34" charset="0"/>
               </a:rPr>
-              <a:t>Theme colors</a:t>
-            </a:r>
-            <a:endParaRPr lang="ko-KR" altLang="en-US" sz="936" b="1">
+              <a:t>technical</a:t>
+            </a:r>
+            <a:endParaRPr lang="ko-KR" altLang="en-US" sz="920" b="1">
               <a:solidFill>
                 <a:srgbClr val="111827"/>
               </a:solidFill>
@@ -5485,10 +5278,57 @@
       </p:sp>
       <p:sp>
         <p:nvSpPr>
-          <p:cNvPr id="49" name="사각형: 둥근 모서리 48">
-            <a:extLst>
-              <a:ext uri="{FF2B5EF4-FFF2-40B4-BE49-F238E27FC236}">
-                <a16:creationId xmlns:a16="http://schemas.microsoft.com/office/drawing/2014/main" id="{7925BFE5-1A3B-21A0-B630-7C5D6FD972CD}"/>
+          <p:cNvPr id="43" name="TextBox 42">
+            <a:extLst>
+              <a:ext uri="{FF2B5EF4-FFF2-40B4-BE49-F238E27FC236}">
+                <a16:creationId xmlns:a16="http://schemas.microsoft.com/office/drawing/2014/main" id="{D5BBFF6C-391A-34B7-3DE9-17041B383DBA}"/>
+              </a:ext>
+            </a:extLst>
+          </p:cNvPr>
+          <p:cNvSpPr txBox="1"/>
+          <p:nvPr/>
+        </p:nvSpPr>
+        <p:spPr>
+          <a:xfrm>
+            <a:off x="7513132" y="5440680"/>
+            <a:ext cx="960096" cy="369332"/>
+          </a:xfrm>
+          <a:prstGeom prst="rect">
+            <a:avLst/>
+          </a:prstGeom>
+          <a:noFill/>
+        </p:spPr>
+        <p:txBody>
+          <a:bodyPr vert="horz" wrap="square" lIns="0" tIns="0" rIns="0" bIns="0" rtlCol="0" anchor="ctr">
+            <a:noAutofit/>
+          </a:bodyPr>
+          <a:lstStyle/>
+          <a:p>
+            <a:pPr algn="ctr"/>
+            <a:r>
+              <a:rPr lang="en-US" altLang="ko-KR" sz="920">
+                <a:solidFill>
+                  <a:srgbClr val="64748B"/>
+                </a:solidFill>
+                <a:latin typeface="Aptos" panose="020B0004020202020204" pitchFamily="34" charset="0"/>
+              </a:rPr>
+              <a:t>Cover / title</a:t>
+            </a:r>
+            <a:endParaRPr lang="ko-KR" altLang="en-US" sz="920">
+              <a:solidFill>
+                <a:srgbClr val="64748B"/>
+              </a:solidFill>
+              <a:latin typeface="Aptos" panose="020B0004020202020204" pitchFamily="34" charset="0"/>
+            </a:endParaRPr>
+          </a:p>
+        </p:txBody>
+      </p:sp>
+      <p:sp>
+        <p:nvSpPr>
+          <p:cNvPr id="44" name="사각형: 둥근 모서리 43">
+            <a:extLst>
+              <a:ext uri="{FF2B5EF4-FFF2-40B4-BE49-F238E27FC236}">
+                <a16:creationId xmlns:a16="http://schemas.microsoft.com/office/drawing/2014/main" id="{393D224E-403F-CA0B-EAB3-5B35DDF5B882}"/>
               </a:ext>
             </a:extLst>
           </p:cNvPr>
@@ -5497,8 +5337,8 @@
         </p:nvSpPr>
         <p:spPr>
           <a:xfrm>
-            <a:off x="9219970" y="3360420"/>
-            <a:ext cx="1859234" cy="320040"/>
+            <a:off x="8671344" y="4663440"/>
+            <a:ext cx="1082013" cy="853440"/>
           </a:xfrm>
           <a:prstGeom prst="roundRect">
             <a:avLst/>
@@ -5506,11 +5346,18 @@
           <a:solidFill>
             <a:srgbClr val="FFFFFF"/>
           </a:solidFill>
-          <a:ln w="10668">
+          <a:ln w="7620">
             <a:solidFill>
-              <a:srgbClr val="E9B44C"/>
+              <a:srgbClr val="334155"/>
             </a:solidFill>
           </a:ln>
+          <a:effectLst>
+            <a:outerShdw blurRad="38100" dist="28988" dir="3671352" rotWithShape="0">
+              <a:scrgbClr r="0" g="0" b="0">
+                <a:alpha val="14000"/>
+              </a:scrgbClr>
+            </a:outerShdw>
+          </a:effectLst>
         </p:spPr>
         <p:style>
           <a:lnRef idx="2">
@@ -5537,12 +5384,142 @@
           </a:p>
         </p:txBody>
       </p:sp>
-      <p:sp>
-        <p:nvSpPr>
-          <p:cNvPr id="50" name="타원 49">
-            <a:extLst>
-              <a:ext uri="{FF2B5EF4-FFF2-40B4-BE49-F238E27FC236}">
-                <a16:creationId xmlns:a16="http://schemas.microsoft.com/office/drawing/2014/main" id="{AFF8127D-B998-07B5-ADB1-390F293B0A45}"/>
+      <p:pic>
+        <p:nvPicPr>
+          <p:cNvPr id="46" name="그림 45">
+            <a:extLst>
+              <a:ext uri="{FF2B5EF4-FFF2-40B4-BE49-F238E27FC236}">
+                <a16:creationId xmlns:a16="http://schemas.microsoft.com/office/drawing/2014/main" id="{E1654201-D3D6-0DF1-DD08-ECC7D369D815}"/>
+              </a:ext>
+            </a:extLst>
+          </p:cNvPr>
+          <p:cNvPicPr>
+            <a:picLocks/>
+          </p:cNvPicPr>
+          <p:nvPr/>
+        </p:nvPicPr>
+        <p:blipFill>
+          <a:blip r:embed="rId4">
+            <a:extLst>
+              <a:ext uri="{28A0092B-C50C-407E-A947-70E740481C1C}">
+                <a14:useLocalDpi xmlns:a14="http://schemas.microsoft.com/office/drawing/2010/main" val="0"/>
+              </a:ext>
+            </a:extLst>
+          </a:blip>
+          <a:stretch>
+            <a:fillRect/>
+          </a:stretch>
+        </p:blipFill>
+        <p:spPr>
+          <a:xfrm>
+            <a:off x="8717062" y="4709160"/>
+            <a:ext cx="990575" cy="563880"/>
+          </a:xfrm>
+          <a:prstGeom prst="rect">
+            <a:avLst/>
+          </a:prstGeom>
+        </p:spPr>
+      </p:pic>
+      <p:sp>
+        <p:nvSpPr>
+          <p:cNvPr id="47" name="TextBox 46">
+            <a:extLst>
+              <a:ext uri="{FF2B5EF4-FFF2-40B4-BE49-F238E27FC236}">
+                <a16:creationId xmlns:a16="http://schemas.microsoft.com/office/drawing/2014/main" id="{92519C92-04AE-755A-AEF9-98DEEA96D6C8}"/>
+              </a:ext>
+            </a:extLst>
+          </p:cNvPr>
+          <p:cNvSpPr txBox="1"/>
+          <p:nvPr/>
+        </p:nvSpPr>
+        <p:spPr>
+          <a:xfrm>
+            <a:off x="8732302" y="5318760"/>
+            <a:ext cx="960096" cy="369332"/>
+          </a:xfrm>
+          <a:prstGeom prst="rect">
+            <a:avLst/>
+          </a:prstGeom>
+          <a:noFill/>
+        </p:spPr>
+        <p:txBody>
+          <a:bodyPr vert="horz" wrap="square" lIns="0" tIns="0" rIns="0" bIns="0" rtlCol="0" anchor="ctr">
+            <a:noAutofit/>
+          </a:bodyPr>
+          <a:lstStyle/>
+          <a:p>
+            <a:pPr algn="ctr"/>
+            <a:r>
+              <a:rPr lang="en-US" altLang="ko-KR" sz="920" b="1">
+                <a:solidFill>
+                  <a:srgbClr val="111827"/>
+                </a:solidFill>
+                <a:latin typeface="Aptos" panose="020B0004020202020204" pitchFamily="34" charset="0"/>
+              </a:rPr>
+              <a:t>glass</a:t>
+            </a:r>
+            <a:endParaRPr lang="ko-KR" altLang="en-US" sz="920" b="1">
+              <a:solidFill>
+                <a:srgbClr val="111827"/>
+              </a:solidFill>
+              <a:latin typeface="Aptos" panose="020B0004020202020204" pitchFamily="34" charset="0"/>
+            </a:endParaRPr>
+          </a:p>
+        </p:txBody>
+      </p:sp>
+      <p:sp>
+        <p:nvSpPr>
+          <p:cNvPr id="48" name="TextBox 47">
+            <a:extLst>
+              <a:ext uri="{FF2B5EF4-FFF2-40B4-BE49-F238E27FC236}">
+                <a16:creationId xmlns:a16="http://schemas.microsoft.com/office/drawing/2014/main" id="{AA17F1AD-4762-1E50-BF02-67B5FE5B4BBA}"/>
+              </a:ext>
+            </a:extLst>
+          </p:cNvPr>
+          <p:cNvSpPr txBox="1"/>
+          <p:nvPr/>
+        </p:nvSpPr>
+        <p:spPr>
+          <a:xfrm>
+            <a:off x="8732302" y="5440680"/>
+            <a:ext cx="960096" cy="369332"/>
+          </a:xfrm>
+          <a:prstGeom prst="rect">
+            <a:avLst/>
+          </a:prstGeom>
+          <a:noFill/>
+        </p:spPr>
+        <p:txBody>
+          <a:bodyPr vert="horz" wrap="square" lIns="0" tIns="0" rIns="0" bIns="0" rtlCol="0" anchor="ctr">
+            <a:noAutofit/>
+          </a:bodyPr>
+          <a:lstStyle/>
+          <a:p>
+            <a:pPr algn="ctr"/>
+            <a:r>
+              <a:rPr lang="en-US" altLang="ko-KR" sz="920">
+                <a:solidFill>
+                  <a:srgbClr val="64748B"/>
+                </a:solidFill>
+                <a:latin typeface="Aptos" panose="020B0004020202020204" pitchFamily="34" charset="0"/>
+              </a:rPr>
+              <a:t>Semantic grid</a:t>
+            </a:r>
+            <a:endParaRPr lang="ko-KR" altLang="en-US" sz="920">
+              <a:solidFill>
+                <a:srgbClr val="64748B"/>
+              </a:solidFill>
+              <a:latin typeface="Aptos" panose="020B0004020202020204" pitchFamily="34" charset="0"/>
+            </a:endParaRPr>
+          </a:p>
+        </p:txBody>
+      </p:sp>
+      <p:sp>
+        <p:nvSpPr>
+          <p:cNvPr id="49" name="사각형: 둥근 모서리 48">
+            <a:extLst>
+              <a:ext uri="{FF2B5EF4-FFF2-40B4-BE49-F238E27FC236}">
+                <a16:creationId xmlns:a16="http://schemas.microsoft.com/office/drawing/2014/main" id="{BE7F8F50-3CB6-F1FC-0F16-D23D4328FEE0}"/>
               </a:ext>
             </a:extLst>
           </p:cNvPr>
@@ -5551,20 +5528,27 @@
         </p:nvSpPr>
         <p:spPr>
           <a:xfrm>
-            <a:off x="9326647" y="3451860"/>
-            <a:ext cx="137157" cy="137160"/>
-          </a:xfrm>
-          <a:prstGeom prst="ellipse">
+            <a:off x="9890513" y="4663440"/>
+            <a:ext cx="1082013" cy="853440"/>
+          </a:xfrm>
+          <a:prstGeom prst="roundRect">
             <a:avLst/>
           </a:prstGeom>
           <a:solidFill>
-            <a:srgbClr val="E9B44C"/>
+            <a:srgbClr val="FFFFFF"/>
           </a:solidFill>
-          <a:ln w="9144">
+          <a:ln w="7620">
             <a:solidFill>
-              <a:srgbClr val="FFFFFF"/>
+              <a:srgbClr val="334155"/>
             </a:solidFill>
           </a:ln>
+          <a:effectLst>
+            <a:outerShdw blurRad="38100" dist="28988" dir="3671352" rotWithShape="0">
+              <a:scrgbClr r="0" g="0" b="0">
+                <a:alpha val="14000"/>
+              </a:scrgbClr>
+            </a:outerShdw>
+          </a:effectLst>
         </p:spPr>
         <p:style>
           <a:lnRef idx="2">
@@ -5591,12 +5575,48 @@
           </a:p>
         </p:txBody>
       </p:sp>
-      <p:sp>
-        <p:nvSpPr>
-          <p:cNvPr id="51" name="TextBox 50">
-            <a:extLst>
-              <a:ext uri="{FF2B5EF4-FFF2-40B4-BE49-F238E27FC236}">
-                <a16:creationId xmlns:a16="http://schemas.microsoft.com/office/drawing/2014/main" id="{0DF8D305-6C9F-A15F-9C88-97EBEF625878}"/>
+      <p:pic>
+        <p:nvPicPr>
+          <p:cNvPr id="51" name="그림 50">
+            <a:extLst>
+              <a:ext uri="{FF2B5EF4-FFF2-40B4-BE49-F238E27FC236}">
+                <a16:creationId xmlns:a16="http://schemas.microsoft.com/office/drawing/2014/main" id="{630AF9CF-13FC-AFA3-DC45-E1296B37F096}"/>
+              </a:ext>
+            </a:extLst>
+          </p:cNvPr>
+          <p:cNvPicPr>
+            <a:picLocks/>
+          </p:cNvPicPr>
+          <p:nvPr/>
+        </p:nvPicPr>
+        <p:blipFill>
+          <a:blip r:embed="rId5">
+            <a:extLst>
+              <a:ext uri="{28A0092B-C50C-407E-A947-70E740481C1C}">
+                <a14:useLocalDpi xmlns:a14="http://schemas.microsoft.com/office/drawing/2010/main" val="0"/>
+              </a:ext>
+            </a:extLst>
+          </a:blip>
+          <a:stretch>
+            <a:fillRect/>
+          </a:stretch>
+        </p:blipFill>
+        <p:spPr>
+          <a:xfrm>
+            <a:off x="9936231" y="4709160"/>
+            <a:ext cx="990575" cy="563880"/>
+          </a:xfrm>
+          <a:prstGeom prst="rect">
+            <a:avLst/>
+          </a:prstGeom>
+        </p:spPr>
+      </p:pic>
+      <p:sp>
+        <p:nvSpPr>
+          <p:cNvPr id="52" name="TextBox 51">
+            <a:extLst>
+              <a:ext uri="{FF2B5EF4-FFF2-40B4-BE49-F238E27FC236}">
+                <a16:creationId xmlns:a16="http://schemas.microsoft.com/office/drawing/2014/main" id="{F8470964-AD81-244A-60E0-17209931ED84}"/>
               </a:ext>
             </a:extLst>
           </p:cNvPr>
@@ -5605,8 +5625,8 @@
         </p:nvSpPr>
         <p:spPr>
           <a:xfrm>
-            <a:off x="9326647" y="3451860"/>
-            <a:ext cx="137157" cy="369332"/>
+            <a:off x="9951471" y="5318760"/>
+            <a:ext cx="960096" cy="369332"/>
           </a:xfrm>
           <a:prstGeom prst="rect">
             <a:avLst/>
@@ -5622,60 +5642,14 @@
             <a:pPr algn="ctr"/>
             <a:r>
               <a:rPr lang="en-US" altLang="ko-KR" sz="920" b="1">
-                <a:solidFill>
-                  <a:srgbClr val="FFFFFF"/>
-                </a:solidFill>
-                <a:latin typeface="Aptos" panose="020B0004020202020204" pitchFamily="34" charset="0"/>
-              </a:rPr>
-              <a:t>S</a:t>
-            </a:r>
-            <a:endParaRPr lang="ko-KR" altLang="en-US" sz="920" b="1">
-              <a:solidFill>
-                <a:srgbClr val="FFFFFF"/>
-              </a:solidFill>
-              <a:latin typeface="Aptos" panose="020B0004020202020204" pitchFamily="34" charset="0"/>
-            </a:endParaRPr>
-          </a:p>
-        </p:txBody>
-      </p:sp>
-      <p:sp>
-        <p:nvSpPr>
-          <p:cNvPr id="52" name="TextBox 51">
-            <a:extLst>
-              <a:ext uri="{FF2B5EF4-FFF2-40B4-BE49-F238E27FC236}">
-                <a16:creationId xmlns:a16="http://schemas.microsoft.com/office/drawing/2014/main" id="{72DF39AC-06CF-0D81-490C-ED2962764021}"/>
-              </a:ext>
-            </a:extLst>
-          </p:cNvPr>
-          <p:cNvSpPr txBox="1"/>
-          <p:nvPr/>
-        </p:nvSpPr>
-        <p:spPr>
-          <a:xfrm>
-            <a:off x="9540001" y="3421380"/>
-            <a:ext cx="1432524" cy="369332"/>
-          </a:xfrm>
-          <a:prstGeom prst="rect">
-            <a:avLst/>
-          </a:prstGeom>
-          <a:noFill/>
-        </p:spPr>
-        <p:txBody>
-          <a:bodyPr vert="horz" wrap="square" lIns="0" tIns="0" rIns="0" bIns="0" rtlCol="0" anchor="ctr">
-            <a:noAutofit/>
-          </a:bodyPr>
-          <a:lstStyle/>
-          <a:p>
-            <a:r>
-              <a:rPr lang="en-US" altLang="ko-KR" sz="936" b="1">
                 <a:solidFill>
                   <a:srgbClr val="111827"/>
                 </a:solidFill>
                 <a:latin typeface="Aptos" panose="020B0004020202020204" pitchFamily="34" charset="0"/>
               </a:rPr>
-              <a:t>SVG surfaces</a:t>
-            </a:r>
-            <a:endParaRPr lang="ko-KR" altLang="en-US" sz="936" b="1">
+              <a:t>magazine</a:t>
+            </a:r>
+            <a:endParaRPr lang="ko-KR" altLang="en-US" sz="920" b="1">
               <a:solidFill>
                 <a:srgbClr val="111827"/>
               </a:solidFill>
@@ -5686,10 +5660,57 @@
       </p:sp>
       <p:sp>
         <p:nvSpPr>
-          <p:cNvPr id="53" name="사각형: 둥근 모서리 52">
-            <a:extLst>
-              <a:ext uri="{FF2B5EF4-FFF2-40B4-BE49-F238E27FC236}">
-                <a16:creationId xmlns:a16="http://schemas.microsoft.com/office/drawing/2014/main" id="{21877671-7E78-33CB-F110-A1A7435D1214}"/>
+          <p:cNvPr id="53" name="TextBox 52">
+            <a:extLst>
+              <a:ext uri="{FF2B5EF4-FFF2-40B4-BE49-F238E27FC236}">
+                <a16:creationId xmlns:a16="http://schemas.microsoft.com/office/drawing/2014/main" id="{58588BB2-8DDB-749D-2DCC-7FA93D4D3CC2}"/>
+              </a:ext>
+            </a:extLst>
+          </p:cNvPr>
+          <p:cNvSpPr txBox="1"/>
+          <p:nvPr/>
+        </p:nvSpPr>
+        <p:spPr>
+          <a:xfrm>
+            <a:off x="9951471" y="5440680"/>
+            <a:ext cx="960096" cy="369332"/>
+          </a:xfrm>
+          <a:prstGeom prst="rect">
+            <a:avLst/>
+          </a:prstGeom>
+          <a:noFill/>
+        </p:spPr>
+        <p:txBody>
+          <a:bodyPr vert="horz" wrap="square" lIns="0" tIns="0" rIns="0" bIns="0" rtlCol="0" anchor="ctr">
+            <a:noAutofit/>
+          </a:bodyPr>
+          <a:lstStyle/>
+          <a:p>
+            <a:pPr algn="ctr"/>
+            <a:r>
+              <a:rPr lang="en-US" altLang="ko-KR" sz="920">
+                <a:solidFill>
+                  <a:srgbClr val="64748B"/>
+                </a:solidFill>
+                <a:latin typeface="Aptos" panose="020B0004020202020204" pitchFamily="34" charset="0"/>
+              </a:rPr>
+              <a:t>Object grammar</a:t>
+            </a:r>
+            <a:endParaRPr lang="ko-KR" altLang="en-US" sz="920">
+              <a:solidFill>
+                <a:srgbClr val="64748B"/>
+              </a:solidFill>
+              <a:latin typeface="Aptos" panose="020B0004020202020204" pitchFamily="34" charset="0"/>
+            </a:endParaRPr>
+          </a:p>
+        </p:txBody>
+      </p:sp>
+      <p:sp>
+        <p:nvSpPr>
+          <p:cNvPr id="54" name="사각형: 둥근 모서리 53">
+            <a:extLst>
+              <a:ext uri="{FF2B5EF4-FFF2-40B4-BE49-F238E27FC236}">
+                <a16:creationId xmlns:a16="http://schemas.microsoft.com/office/drawing/2014/main" id="{BE17E45D-6201-9853-4ECA-C6676C604FB8}"/>
               </a:ext>
             </a:extLst>
           </p:cNvPr>
@@ -5698,18 +5719,18 @@
         </p:nvSpPr>
         <p:spPr>
           <a:xfrm>
-            <a:off x="9219970" y="3688080"/>
-            <a:ext cx="1859234" cy="320040"/>
+            <a:off x="960096" y="5516880"/>
+            <a:ext cx="6034889" cy="563880"/>
           </a:xfrm>
           <a:prstGeom prst="roundRect">
             <a:avLst/>
           </a:prstGeom>
           <a:solidFill>
-            <a:srgbClr val="FFFFFF"/>
+            <a:srgbClr val="17213A"/>
           </a:solidFill>
-          <a:ln w="10668">
+          <a:ln w="11430">
             <a:solidFill>
-              <a:srgbClr val="8B7CF6"/>
+              <a:srgbClr val="22D3EE"/>
             </a:solidFill>
           </a:ln>
         </p:spPr>
@@ -5740,64 +5761,10 @@
       </p:sp>
       <p:sp>
         <p:nvSpPr>
-          <p:cNvPr id="54" name="타원 53">
-            <a:extLst>
-              <a:ext uri="{FF2B5EF4-FFF2-40B4-BE49-F238E27FC236}">
-                <a16:creationId xmlns:a16="http://schemas.microsoft.com/office/drawing/2014/main" id="{361AECED-BE96-93C8-02D4-E952D0165DA8}"/>
-              </a:ext>
-            </a:extLst>
-          </p:cNvPr>
-          <p:cNvSpPr/>
-          <p:nvPr/>
-        </p:nvSpPr>
-        <p:spPr>
-          <a:xfrm>
-            <a:off x="9326647" y="3779520"/>
-            <a:ext cx="137157" cy="137160"/>
-          </a:xfrm>
-          <a:prstGeom prst="ellipse">
-            <a:avLst/>
-          </a:prstGeom>
-          <a:solidFill>
-            <a:srgbClr val="8B7CF6"/>
-          </a:solidFill>
-          <a:ln w="9144">
-            <a:solidFill>
-              <a:srgbClr val="FFFFFF"/>
-            </a:solidFill>
-          </a:ln>
-        </p:spPr>
-        <p:style>
-          <a:lnRef idx="2">
-            <a:schemeClr val="accent1">
-              <a:shade val="15000"/>
-            </a:schemeClr>
-          </a:lnRef>
-          <a:fillRef idx="1">
-            <a:schemeClr val="accent1"/>
-          </a:fillRef>
-          <a:effectRef idx="0">
-            <a:schemeClr val="accent1"/>
-          </a:effectRef>
-          <a:fontRef idx="minor">
-            <a:schemeClr val="lt1"/>
-          </a:fontRef>
-        </p:style>
-        <p:txBody>
-          <a:bodyPr rtlCol="0" anchor="ctr"/>
-          <a:lstStyle/>
-          <a:p>
-            <a:pPr algn="ctr"/>
-            <a:endParaRPr lang="ko-KR" altLang="en-US"/>
-          </a:p>
-        </p:txBody>
-      </p:sp>
-      <p:sp>
-        <p:nvSpPr>
           <p:cNvPr id="55" name="TextBox 54">
             <a:extLst>
               <a:ext uri="{FF2B5EF4-FFF2-40B4-BE49-F238E27FC236}">
-                <a16:creationId xmlns:a16="http://schemas.microsoft.com/office/drawing/2014/main" id="{281B623C-40AD-ADD6-7D48-27774D71EC1C}"/>
+                <a16:creationId xmlns:a16="http://schemas.microsoft.com/office/drawing/2014/main" id="{D55481FB-7939-C065-8AF6-188CD4432AC0}"/>
               </a:ext>
             </a:extLst>
           </p:cNvPr>
@@ -5806,8 +5773,8 @@
         </p:nvSpPr>
         <p:spPr>
           <a:xfrm>
-            <a:off x="9326647" y="3779520"/>
-            <a:ext cx="137157" cy="369332"/>
+            <a:off x="1203930" y="5654040"/>
+            <a:ext cx="1904952" cy="369332"/>
           </a:xfrm>
           <a:prstGeom prst="rect">
             <a:avLst/>
@@ -5820,17 +5787,16 @@
           </a:bodyPr>
           <a:lstStyle/>
           <a:p>
-            <a:pPr algn="ctr"/>
-            <a:r>
-              <a:rPr lang="en-US" altLang="ko-KR" sz="920" b="1">
+            <a:r>
+              <a:rPr lang="en-US" altLang="ko-KR" sz="1224" b="1">
                 <a:solidFill>
                   <a:srgbClr val="FFFFFF"/>
                 </a:solidFill>
                 <a:latin typeface="Aptos" panose="020B0004020202020204" pitchFamily="34" charset="0"/>
               </a:rPr>
-              <a:t>P</a:t>
-            </a:r>
-            <a:endParaRPr lang="ko-KR" altLang="en-US" sz="920" b="1">
+              <a:t>Built from real MDPR results</a:t>
+            </a:r>
+            <a:endParaRPr lang="ko-KR" altLang="en-US" sz="1224" b="1">
               <a:solidFill>
                 <a:srgbClr val="FFFFFF"/>
               </a:solidFill>
@@ -5844,7 +5810,7 @@
           <p:cNvPr id="56" name="TextBox 55">
             <a:extLst>
               <a:ext uri="{FF2B5EF4-FFF2-40B4-BE49-F238E27FC236}">
-                <a16:creationId xmlns:a16="http://schemas.microsoft.com/office/drawing/2014/main" id="{7C9B7E0E-D33A-F1A7-655E-E31C2330281E}"/>
+                <a16:creationId xmlns:a16="http://schemas.microsoft.com/office/drawing/2014/main" id="{A65C749C-8336-EA23-A496-F2CF1F6BABEF}"/>
               </a:ext>
             </a:extLst>
           </p:cNvPr>
@@ -5853,8 +5819,8 @@
         </p:nvSpPr>
         <p:spPr>
           <a:xfrm>
-            <a:off x="9540001" y="3749040"/>
-            <a:ext cx="1432524" cy="369332"/>
+            <a:off x="3200320" y="5654040"/>
+            <a:ext cx="3276518" cy="369332"/>
           </a:xfrm>
           <a:prstGeom prst="rect">
             <a:avLst/>
@@ -5868,766 +5834,15 @@
           <a:lstStyle/>
           <a:p>
             <a:r>
-              <a:rPr lang="en-US" altLang="ko-KR" sz="936" b="1">
-                <a:solidFill>
-                  <a:srgbClr val="111827"/>
-                </a:solidFill>
-                <a:latin typeface="Aptos" panose="020B0004020202020204" pitchFamily="34" charset="0"/>
-              </a:rPr>
-              <a:t>Proof objects</a:t>
-            </a:r>
-            <a:endParaRPr lang="ko-KR" altLang="en-US" sz="936" b="1">
-              <a:solidFill>
-                <a:srgbClr val="111827"/>
-              </a:solidFill>
-              <a:latin typeface="Aptos" panose="020B0004020202020204" pitchFamily="34" charset="0"/>
-            </a:endParaRPr>
-          </a:p>
-        </p:txBody>
-      </p:sp>
-      <p:sp>
-        <p:nvSpPr>
-          <p:cNvPr id="57" name="사각형: 둥근 모서리 56">
-            <a:extLst>
-              <a:ext uri="{FF2B5EF4-FFF2-40B4-BE49-F238E27FC236}">
-                <a16:creationId xmlns:a16="http://schemas.microsoft.com/office/drawing/2014/main" id="{15AFD296-6CA8-3686-6D62-151BC9658DFD}"/>
-              </a:ext>
-            </a:extLst>
-          </p:cNvPr>
-          <p:cNvSpPr/>
-          <p:nvPr/>
-        </p:nvSpPr>
-        <p:spPr>
-          <a:xfrm>
-            <a:off x="9219970" y="4015740"/>
-            <a:ext cx="1859234" cy="320040"/>
-          </a:xfrm>
-          <a:prstGeom prst="roundRect">
-            <a:avLst/>
-          </a:prstGeom>
-          <a:solidFill>
-            <a:srgbClr val="FFFFFF"/>
-          </a:solidFill>
-          <a:ln w="10668">
-            <a:solidFill>
-              <a:srgbClr val="BE123C"/>
-            </a:solidFill>
-          </a:ln>
-        </p:spPr>
-        <p:style>
-          <a:lnRef idx="2">
-            <a:schemeClr val="accent1">
-              <a:shade val="15000"/>
-            </a:schemeClr>
-          </a:lnRef>
-          <a:fillRef idx="1">
-            <a:schemeClr val="accent1"/>
-          </a:fillRef>
-          <a:effectRef idx="0">
-            <a:schemeClr val="accent1"/>
-          </a:effectRef>
-          <a:fontRef idx="minor">
-            <a:schemeClr val="lt1"/>
-          </a:fontRef>
-        </p:style>
-        <p:txBody>
-          <a:bodyPr rtlCol="0" anchor="ctr"/>
-          <a:lstStyle/>
-          <a:p>
-            <a:pPr algn="ctr"/>
-            <a:endParaRPr lang="ko-KR" altLang="en-US"/>
-          </a:p>
-        </p:txBody>
-      </p:sp>
-      <p:sp>
-        <p:nvSpPr>
-          <p:cNvPr id="58" name="타원 57">
-            <a:extLst>
-              <a:ext uri="{FF2B5EF4-FFF2-40B4-BE49-F238E27FC236}">
-                <a16:creationId xmlns:a16="http://schemas.microsoft.com/office/drawing/2014/main" id="{DF9B09E1-26E9-508A-BBB0-950182A031A8}"/>
-              </a:ext>
-            </a:extLst>
-          </p:cNvPr>
-          <p:cNvSpPr/>
-          <p:nvPr/>
-        </p:nvSpPr>
-        <p:spPr>
-          <a:xfrm>
-            <a:off x="9326647" y="4107180"/>
-            <a:ext cx="137157" cy="137160"/>
-          </a:xfrm>
-          <a:prstGeom prst="ellipse">
-            <a:avLst/>
-          </a:prstGeom>
-          <a:solidFill>
-            <a:srgbClr val="BE123C"/>
-          </a:solidFill>
-          <a:ln w="9144">
-            <a:solidFill>
-              <a:srgbClr val="FFFFFF"/>
-            </a:solidFill>
-          </a:ln>
-        </p:spPr>
-        <p:style>
-          <a:lnRef idx="2">
-            <a:schemeClr val="accent1">
-              <a:shade val="15000"/>
-            </a:schemeClr>
-          </a:lnRef>
-          <a:fillRef idx="1">
-            <a:schemeClr val="accent1"/>
-          </a:fillRef>
-          <a:effectRef idx="0">
-            <a:schemeClr val="accent1"/>
-          </a:effectRef>
-          <a:fontRef idx="minor">
-            <a:schemeClr val="lt1"/>
-          </a:fontRef>
-        </p:style>
-        <p:txBody>
-          <a:bodyPr rtlCol="0" anchor="ctr"/>
-          <a:lstStyle/>
-          <a:p>
-            <a:pPr algn="ctr"/>
-            <a:endParaRPr lang="ko-KR" altLang="en-US"/>
-          </a:p>
-        </p:txBody>
-      </p:sp>
-      <p:sp>
-        <p:nvSpPr>
-          <p:cNvPr id="59" name="TextBox 58">
-            <a:extLst>
-              <a:ext uri="{FF2B5EF4-FFF2-40B4-BE49-F238E27FC236}">
-                <a16:creationId xmlns:a16="http://schemas.microsoft.com/office/drawing/2014/main" id="{42536AF2-31F4-0761-82C5-90521BBCD0C2}"/>
-              </a:ext>
-            </a:extLst>
-          </p:cNvPr>
-          <p:cNvSpPr txBox="1"/>
-          <p:nvPr/>
-        </p:nvSpPr>
-        <p:spPr>
-          <a:xfrm>
-            <a:off x="9326647" y="4107180"/>
-            <a:ext cx="137157" cy="369332"/>
-          </a:xfrm>
-          <a:prstGeom prst="rect">
-            <a:avLst/>
-          </a:prstGeom>
-          <a:noFill/>
-        </p:spPr>
-        <p:txBody>
-          <a:bodyPr vert="horz" wrap="square" lIns="0" tIns="0" rIns="0" bIns="0" rtlCol="0" anchor="ctr">
-            <a:noAutofit/>
-          </a:bodyPr>
-          <a:lstStyle/>
-          <a:p>
-            <a:pPr algn="ctr"/>
-            <a:r>
-              <a:rPr lang="en-US" altLang="ko-KR" sz="920" b="1">
-                <a:solidFill>
-                  <a:srgbClr val="FFFFFF"/>
-                </a:solidFill>
-                <a:latin typeface="Aptos" panose="020B0004020202020204" pitchFamily="34" charset="0"/>
-              </a:rPr>
-              <a:t>N</a:t>
-            </a:r>
-            <a:endParaRPr lang="ko-KR" altLang="en-US" sz="920" b="1">
-              <a:solidFill>
-                <a:srgbClr val="FFFFFF"/>
-              </a:solidFill>
-              <a:latin typeface="Aptos" panose="020B0004020202020204" pitchFamily="34" charset="0"/>
-            </a:endParaRPr>
-          </a:p>
-        </p:txBody>
-      </p:sp>
-      <p:sp>
-        <p:nvSpPr>
-          <p:cNvPr id="60" name="TextBox 59">
-            <a:extLst>
-              <a:ext uri="{FF2B5EF4-FFF2-40B4-BE49-F238E27FC236}">
-                <a16:creationId xmlns:a16="http://schemas.microsoft.com/office/drawing/2014/main" id="{51A49513-2082-85AE-7ABD-BDD58EB9C7AD}"/>
-              </a:ext>
-            </a:extLst>
-          </p:cNvPr>
-          <p:cNvSpPr txBox="1"/>
-          <p:nvPr/>
-        </p:nvSpPr>
-        <p:spPr>
-          <a:xfrm>
-            <a:off x="9540001" y="4076700"/>
-            <a:ext cx="1432524" cy="369332"/>
-          </a:xfrm>
-          <a:prstGeom prst="rect">
-            <a:avLst/>
-          </a:prstGeom>
-          <a:noFill/>
-        </p:spPr>
-        <p:txBody>
-          <a:bodyPr vert="horz" wrap="square" lIns="0" tIns="0" rIns="0" bIns="0" rtlCol="0" anchor="ctr">
-            <a:noAutofit/>
-          </a:bodyPr>
-          <a:lstStyle/>
-          <a:p>
-            <a:r>
-              <a:rPr lang="en-US" altLang="ko-KR" sz="936" b="1">
-                <a:solidFill>
-                  <a:srgbClr val="111827"/>
-                </a:solidFill>
-                <a:latin typeface="Aptos" panose="020B0004020202020204" pitchFamily="34" charset="0"/>
-              </a:rPr>
-              <a:t>Native tables</a:t>
-            </a:r>
-            <a:endParaRPr lang="ko-KR" altLang="en-US" sz="936" b="1">
-              <a:solidFill>
-                <a:srgbClr val="111827"/>
-              </a:solidFill>
-              <a:latin typeface="Aptos" panose="020B0004020202020204" pitchFamily="34" charset="0"/>
-            </a:endParaRPr>
-          </a:p>
-        </p:txBody>
-      </p:sp>
-      <p:sp>
-        <p:nvSpPr>
-          <p:cNvPr id="61" name="사각형: 둥근 모서리 60">
-            <a:extLst>
-              <a:ext uri="{FF2B5EF4-FFF2-40B4-BE49-F238E27FC236}">
-                <a16:creationId xmlns:a16="http://schemas.microsoft.com/office/drawing/2014/main" id="{B1337FDF-A3D1-D3DF-A8A2-FCC54204D729}"/>
-              </a:ext>
-            </a:extLst>
-          </p:cNvPr>
-          <p:cNvSpPr/>
-          <p:nvPr/>
-        </p:nvSpPr>
-        <p:spPr>
-          <a:xfrm>
-            <a:off x="9219970" y="4343400"/>
-            <a:ext cx="1859234" cy="320040"/>
-          </a:xfrm>
-          <a:prstGeom prst="roundRect">
-            <a:avLst/>
-          </a:prstGeom>
-          <a:solidFill>
-            <a:srgbClr val="FFFFFF"/>
-          </a:solidFill>
-          <a:ln w="10668">
-            <a:solidFill>
-              <a:srgbClr val="86A789"/>
-            </a:solidFill>
-          </a:ln>
-        </p:spPr>
-        <p:style>
-          <a:lnRef idx="2">
-            <a:schemeClr val="accent1">
-              <a:shade val="15000"/>
-            </a:schemeClr>
-          </a:lnRef>
-          <a:fillRef idx="1">
-            <a:schemeClr val="accent1"/>
-          </a:fillRef>
-          <a:effectRef idx="0">
-            <a:schemeClr val="accent1"/>
-          </a:effectRef>
-          <a:fontRef idx="minor">
-            <a:schemeClr val="lt1"/>
-          </a:fontRef>
-        </p:style>
-        <p:txBody>
-          <a:bodyPr rtlCol="0" anchor="ctr"/>
-          <a:lstStyle/>
-          <a:p>
-            <a:pPr algn="ctr"/>
-            <a:endParaRPr lang="ko-KR" altLang="en-US"/>
-          </a:p>
-        </p:txBody>
-      </p:sp>
-      <p:sp>
-        <p:nvSpPr>
-          <p:cNvPr id="62" name="타원 61">
-            <a:extLst>
-              <a:ext uri="{FF2B5EF4-FFF2-40B4-BE49-F238E27FC236}">
-                <a16:creationId xmlns:a16="http://schemas.microsoft.com/office/drawing/2014/main" id="{5D313F73-D468-9307-7B52-928253F11933}"/>
-              </a:ext>
-            </a:extLst>
-          </p:cNvPr>
-          <p:cNvSpPr/>
-          <p:nvPr/>
-        </p:nvSpPr>
-        <p:spPr>
-          <a:xfrm>
-            <a:off x="9326647" y="4434840"/>
-            <a:ext cx="137157" cy="137160"/>
-          </a:xfrm>
-          <a:prstGeom prst="ellipse">
-            <a:avLst/>
-          </a:prstGeom>
-          <a:solidFill>
-            <a:srgbClr val="86A789"/>
-          </a:solidFill>
-          <a:ln w="9144">
-            <a:solidFill>
-              <a:srgbClr val="FFFFFF"/>
-            </a:solidFill>
-          </a:ln>
-        </p:spPr>
-        <p:style>
-          <a:lnRef idx="2">
-            <a:schemeClr val="accent1">
-              <a:shade val="15000"/>
-            </a:schemeClr>
-          </a:lnRef>
-          <a:fillRef idx="1">
-            <a:schemeClr val="accent1"/>
-          </a:fillRef>
-          <a:effectRef idx="0">
-            <a:schemeClr val="accent1"/>
-          </a:effectRef>
-          <a:fontRef idx="minor">
-            <a:schemeClr val="lt1"/>
-          </a:fontRef>
-        </p:style>
-        <p:txBody>
-          <a:bodyPr rtlCol="0" anchor="ctr"/>
-          <a:lstStyle/>
-          <a:p>
-            <a:pPr algn="ctr"/>
-            <a:endParaRPr lang="ko-KR" altLang="en-US"/>
-          </a:p>
-        </p:txBody>
-      </p:sp>
-      <p:sp>
-        <p:nvSpPr>
-          <p:cNvPr id="63" name="TextBox 62">
-            <a:extLst>
-              <a:ext uri="{FF2B5EF4-FFF2-40B4-BE49-F238E27FC236}">
-                <a16:creationId xmlns:a16="http://schemas.microsoft.com/office/drawing/2014/main" id="{8FFD3150-F952-2744-4D0E-F81A097CC07A}"/>
-              </a:ext>
-            </a:extLst>
-          </p:cNvPr>
-          <p:cNvSpPr txBox="1"/>
-          <p:nvPr/>
-        </p:nvSpPr>
-        <p:spPr>
-          <a:xfrm>
-            <a:off x="9326647" y="4434840"/>
-            <a:ext cx="137157" cy="369332"/>
-          </a:xfrm>
-          <a:prstGeom prst="rect">
-            <a:avLst/>
-          </a:prstGeom>
-          <a:noFill/>
-        </p:spPr>
-        <p:txBody>
-          <a:bodyPr vert="horz" wrap="square" lIns="0" tIns="0" rIns="0" bIns="0" rtlCol="0" anchor="ctr">
-            <a:noAutofit/>
-          </a:bodyPr>
-          <a:lstStyle/>
-          <a:p>
-            <a:pPr algn="ctr"/>
-            <a:r>
-              <a:rPr lang="en-US" altLang="ko-KR" sz="920" b="1">
-                <a:solidFill>
-                  <a:srgbClr val="FFFFFF"/>
-                </a:solidFill>
-                <a:latin typeface="Aptos" panose="020B0004020202020204" pitchFamily="34" charset="0"/>
-              </a:rPr>
-              <a:t>C</a:t>
-            </a:r>
-            <a:endParaRPr lang="ko-KR" altLang="en-US" sz="920" b="1">
-              <a:solidFill>
-                <a:srgbClr val="FFFFFF"/>
-              </a:solidFill>
-              <a:latin typeface="Aptos" panose="020B0004020202020204" pitchFamily="34" charset="0"/>
-            </a:endParaRPr>
-          </a:p>
-        </p:txBody>
-      </p:sp>
-      <p:sp>
-        <p:nvSpPr>
-          <p:cNvPr id="64" name="TextBox 63">
-            <a:extLst>
-              <a:ext uri="{FF2B5EF4-FFF2-40B4-BE49-F238E27FC236}">
-                <a16:creationId xmlns:a16="http://schemas.microsoft.com/office/drawing/2014/main" id="{5BCA9980-2914-9927-B7BD-603EDBBFFFED}"/>
-              </a:ext>
-            </a:extLst>
-          </p:cNvPr>
-          <p:cNvSpPr txBox="1"/>
-          <p:nvPr/>
-        </p:nvSpPr>
-        <p:spPr>
-          <a:xfrm>
-            <a:off x="9540001" y="4404360"/>
-            <a:ext cx="1432524" cy="369332"/>
-          </a:xfrm>
-          <a:prstGeom prst="rect">
-            <a:avLst/>
-          </a:prstGeom>
-          <a:noFill/>
-        </p:spPr>
-        <p:txBody>
-          <a:bodyPr vert="horz" wrap="square" lIns="0" tIns="0" rIns="0" bIns="0" rtlCol="0" anchor="ctr">
-            <a:noAutofit/>
-          </a:bodyPr>
-          <a:lstStyle/>
-          <a:p>
-            <a:r>
-              <a:rPr lang="en-US" altLang="ko-KR" sz="936" b="1">
-                <a:solidFill>
-                  <a:srgbClr val="111827"/>
-                </a:solidFill>
-                <a:latin typeface="Aptos" panose="020B0004020202020204" pitchFamily="34" charset="0"/>
-              </a:rPr>
-              <a:t>Charts + prose</a:t>
-            </a:r>
-            <a:endParaRPr lang="ko-KR" altLang="en-US" sz="936" b="1">
-              <a:solidFill>
-                <a:srgbClr val="111827"/>
-              </a:solidFill>
-              <a:latin typeface="Aptos" panose="020B0004020202020204" pitchFamily="34" charset="0"/>
-            </a:endParaRPr>
-          </a:p>
-        </p:txBody>
-      </p:sp>
-      <p:sp>
-        <p:nvSpPr>
-          <p:cNvPr id="65" name="사각형: 둥근 모서리 64">
-            <a:extLst>
-              <a:ext uri="{FF2B5EF4-FFF2-40B4-BE49-F238E27FC236}">
-                <a16:creationId xmlns:a16="http://schemas.microsoft.com/office/drawing/2014/main" id="{13AF8765-115C-4FF1-A4F3-76A93B7D66FB}"/>
-              </a:ext>
-            </a:extLst>
-          </p:cNvPr>
-          <p:cNvSpPr/>
-          <p:nvPr/>
-        </p:nvSpPr>
-        <p:spPr>
-          <a:xfrm>
-            <a:off x="9219970" y="4671060"/>
-            <a:ext cx="1859234" cy="320040"/>
-          </a:xfrm>
-          <a:prstGeom prst="roundRect">
-            <a:avLst/>
-          </a:prstGeom>
-          <a:solidFill>
-            <a:srgbClr val="FFFFFF"/>
-          </a:solidFill>
-          <a:ln w="10668">
-            <a:solidFill>
-              <a:srgbClr val="6366F1"/>
-            </a:solidFill>
-          </a:ln>
-        </p:spPr>
-        <p:style>
-          <a:lnRef idx="2">
-            <a:schemeClr val="accent1">
-              <a:shade val="15000"/>
-            </a:schemeClr>
-          </a:lnRef>
-          <a:fillRef idx="1">
-            <a:schemeClr val="accent1"/>
-          </a:fillRef>
-          <a:effectRef idx="0">
-            <a:schemeClr val="accent1"/>
-          </a:effectRef>
-          <a:fontRef idx="minor">
-            <a:schemeClr val="lt1"/>
-          </a:fontRef>
-        </p:style>
-        <p:txBody>
-          <a:bodyPr rtlCol="0" anchor="ctr"/>
-          <a:lstStyle/>
-          <a:p>
-            <a:pPr algn="ctr"/>
-            <a:endParaRPr lang="ko-KR" altLang="en-US"/>
-          </a:p>
-        </p:txBody>
-      </p:sp>
-      <p:sp>
-        <p:nvSpPr>
-          <p:cNvPr id="66" name="타원 65">
-            <a:extLst>
-              <a:ext uri="{FF2B5EF4-FFF2-40B4-BE49-F238E27FC236}">
-                <a16:creationId xmlns:a16="http://schemas.microsoft.com/office/drawing/2014/main" id="{6B1E6365-C898-7F62-19BF-43B950DC34A5}"/>
-              </a:ext>
-            </a:extLst>
-          </p:cNvPr>
-          <p:cNvSpPr/>
-          <p:nvPr/>
-        </p:nvSpPr>
-        <p:spPr>
-          <a:xfrm>
-            <a:off x="9326647" y="4762500"/>
-            <a:ext cx="137157" cy="137160"/>
-          </a:xfrm>
-          <a:prstGeom prst="ellipse">
-            <a:avLst/>
-          </a:prstGeom>
-          <a:solidFill>
-            <a:srgbClr val="6366F1"/>
-          </a:solidFill>
-          <a:ln w="9144">
-            <a:solidFill>
-              <a:srgbClr val="FFFFFF"/>
-            </a:solidFill>
-          </a:ln>
-        </p:spPr>
-        <p:style>
-          <a:lnRef idx="2">
-            <a:schemeClr val="accent1">
-              <a:shade val="15000"/>
-            </a:schemeClr>
-          </a:lnRef>
-          <a:fillRef idx="1">
-            <a:schemeClr val="accent1"/>
-          </a:fillRef>
-          <a:effectRef idx="0">
-            <a:schemeClr val="accent1"/>
-          </a:effectRef>
-          <a:fontRef idx="minor">
-            <a:schemeClr val="lt1"/>
-          </a:fontRef>
-        </p:style>
-        <p:txBody>
-          <a:bodyPr rtlCol="0" anchor="ctr"/>
-          <a:lstStyle/>
-          <a:p>
-            <a:pPr algn="ctr"/>
-            <a:endParaRPr lang="ko-KR" altLang="en-US"/>
-          </a:p>
-        </p:txBody>
-      </p:sp>
-      <p:sp>
-        <p:nvSpPr>
-          <p:cNvPr id="67" name="TextBox 66">
-            <a:extLst>
-              <a:ext uri="{FF2B5EF4-FFF2-40B4-BE49-F238E27FC236}">
-                <a16:creationId xmlns:a16="http://schemas.microsoft.com/office/drawing/2014/main" id="{9EF2B9B2-FDD0-FC7F-E6B2-3C619C83BA30}"/>
-              </a:ext>
-            </a:extLst>
-          </p:cNvPr>
-          <p:cNvSpPr txBox="1"/>
-          <p:nvPr/>
-        </p:nvSpPr>
-        <p:spPr>
-          <a:xfrm>
-            <a:off x="9326647" y="4762500"/>
-            <a:ext cx="137157" cy="369332"/>
-          </a:xfrm>
-          <a:prstGeom prst="rect">
-            <a:avLst/>
-          </a:prstGeom>
-          <a:noFill/>
-        </p:spPr>
-        <p:txBody>
-          <a:bodyPr vert="horz" wrap="square" lIns="0" tIns="0" rIns="0" bIns="0" rtlCol="0" anchor="ctr">
-            <a:noAutofit/>
-          </a:bodyPr>
-          <a:lstStyle/>
-          <a:p>
-            <a:pPr algn="ctr"/>
-            <a:r>
-              <a:rPr lang="en-US" altLang="ko-KR" sz="920" b="1">
-                <a:solidFill>
-                  <a:srgbClr val="FFFFFF"/>
-                </a:solidFill>
-                <a:latin typeface="Aptos" panose="020B0004020202020204" pitchFamily="34" charset="0"/>
-              </a:rPr>
-              <a:t>O</a:t>
-            </a:r>
-            <a:endParaRPr lang="ko-KR" altLang="en-US" sz="920" b="1">
-              <a:solidFill>
-                <a:srgbClr val="FFFFFF"/>
-              </a:solidFill>
-              <a:latin typeface="Aptos" panose="020B0004020202020204" pitchFamily="34" charset="0"/>
-            </a:endParaRPr>
-          </a:p>
-        </p:txBody>
-      </p:sp>
-      <p:sp>
-        <p:nvSpPr>
-          <p:cNvPr id="68" name="TextBox 67">
-            <a:extLst>
-              <a:ext uri="{FF2B5EF4-FFF2-40B4-BE49-F238E27FC236}">
-                <a16:creationId xmlns:a16="http://schemas.microsoft.com/office/drawing/2014/main" id="{AC5FEDBC-6223-1586-E995-B2DDB800756F}"/>
-              </a:ext>
-            </a:extLst>
-          </p:cNvPr>
-          <p:cNvSpPr txBox="1"/>
-          <p:nvPr/>
-        </p:nvSpPr>
-        <p:spPr>
-          <a:xfrm>
-            <a:off x="9540001" y="4732020"/>
-            <a:ext cx="1432524" cy="369332"/>
-          </a:xfrm>
-          <a:prstGeom prst="rect">
-            <a:avLst/>
-          </a:prstGeom>
-          <a:noFill/>
-        </p:spPr>
-        <p:txBody>
-          <a:bodyPr vert="horz" wrap="square" lIns="0" tIns="0" rIns="0" bIns="0" rtlCol="0" anchor="ctr">
-            <a:noAutofit/>
-          </a:bodyPr>
-          <a:lstStyle/>
-          <a:p>
-            <a:r>
-              <a:rPr lang="en-US" altLang="ko-KR" sz="936" b="1">
-                <a:solidFill>
-                  <a:srgbClr val="111827"/>
-                </a:solidFill>
-                <a:latin typeface="Aptos" panose="020B0004020202020204" pitchFamily="34" charset="0"/>
-              </a:rPr>
-              <a:t>Overflow QA</a:t>
-            </a:r>
-            <a:endParaRPr lang="ko-KR" altLang="en-US" sz="936" b="1">
-              <a:solidFill>
-                <a:srgbClr val="111827"/>
-              </a:solidFill>
-              <a:latin typeface="Aptos" panose="020B0004020202020204" pitchFamily="34" charset="0"/>
-            </a:endParaRPr>
-          </a:p>
-        </p:txBody>
-      </p:sp>
-      <p:sp>
-        <p:nvSpPr>
-          <p:cNvPr id="69" name="사각형: 둥근 모서리 68">
-            <a:extLst>
-              <a:ext uri="{FF2B5EF4-FFF2-40B4-BE49-F238E27FC236}">
-                <a16:creationId xmlns:a16="http://schemas.microsoft.com/office/drawing/2014/main" id="{753D7357-F7D1-166E-B32A-6E2B10B6FE6F}"/>
-              </a:ext>
-            </a:extLst>
-          </p:cNvPr>
-          <p:cNvSpPr/>
-          <p:nvPr/>
-        </p:nvSpPr>
-        <p:spPr>
-          <a:xfrm>
-            <a:off x="8991375" y="5440680"/>
-            <a:ext cx="2316422" cy="640080"/>
-          </a:xfrm>
-          <a:prstGeom prst="roundRect">
-            <a:avLst/>
-          </a:prstGeom>
-          <a:solidFill>
-            <a:srgbClr val="17213A"/>
-          </a:solidFill>
-          <a:ln w="13716">
-            <a:solidFill>
-              <a:srgbClr val="22D3EE"/>
-            </a:solidFill>
-          </a:ln>
-        </p:spPr>
-        <p:style>
-          <a:lnRef idx="2">
-            <a:schemeClr val="accent1">
-              <a:shade val="15000"/>
-            </a:schemeClr>
-          </a:lnRef>
-          <a:fillRef idx="1">
-            <a:schemeClr val="accent1"/>
-          </a:fillRef>
-          <a:effectRef idx="0">
-            <a:schemeClr val="accent1"/>
-          </a:effectRef>
-          <a:fontRef idx="minor">
-            <a:schemeClr val="lt1"/>
-          </a:fontRef>
-        </p:style>
-        <p:txBody>
-          <a:bodyPr rtlCol="0" anchor="ctr"/>
-          <a:lstStyle/>
-          <a:p>
-            <a:pPr algn="ctr"/>
-            <a:endParaRPr lang="ko-KR" altLang="en-US"/>
-          </a:p>
-        </p:txBody>
-      </p:sp>
-      <p:sp>
-        <p:nvSpPr>
-          <p:cNvPr id="70" name="TextBox 69">
-            <a:extLst>
-              <a:ext uri="{FF2B5EF4-FFF2-40B4-BE49-F238E27FC236}">
-                <a16:creationId xmlns:a16="http://schemas.microsoft.com/office/drawing/2014/main" id="{AE49F3BC-9CC7-31CD-1F14-EBD9077EFB9A}"/>
-              </a:ext>
-            </a:extLst>
-          </p:cNvPr>
-          <p:cNvSpPr txBox="1"/>
-          <p:nvPr/>
-        </p:nvSpPr>
-        <p:spPr>
-          <a:xfrm>
-            <a:off x="9219970" y="5562600"/>
-            <a:ext cx="1859234" cy="369332"/>
-          </a:xfrm>
-          <a:prstGeom prst="rect">
-            <a:avLst/>
-          </a:prstGeom>
-          <a:noFill/>
-        </p:spPr>
-        <p:txBody>
-          <a:bodyPr vert="horz" wrap="square" lIns="0" tIns="0" rIns="0" bIns="0" rtlCol="0" anchor="ctr">
-            <a:noAutofit/>
-          </a:bodyPr>
-          <a:lstStyle/>
-          <a:p>
-            <a:pPr algn="ctr"/>
-            <a:r>
-              <a:rPr lang="en-US" altLang="ko-KR" sz="1152" b="1">
-                <a:solidFill>
-                  <a:srgbClr val="FFFFFF"/>
-                </a:solidFill>
-                <a:latin typeface="Aptos" panose="020B0004020202020204" pitchFamily="34" charset="0"/>
-              </a:rPr>
-              <a:t>Built from MDPR results</a:t>
-            </a:r>
-            <a:endParaRPr lang="ko-KR" altLang="en-US" sz="1152" b="1">
-              <a:solidFill>
-                <a:srgbClr val="FFFFFF"/>
-              </a:solidFill>
-              <a:latin typeface="Aptos" panose="020B0004020202020204" pitchFamily="34" charset="0"/>
-            </a:endParaRPr>
-          </a:p>
-        </p:txBody>
-      </p:sp>
-      <p:sp>
-        <p:nvSpPr>
-          <p:cNvPr id="71" name="TextBox 70">
-            <a:extLst>
-              <a:ext uri="{FF2B5EF4-FFF2-40B4-BE49-F238E27FC236}">
-                <a16:creationId xmlns:a16="http://schemas.microsoft.com/office/drawing/2014/main" id="{05F922CE-351F-0D0B-D9CA-D64B3365140B}"/>
-              </a:ext>
-            </a:extLst>
-          </p:cNvPr>
-          <p:cNvSpPr txBox="1"/>
-          <p:nvPr/>
-        </p:nvSpPr>
-        <p:spPr>
-          <a:xfrm>
-            <a:off x="9219970" y="5806440"/>
-            <a:ext cx="1859234" cy="369332"/>
-          </a:xfrm>
-          <a:prstGeom prst="rect">
-            <a:avLst/>
-          </a:prstGeom>
-          <a:noFill/>
-        </p:spPr>
-        <p:txBody>
-          <a:bodyPr vert="horz" wrap="square" lIns="0" tIns="0" rIns="0" bIns="0" rtlCol="0" anchor="ctr">
-            <a:noAutofit/>
-          </a:bodyPr>
-          <a:lstStyle/>
-          <a:p>
-            <a:pPr algn="ctr"/>
-            <a:r>
-              <a:rPr lang="en-US" altLang="ko-KR" sz="920">
+              <a:rPr lang="en-US" altLang="ko-KR" sz="1008">
                 <a:solidFill>
                   <a:srgbClr val="CBD5E1"/>
                 </a:solidFill>
                 <a:latin typeface="Aptos" panose="020B0004020202020204" pitchFamily="34" charset="0"/>
               </a:rPr>
-              <a:t>theme-preview PPTX -&gt; PNG</a:t>
-            </a:r>
-            <a:endParaRPr lang="ko-KR" altLang="en-US" sz="920">
+              <a:t>theme-preview PPTX -&gt; PowerPoint PNG -&gt; README teaser</a:t>
+            </a:r>
+            <a:endParaRPr lang="ko-KR" altLang="en-US" sz="1008">
               <a:solidFill>
                 <a:srgbClr val="CBD5E1"/>
               </a:solidFill>
@@ -6639,7 +5854,7 @@
     </p:spTree>
     <p:extLst>
       <p:ext uri="{BB962C8B-B14F-4D97-AF65-F5344CB8AC3E}">
-        <p14:creationId xmlns:p14="http://schemas.microsoft.com/office/powerpoint/2010/main" val="1180482900"/>
+        <p14:creationId xmlns:p14="http://schemas.microsoft.com/office/powerpoint/2010/main" val="3310484015"/>
       </p:ext>
     </p:extLst>
   </p:cSld>

</xml_diff>